<commit_message>
Update current PowerPoint and remove old one
</commit_message>
<xml_diff>
--- a/docs/onboarding/ai-orchestration.pptx
+++ b/docs/onboarding/ai-orchestration.pptx
@@ -10,6 +10,14 @@
     <p:sldId id="258" r:id="rId4"/>
     <p:sldId id="259" r:id="rId5"/>
     <p:sldId id="260" r:id="rId6"/>
+    <p:sldId id="261" r:id="rId7"/>
+    <p:sldId id="263" r:id="rId8"/>
+    <p:sldId id="262" r:id="rId9"/>
+    <p:sldId id="264" r:id="rId10"/>
+    <p:sldId id="265" r:id="rId11"/>
+    <p:sldId id="266" r:id="rId12"/>
+    <p:sldId id="267" r:id="rId13"/>
+    <p:sldId id="268" r:id="rId14"/>
   </p:sldIdLst>
   <p:sldSz cx="12192000" cy="6858000"/>
   <p:notesSz cx="6858000" cy="9144000"/>
@@ -3410,6 +3418,553 @@
 </p:sld>
 </file>
 
+<file path=ppt/slides/slide10.xml><?xml version="1.0" encoding="utf-8"?>
+<p:sld xmlns:a="http://schemas.openxmlformats.org/drawingml/2006/main" xmlns:r="http://schemas.openxmlformats.org/officeDocument/2006/relationships" xmlns:p="http://schemas.openxmlformats.org/presentationml/2006/main">
+  <p:cSld>
+    <p:spTree>
+      <p:nvGrpSpPr>
+        <p:cNvPr id="1" name=""/>
+        <p:cNvGrpSpPr/>
+        <p:nvPr/>
+      </p:nvGrpSpPr>
+      <p:grpSpPr>
+        <a:xfrm>
+          <a:off x="0" y="0"/>
+          <a:ext cx="0" cy="0"/>
+          <a:chOff x="0" y="0"/>
+          <a:chExt cx="0" cy="0"/>
+        </a:xfrm>
+      </p:grpSpPr>
+      <p:sp>
+        <p:nvSpPr>
+          <p:cNvPr id="2" name="Title 1">
+            <a:extLst>
+              <a:ext uri="{FF2B5EF4-FFF2-40B4-BE49-F238E27FC236}">
+                <a16:creationId xmlns:a16="http://schemas.microsoft.com/office/drawing/2014/main" id="{010905FE-C604-2F18-A693-B41F8D012592}"/>
+              </a:ext>
+            </a:extLst>
+          </p:cNvPr>
+          <p:cNvSpPr>
+            <a:spLocks noGrp="1"/>
+          </p:cNvSpPr>
+          <p:nvPr>
+            <p:ph type="title"/>
+          </p:nvPr>
+        </p:nvSpPr>
+        <p:spPr>
+          <a:xfrm>
+            <a:off x="838200" y="365125"/>
+            <a:ext cx="10515600" cy="1082675"/>
+          </a:xfrm>
+        </p:spPr>
+        <p:txBody>
+          <a:bodyPr/>
+          <a:lstStyle/>
+          <a:p>
+            <a:r>
+              <a:rPr lang="en-US" i="1" dirty="0"/>
+              <a:t>System Files</a:t>
+            </a:r>
+          </a:p>
+        </p:txBody>
+      </p:sp>
+      <p:sp>
+        <p:nvSpPr>
+          <p:cNvPr id="3" name="Content Placeholder 2">
+            <a:extLst>
+              <a:ext uri="{FF2B5EF4-FFF2-40B4-BE49-F238E27FC236}">
+                <a16:creationId xmlns:a16="http://schemas.microsoft.com/office/drawing/2014/main" id="{A0625F5A-0612-85A4-A86A-3A806DC4216E}"/>
+              </a:ext>
+            </a:extLst>
+          </p:cNvPr>
+          <p:cNvSpPr>
+            <a:spLocks noGrp="1"/>
+          </p:cNvSpPr>
+          <p:nvPr>
+            <p:ph idx="1"/>
+          </p:nvPr>
+        </p:nvSpPr>
+        <p:spPr>
+          <a:xfrm>
+            <a:off x="838200" y="1690688"/>
+            <a:ext cx="10515600" cy="4486275"/>
+          </a:xfrm>
+        </p:spPr>
+        <p:txBody>
+          <a:bodyPr>
+            <a:normAutofit fontScale="92500" lnSpcReduction="10000"/>
+          </a:bodyPr>
+          <a:lstStyle/>
+          <a:p>
+            <a:r>
+              <a:rPr lang="en-US" dirty="0"/>
+              <a:t>The extension (sometimes called "framework") uses files to govern its work.  </a:t>
+            </a:r>
+          </a:p>
+          <a:p>
+            <a:r>
+              <a:rPr lang="en-US" dirty="0"/>
+              <a:t>Do not directly edit anything in the .dabbler directory, nor the session-plan.md file, as these have special formats.</a:t>
+            </a:r>
+          </a:p>
+          <a:p>
+            <a:r>
+              <a:rPr lang="en-US" dirty="0"/>
+              <a:t>Here are some of the important system files:</a:t>
+            </a:r>
+          </a:p>
+          <a:p>
+            <a:pPr lvl="1"/>
+            <a:r>
+              <a:rPr lang="en-US" b="1" u="sng" dirty="0">
+                <a:solidFill>
+                  <a:srgbClr val="0070C0"/>
+                </a:solidFill>
+              </a:rPr>
+              <a:t>docs\planning\solution-plan.md</a:t>
+            </a:r>
+            <a:r>
+              <a:rPr lang="en-US" dirty="0"/>
+              <a:t> – the overall solution plan</a:t>
+            </a:r>
+            <a:endParaRPr lang="en-US" b="1" u="sng" dirty="0">
+              <a:solidFill>
+                <a:srgbClr val="0070C0"/>
+              </a:solidFill>
+            </a:endParaRPr>
+          </a:p>
+          <a:p>
+            <a:pPr lvl="1"/>
+            <a:r>
+              <a:rPr lang="en-US" b="1" u="sng" dirty="0">
+                <a:solidFill>
+                  <a:srgbClr val="0070C0"/>
+                </a:solidFill>
+              </a:rPr>
+              <a:t>docs\sessions\session-plan.md</a:t>
+            </a:r>
+            <a:r>
+              <a:rPr lang="en-US" dirty="0"/>
+              <a:t> – the session-specific plan</a:t>
+            </a:r>
+          </a:p>
+          <a:p>
+            <a:pPr lvl="1"/>
+            <a:r>
+              <a:rPr lang="en-US" b="1" u="sng" dirty="0">
+                <a:solidFill>
+                  <a:srgbClr val="0070C0"/>
+                </a:solidFill>
+              </a:rPr>
+              <a:t>.dabbler\solution\</a:t>
+            </a:r>
+            <a:r>
+              <a:rPr lang="en-US" b="1" u="sng" dirty="0" err="1">
+                <a:solidFill>
+                  <a:srgbClr val="0070C0"/>
+                </a:solidFill>
+              </a:rPr>
+              <a:t>solution.json</a:t>
+            </a:r>
+            <a:r>
+              <a:rPr lang="en-US" dirty="0"/>
+              <a:t> – the organization of the solution into projects or modules (if any)</a:t>
+            </a:r>
+          </a:p>
+          <a:p>
+            <a:pPr lvl="1"/>
+            <a:r>
+              <a:rPr lang="en-US" b="1" u="sng" dirty="0">
+                <a:solidFill>
+                  <a:srgbClr val="0070C0"/>
+                </a:solidFill>
+              </a:rPr>
+              <a:t>.dabbler\...\</a:t>
+            </a:r>
+            <a:r>
+              <a:rPr lang="en-US" b="1" u="sng" dirty="0" err="1">
+                <a:solidFill>
+                  <a:srgbClr val="0070C0"/>
+                </a:solidFill>
+              </a:rPr>
+              <a:t>instruction.json</a:t>
+            </a:r>
+            <a:r>
+              <a:rPr lang="en-US" u="sng" dirty="0"/>
+              <a:t> </a:t>
+            </a:r>
+            <a:r>
+              <a:rPr lang="en-US" dirty="0"/>
+              <a:t>– a shared file between the extension and AI that allows coordination of work</a:t>
+            </a:r>
+          </a:p>
+          <a:p>
+            <a:pPr lvl="1"/>
+            <a:r>
+              <a:rPr lang="en-US" b="1" dirty="0" err="1">
+                <a:solidFill>
+                  <a:srgbClr val="0070C0"/>
+                </a:solidFill>
+              </a:rPr>
+              <a:t>dabbler.yaml</a:t>
+            </a:r>
+            <a:r>
+              <a:rPr lang="en-US" dirty="0"/>
+              <a:t> – defines testing and solution packaging</a:t>
+            </a:r>
+          </a:p>
+          <a:p>
+            <a:pPr lvl="1"/>
+            <a:r>
+              <a:rPr lang="en-US" b="1" u="sng" dirty="0">
+                <a:solidFill>
+                  <a:srgbClr val="0070C0"/>
+                </a:solidFill>
+              </a:rPr>
+              <a:t>AGENTS.md, CLAUDE.me</a:t>
+            </a:r>
+            <a:r>
+              <a:rPr lang="en-US" dirty="0"/>
+              <a:t> – initial instruction files for AI models.</a:t>
+            </a:r>
+          </a:p>
+        </p:txBody>
+      </p:sp>
+    </p:spTree>
+    <p:extLst>
+      <p:ext uri="{BB962C8B-B14F-4D97-AF65-F5344CB8AC3E}">
+        <p14:creationId xmlns:p14="http://schemas.microsoft.com/office/powerpoint/2010/main" val="229979975"/>
+      </p:ext>
+    </p:extLst>
+  </p:cSld>
+  <p:clrMapOvr>
+    <a:masterClrMapping/>
+  </p:clrMapOvr>
+</p:sld>
+</file>
+
+<file path=ppt/slides/slide11.xml><?xml version="1.0" encoding="utf-8"?>
+<p:sld xmlns:a="http://schemas.openxmlformats.org/drawingml/2006/main" xmlns:r="http://schemas.openxmlformats.org/officeDocument/2006/relationships" xmlns:p="http://schemas.openxmlformats.org/presentationml/2006/main">
+  <p:cSld>
+    <p:spTree>
+      <p:nvGrpSpPr>
+        <p:cNvPr id="1" name=""/>
+        <p:cNvGrpSpPr/>
+        <p:nvPr/>
+      </p:nvGrpSpPr>
+      <p:grpSpPr>
+        <a:xfrm>
+          <a:off x="0" y="0"/>
+          <a:ext cx="0" cy="0"/>
+          <a:chOff x="0" y="0"/>
+          <a:chExt cx="0" cy="0"/>
+        </a:xfrm>
+      </p:grpSpPr>
+      <p:sp>
+        <p:nvSpPr>
+          <p:cNvPr id="2" name="Title 1">
+            <a:extLst>
+              <a:ext uri="{FF2B5EF4-FFF2-40B4-BE49-F238E27FC236}">
+                <a16:creationId xmlns:a16="http://schemas.microsoft.com/office/drawing/2014/main" id="{5BD1EF6E-CEFB-2608-C538-1FE9724AD32C}"/>
+              </a:ext>
+            </a:extLst>
+          </p:cNvPr>
+          <p:cNvSpPr>
+            <a:spLocks noGrp="1"/>
+          </p:cNvSpPr>
+          <p:nvPr>
+            <p:ph type="title"/>
+          </p:nvPr>
+        </p:nvSpPr>
+        <p:spPr/>
+        <p:txBody>
+          <a:bodyPr/>
+          <a:lstStyle/>
+          <a:p>
+            <a:r>
+              <a:rPr lang="en-US" i="1" dirty="0"/>
+              <a:t>Additional Q&amp;A</a:t>
+            </a:r>
+          </a:p>
+        </p:txBody>
+      </p:sp>
+      <p:sp>
+        <p:nvSpPr>
+          <p:cNvPr id="3" name="Content Placeholder 2">
+            <a:extLst>
+              <a:ext uri="{FF2B5EF4-FFF2-40B4-BE49-F238E27FC236}">
+                <a16:creationId xmlns:a16="http://schemas.microsoft.com/office/drawing/2014/main" id="{B3AC8D0A-1B14-C3C2-79B3-89E560244202}"/>
+              </a:ext>
+            </a:extLst>
+          </p:cNvPr>
+          <p:cNvSpPr>
+            <a:spLocks noGrp="1"/>
+          </p:cNvSpPr>
+          <p:nvPr>
+            <p:ph idx="1"/>
+          </p:nvPr>
+        </p:nvSpPr>
+        <p:spPr/>
+        <p:txBody>
+          <a:bodyPr>
+            <a:normAutofit/>
+          </a:bodyPr>
+          <a:lstStyle/>
+          <a:p>
+            <a:r>
+              <a:rPr lang="en-US" dirty="0"/>
+              <a:t>Question: </a:t>
+            </a:r>
+            <a:r>
+              <a:rPr lang="en-US" i="1" dirty="0"/>
+              <a:t>This is an open-source extension developed by one person.  Isn't that risky?</a:t>
+            </a:r>
+            <a:br>
+              <a:rPr lang="en-US" dirty="0"/>
+            </a:br>
+            <a:endParaRPr lang="en-US" dirty="0"/>
+          </a:p>
+          <a:p>
+            <a:r>
+              <a:rPr lang="en-US" dirty="0"/>
+              <a:t>Answer: </a:t>
+            </a:r>
+            <a:r>
+              <a:rPr lang="en-US" i="1" dirty="0"/>
+              <a:t>It is less risky than many open-source extensions because, in reality, it is written by AI and maintained by AI.  Anyone with access to AI can fix or enhance the solution.  Being a developer helps, but you don't have to know anything about AI or TypeScript or Visual Studio Code Extension programming. </a:t>
+            </a:r>
+          </a:p>
+        </p:txBody>
+      </p:sp>
+    </p:spTree>
+    <p:extLst>
+      <p:ext uri="{BB962C8B-B14F-4D97-AF65-F5344CB8AC3E}">
+        <p14:creationId xmlns:p14="http://schemas.microsoft.com/office/powerpoint/2010/main" val="3540892354"/>
+      </p:ext>
+    </p:extLst>
+  </p:cSld>
+  <p:clrMapOvr>
+    <a:masterClrMapping/>
+  </p:clrMapOvr>
+</p:sld>
+</file>
+
+<file path=ppt/slides/slide12.xml><?xml version="1.0" encoding="utf-8"?>
+<p:sld xmlns:a="http://schemas.openxmlformats.org/drawingml/2006/main" xmlns:r="http://schemas.openxmlformats.org/officeDocument/2006/relationships" xmlns:p="http://schemas.openxmlformats.org/presentationml/2006/main">
+  <p:cSld>
+    <p:spTree>
+      <p:nvGrpSpPr>
+        <p:cNvPr id="1" name=""/>
+        <p:cNvGrpSpPr/>
+        <p:nvPr/>
+      </p:nvGrpSpPr>
+      <p:grpSpPr>
+        <a:xfrm>
+          <a:off x="0" y="0"/>
+          <a:ext cx="0" cy="0"/>
+          <a:chOff x="0" y="0"/>
+          <a:chExt cx="0" cy="0"/>
+        </a:xfrm>
+      </p:grpSpPr>
+      <p:sp>
+        <p:nvSpPr>
+          <p:cNvPr id="2" name="Title 1">
+            <a:extLst>
+              <a:ext uri="{FF2B5EF4-FFF2-40B4-BE49-F238E27FC236}">
+                <a16:creationId xmlns:a16="http://schemas.microsoft.com/office/drawing/2014/main" id="{B5AC1AB3-0EAE-BCD9-7654-8CC37159596D}"/>
+              </a:ext>
+            </a:extLst>
+          </p:cNvPr>
+          <p:cNvSpPr>
+            <a:spLocks noGrp="1"/>
+          </p:cNvSpPr>
+          <p:nvPr>
+            <p:ph type="title"/>
+          </p:nvPr>
+        </p:nvSpPr>
+        <p:spPr/>
+        <p:txBody>
+          <a:bodyPr/>
+          <a:lstStyle/>
+          <a:p>
+            <a:r>
+              <a:rPr lang="en-US" i="1" dirty="0"/>
+              <a:t>Additional Q&amp;A</a:t>
+            </a:r>
+            <a:endParaRPr lang="en-US" dirty="0"/>
+          </a:p>
+        </p:txBody>
+      </p:sp>
+      <p:sp>
+        <p:nvSpPr>
+          <p:cNvPr id="3" name="Content Placeholder 2">
+            <a:extLst>
+              <a:ext uri="{FF2B5EF4-FFF2-40B4-BE49-F238E27FC236}">
+                <a16:creationId xmlns:a16="http://schemas.microsoft.com/office/drawing/2014/main" id="{BFEEA118-E19E-86E7-A8A1-9BBE8A61DD4B}"/>
+              </a:ext>
+            </a:extLst>
+          </p:cNvPr>
+          <p:cNvSpPr>
+            <a:spLocks noGrp="1"/>
+          </p:cNvSpPr>
+          <p:nvPr>
+            <p:ph idx="1"/>
+          </p:nvPr>
+        </p:nvSpPr>
+        <p:spPr/>
+        <p:txBody>
+          <a:bodyPr/>
+          <a:lstStyle/>
+          <a:p>
+            <a:r>
+              <a:rPr lang="en-US" dirty="0"/>
+              <a:t>Question: </a:t>
+            </a:r>
+            <a:r>
+              <a:rPr lang="en-US" i="1" dirty="0"/>
+              <a:t>What if something better comes along?  Will I have trouble transitioning?</a:t>
+            </a:r>
+            <a:br>
+              <a:rPr lang="en-US" dirty="0"/>
+            </a:br>
+            <a:endParaRPr lang="en-US" dirty="0"/>
+          </a:p>
+          <a:p>
+            <a:r>
+              <a:rPr lang="en-US" dirty="0"/>
+              <a:t>Answer: </a:t>
+            </a:r>
+            <a:r>
+              <a:rPr lang="en-US" i="1" dirty="0"/>
+              <a:t>If that "something better" includes an AI assistant, have that AI assistant look at your current solution and help you with the transition.  If it doesn't, just fire up an instance of your favorite agentic AI (probably a CLI or an IDE extension) and ask it for help. Again, the AI Orchestration extension uses some special system files that can be ignored or deleted during a transition.</a:t>
+            </a:r>
+          </a:p>
+        </p:txBody>
+      </p:sp>
+    </p:spTree>
+    <p:extLst>
+      <p:ext uri="{BB962C8B-B14F-4D97-AF65-F5344CB8AC3E}">
+        <p14:creationId xmlns:p14="http://schemas.microsoft.com/office/powerpoint/2010/main" val="3271425303"/>
+      </p:ext>
+    </p:extLst>
+  </p:cSld>
+  <p:clrMapOvr>
+    <a:masterClrMapping/>
+  </p:clrMapOvr>
+</p:sld>
+</file>
+
+<file path=ppt/slides/slide13.xml><?xml version="1.0" encoding="utf-8"?>
+<p:sld xmlns:a="http://schemas.openxmlformats.org/drawingml/2006/main" xmlns:r="http://schemas.openxmlformats.org/officeDocument/2006/relationships" xmlns:p="http://schemas.openxmlformats.org/presentationml/2006/main">
+  <p:cSld>
+    <p:spTree>
+      <p:nvGrpSpPr>
+        <p:cNvPr id="1" name="">
+          <a:extLst>
+            <a:ext uri="{FF2B5EF4-FFF2-40B4-BE49-F238E27FC236}">
+              <a16:creationId xmlns:a16="http://schemas.microsoft.com/office/drawing/2014/main" id="{9F414F7E-05FB-7173-096B-35DDA6EF93D4}"/>
+            </a:ext>
+          </a:extLst>
+        </p:cNvPr>
+        <p:cNvGrpSpPr/>
+        <p:nvPr/>
+      </p:nvGrpSpPr>
+      <p:grpSpPr>
+        <a:xfrm>
+          <a:off x="0" y="0"/>
+          <a:ext cx="0" cy="0"/>
+          <a:chOff x="0" y="0"/>
+          <a:chExt cx="0" cy="0"/>
+        </a:xfrm>
+      </p:grpSpPr>
+      <p:sp>
+        <p:nvSpPr>
+          <p:cNvPr id="2" name="Title 1">
+            <a:extLst>
+              <a:ext uri="{FF2B5EF4-FFF2-40B4-BE49-F238E27FC236}">
+                <a16:creationId xmlns:a16="http://schemas.microsoft.com/office/drawing/2014/main" id="{D4095504-EB60-8306-A905-5000C347BBF6}"/>
+              </a:ext>
+            </a:extLst>
+          </p:cNvPr>
+          <p:cNvSpPr>
+            <a:spLocks noGrp="1"/>
+          </p:cNvSpPr>
+          <p:nvPr>
+            <p:ph type="title"/>
+          </p:nvPr>
+        </p:nvSpPr>
+        <p:spPr/>
+        <p:txBody>
+          <a:bodyPr/>
+          <a:lstStyle/>
+          <a:p>
+            <a:r>
+              <a:rPr lang="en-US" i="1" dirty="0"/>
+              <a:t>Additional Q&amp;A</a:t>
+            </a:r>
+            <a:endParaRPr lang="en-US" dirty="0"/>
+          </a:p>
+        </p:txBody>
+      </p:sp>
+      <p:sp>
+        <p:nvSpPr>
+          <p:cNvPr id="3" name="Content Placeholder 2">
+            <a:extLst>
+              <a:ext uri="{FF2B5EF4-FFF2-40B4-BE49-F238E27FC236}">
+                <a16:creationId xmlns:a16="http://schemas.microsoft.com/office/drawing/2014/main" id="{03F7AE78-1854-57D2-E473-83B338A906C8}"/>
+              </a:ext>
+            </a:extLst>
+          </p:cNvPr>
+          <p:cNvSpPr>
+            <a:spLocks noGrp="1"/>
+          </p:cNvSpPr>
+          <p:nvPr>
+            <p:ph idx="1"/>
+          </p:nvPr>
+        </p:nvSpPr>
+        <p:spPr/>
+        <p:txBody>
+          <a:bodyPr/>
+          <a:lstStyle/>
+          <a:p>
+            <a:r>
+              <a:rPr lang="en-US" dirty="0"/>
+              <a:t>Question: </a:t>
+            </a:r>
+            <a:r>
+              <a:rPr lang="en-US" i="1" dirty="0"/>
+              <a:t>What if AI takes over the world?  Should I stop using the AI Orchestration extension?</a:t>
+            </a:r>
+            <a:br>
+              <a:rPr lang="en-US" dirty="0"/>
+            </a:br>
+            <a:endParaRPr lang="en-US" dirty="0"/>
+          </a:p>
+          <a:p>
+            <a:r>
+              <a:rPr lang="en-US" dirty="0"/>
+              <a:t>Answer: </a:t>
+            </a:r>
+            <a:r>
+              <a:rPr lang="en-US" i="1" dirty="0"/>
+              <a:t>If that happens, you will have more important things to worry about than the extension. </a:t>
+            </a:r>
+          </a:p>
+        </p:txBody>
+      </p:sp>
+    </p:spTree>
+    <p:extLst>
+      <p:ext uri="{BB962C8B-B14F-4D97-AF65-F5344CB8AC3E}">
+        <p14:creationId xmlns:p14="http://schemas.microsoft.com/office/powerpoint/2010/main" val="2159532116"/>
+      </p:ext>
+    </p:extLst>
+  </p:cSld>
+  <p:clrMapOvr>
+    <a:masterClrMapping/>
+  </p:clrMapOvr>
+</p:sld>
+</file>
+
 <file path=ppt/slides/slide2.xml><?xml version="1.0" encoding="utf-8"?>
 <p:sld xmlns:a="http://schemas.openxmlformats.org/drawingml/2006/main" xmlns:r="http://schemas.openxmlformats.org/officeDocument/2006/relationships" xmlns:p="http://schemas.openxmlformats.org/presentationml/2006/main">
   <p:cSld>
@@ -4238,6 +4793,1641 @@
     <p:extLst>
       <p:ext uri="{BB962C8B-B14F-4D97-AF65-F5344CB8AC3E}">
         <p14:creationId xmlns:p14="http://schemas.microsoft.com/office/powerpoint/2010/main" val="4059617302"/>
+      </p:ext>
+    </p:extLst>
+  </p:cSld>
+  <p:clrMapOvr>
+    <a:masterClrMapping/>
+  </p:clrMapOvr>
+</p:sld>
+</file>
+
+<file path=ppt/slides/slide6.xml><?xml version="1.0" encoding="utf-8"?>
+<p:sld xmlns:a="http://schemas.openxmlformats.org/drawingml/2006/main" xmlns:r="http://schemas.openxmlformats.org/officeDocument/2006/relationships" xmlns:p="http://schemas.openxmlformats.org/presentationml/2006/main">
+  <p:cSld>
+    <p:spTree>
+      <p:nvGrpSpPr>
+        <p:cNvPr id="1" name=""/>
+        <p:cNvGrpSpPr/>
+        <p:nvPr/>
+      </p:nvGrpSpPr>
+      <p:grpSpPr>
+        <a:xfrm>
+          <a:off x="0" y="0"/>
+          <a:ext cx="0" cy="0"/>
+          <a:chOff x="0" y="0"/>
+          <a:chExt cx="0" cy="0"/>
+        </a:xfrm>
+      </p:grpSpPr>
+      <p:sp>
+        <p:nvSpPr>
+          <p:cNvPr id="20" name="Rectangle 19">
+            <a:extLst>
+              <a:ext uri="{FF2B5EF4-FFF2-40B4-BE49-F238E27FC236}">
+                <a16:creationId xmlns:a16="http://schemas.microsoft.com/office/drawing/2014/main" id="{2F710F11-C596-C8AB-4B23-613793FCA453}"/>
+              </a:ext>
+            </a:extLst>
+          </p:cNvPr>
+          <p:cNvSpPr/>
+          <p:nvPr/>
+        </p:nvSpPr>
+        <p:spPr>
+          <a:xfrm>
+            <a:off x="0" y="0"/>
+            <a:ext cx="12382500" cy="6858000"/>
+          </a:xfrm>
+          <a:prstGeom prst="rect">
+            <a:avLst/>
+          </a:prstGeom>
+        </p:spPr>
+        <p:style>
+          <a:lnRef idx="2">
+            <a:schemeClr val="dk1">
+              <a:shade val="15000"/>
+            </a:schemeClr>
+          </a:lnRef>
+          <a:fillRef idx="1">
+            <a:schemeClr val="dk1"/>
+          </a:fillRef>
+          <a:effectRef idx="0">
+            <a:schemeClr val="dk1"/>
+          </a:effectRef>
+          <a:fontRef idx="minor">
+            <a:schemeClr val="lt1"/>
+          </a:fontRef>
+        </p:style>
+        <p:txBody>
+          <a:bodyPr rtlCol="0" anchor="ctr"/>
+          <a:lstStyle/>
+          <a:p>
+            <a:pPr algn="ctr"/>
+            <a:endParaRPr lang="en-US"/>
+          </a:p>
+        </p:txBody>
+      </p:sp>
+      <p:pic>
+        <p:nvPicPr>
+          <p:cNvPr id="19" name="Picture 18">
+            <a:extLst>
+              <a:ext uri="{FF2B5EF4-FFF2-40B4-BE49-F238E27FC236}">
+                <a16:creationId xmlns:a16="http://schemas.microsoft.com/office/drawing/2014/main" id="{3EE190EF-B16B-B2F3-7F4A-69111F25D62B}"/>
+              </a:ext>
+            </a:extLst>
+          </p:cNvPr>
+          <p:cNvPicPr>
+            <a:picLocks noChangeAspect="1"/>
+          </p:cNvPicPr>
+          <p:nvPr/>
+        </p:nvPicPr>
+        <p:blipFill>
+          <a:blip r:embed="rId2"/>
+          <a:stretch>
+            <a:fillRect/>
+          </a:stretch>
+        </p:blipFill>
+        <p:spPr>
+          <a:xfrm>
+            <a:off x="139700" y="207654"/>
+            <a:ext cx="11912600" cy="6442691"/>
+          </a:xfrm>
+          <a:prstGeom prst="rect">
+            <a:avLst/>
+          </a:prstGeom>
+        </p:spPr>
+      </p:pic>
+      <p:sp>
+        <p:nvSpPr>
+          <p:cNvPr id="2" name="Title 1">
+            <a:extLst>
+              <a:ext uri="{FF2B5EF4-FFF2-40B4-BE49-F238E27FC236}">
+                <a16:creationId xmlns:a16="http://schemas.microsoft.com/office/drawing/2014/main" id="{0C340B89-B409-D58A-9CCC-D6211F4297FA}"/>
+              </a:ext>
+            </a:extLst>
+          </p:cNvPr>
+          <p:cNvSpPr>
+            <a:spLocks noGrp="1"/>
+          </p:cNvSpPr>
+          <p:nvPr>
+            <p:ph type="title"/>
+          </p:nvPr>
+        </p:nvSpPr>
+        <p:spPr>
+          <a:xfrm>
+            <a:off x="983307" y="-28493"/>
+            <a:ext cx="10515600" cy="662462"/>
+          </a:xfrm>
+        </p:spPr>
+        <p:txBody>
+          <a:bodyPr>
+            <a:normAutofit/>
+          </a:bodyPr>
+          <a:lstStyle/>
+          <a:p>
+            <a:pPr algn="ctr"/>
+            <a:r>
+              <a:rPr lang="en-US" sz="3200" i="1" dirty="0">
+                <a:solidFill>
+                  <a:srgbClr val="FFFF00"/>
+                </a:solidFill>
+              </a:rPr>
+              <a:t>Getting Started – Orchestration Layout</a:t>
+            </a:r>
+          </a:p>
+        </p:txBody>
+      </p:sp>
+      <p:sp>
+        <p:nvSpPr>
+          <p:cNvPr id="13" name="Rectangle 12">
+            <a:extLst>
+              <a:ext uri="{FF2B5EF4-FFF2-40B4-BE49-F238E27FC236}">
+                <a16:creationId xmlns:a16="http://schemas.microsoft.com/office/drawing/2014/main" id="{3A629B32-F1EF-605E-BC00-83AA563A9B1A}"/>
+              </a:ext>
+            </a:extLst>
+          </p:cNvPr>
+          <p:cNvSpPr/>
+          <p:nvPr/>
+        </p:nvSpPr>
+        <p:spPr>
+          <a:xfrm>
+            <a:off x="636275" y="3707024"/>
+            <a:ext cx="2964669" cy="2943321"/>
+          </a:xfrm>
+          <a:prstGeom prst="rect">
+            <a:avLst/>
+          </a:prstGeom>
+          <a:noFill/>
+          <a:ln w="38100">
+            <a:solidFill>
+              <a:srgbClr val="FFFF00"/>
+            </a:solidFill>
+          </a:ln>
+        </p:spPr>
+        <p:style>
+          <a:lnRef idx="2">
+            <a:schemeClr val="accent1">
+              <a:shade val="15000"/>
+            </a:schemeClr>
+          </a:lnRef>
+          <a:fillRef idx="1">
+            <a:schemeClr val="accent1"/>
+          </a:fillRef>
+          <a:effectRef idx="0">
+            <a:schemeClr val="accent1"/>
+          </a:effectRef>
+          <a:fontRef idx="minor">
+            <a:schemeClr val="lt1"/>
+          </a:fontRef>
+        </p:style>
+        <p:txBody>
+          <a:bodyPr rtlCol="0" anchor="ctr"/>
+          <a:lstStyle/>
+          <a:p>
+            <a:pPr algn="ctr"/>
+            <a:endParaRPr lang="en-US"/>
+          </a:p>
+        </p:txBody>
+      </p:sp>
+      <p:sp>
+        <p:nvSpPr>
+          <p:cNvPr id="14" name="Rectangle 13">
+            <a:extLst>
+              <a:ext uri="{FF2B5EF4-FFF2-40B4-BE49-F238E27FC236}">
+                <a16:creationId xmlns:a16="http://schemas.microsoft.com/office/drawing/2014/main" id="{237227E5-FC5C-288A-BA82-47719ABDADD3}"/>
+              </a:ext>
+            </a:extLst>
+          </p:cNvPr>
+          <p:cNvSpPr/>
+          <p:nvPr/>
+        </p:nvSpPr>
+        <p:spPr>
+          <a:xfrm>
+            <a:off x="636276" y="841622"/>
+            <a:ext cx="2964668" cy="2752477"/>
+          </a:xfrm>
+          <a:prstGeom prst="rect">
+            <a:avLst/>
+          </a:prstGeom>
+          <a:noFill/>
+          <a:ln w="38100">
+            <a:solidFill>
+              <a:srgbClr val="FFFF00"/>
+            </a:solidFill>
+          </a:ln>
+        </p:spPr>
+        <p:style>
+          <a:lnRef idx="2">
+            <a:schemeClr val="accent1">
+              <a:shade val="15000"/>
+            </a:schemeClr>
+          </a:lnRef>
+          <a:fillRef idx="1">
+            <a:schemeClr val="accent1"/>
+          </a:fillRef>
+          <a:effectRef idx="0">
+            <a:schemeClr val="accent1"/>
+          </a:effectRef>
+          <a:fontRef idx="minor">
+            <a:schemeClr val="lt1"/>
+          </a:fontRef>
+        </p:style>
+        <p:txBody>
+          <a:bodyPr rtlCol="0" anchor="ctr"/>
+          <a:lstStyle/>
+          <a:p>
+            <a:pPr algn="ctr"/>
+            <a:endParaRPr lang="en-US"/>
+          </a:p>
+        </p:txBody>
+      </p:sp>
+      <p:sp>
+        <p:nvSpPr>
+          <p:cNvPr id="21" name="Rectangle 20">
+            <a:extLst>
+              <a:ext uri="{FF2B5EF4-FFF2-40B4-BE49-F238E27FC236}">
+                <a16:creationId xmlns:a16="http://schemas.microsoft.com/office/drawing/2014/main" id="{981D2EC4-3B7F-8AF3-7362-F591C732F1B8}"/>
+              </a:ext>
+            </a:extLst>
+          </p:cNvPr>
+          <p:cNvSpPr/>
+          <p:nvPr/>
+        </p:nvSpPr>
+        <p:spPr>
+          <a:xfrm>
+            <a:off x="3740643" y="530467"/>
+            <a:ext cx="3926709" cy="6148371"/>
+          </a:xfrm>
+          <a:prstGeom prst="rect">
+            <a:avLst/>
+          </a:prstGeom>
+          <a:noFill/>
+          <a:ln w="38100">
+            <a:solidFill>
+              <a:srgbClr val="FFFF00"/>
+            </a:solidFill>
+          </a:ln>
+        </p:spPr>
+        <p:style>
+          <a:lnRef idx="2">
+            <a:schemeClr val="accent1">
+              <a:shade val="15000"/>
+            </a:schemeClr>
+          </a:lnRef>
+          <a:fillRef idx="1">
+            <a:schemeClr val="accent1"/>
+          </a:fillRef>
+          <a:effectRef idx="0">
+            <a:schemeClr val="accent1"/>
+          </a:effectRef>
+          <a:fontRef idx="minor">
+            <a:schemeClr val="lt1"/>
+          </a:fontRef>
+        </p:style>
+        <p:txBody>
+          <a:bodyPr rtlCol="0" anchor="ctr"/>
+          <a:lstStyle/>
+          <a:p>
+            <a:pPr algn="ctr"/>
+            <a:endParaRPr lang="en-US"/>
+          </a:p>
+        </p:txBody>
+      </p:sp>
+      <p:sp>
+        <p:nvSpPr>
+          <p:cNvPr id="22" name="Rectangle 21">
+            <a:extLst>
+              <a:ext uri="{FF2B5EF4-FFF2-40B4-BE49-F238E27FC236}">
+                <a16:creationId xmlns:a16="http://schemas.microsoft.com/office/drawing/2014/main" id="{CBC75FA1-A61E-11FB-0476-0FE684DEAB1F}"/>
+              </a:ext>
+            </a:extLst>
+          </p:cNvPr>
+          <p:cNvSpPr/>
+          <p:nvPr/>
+        </p:nvSpPr>
+        <p:spPr>
+          <a:xfrm>
+            <a:off x="7760378" y="530467"/>
+            <a:ext cx="4291922" cy="6148371"/>
+          </a:xfrm>
+          <a:prstGeom prst="rect">
+            <a:avLst/>
+          </a:prstGeom>
+          <a:noFill/>
+          <a:ln w="38100">
+            <a:solidFill>
+              <a:srgbClr val="FFFF00"/>
+            </a:solidFill>
+          </a:ln>
+        </p:spPr>
+        <p:style>
+          <a:lnRef idx="2">
+            <a:schemeClr val="accent1">
+              <a:shade val="15000"/>
+            </a:schemeClr>
+          </a:lnRef>
+          <a:fillRef idx="1">
+            <a:schemeClr val="accent1"/>
+          </a:fillRef>
+          <a:effectRef idx="0">
+            <a:schemeClr val="accent1"/>
+          </a:effectRef>
+          <a:fontRef idx="minor">
+            <a:schemeClr val="lt1"/>
+          </a:fontRef>
+        </p:style>
+        <p:txBody>
+          <a:bodyPr rtlCol="0" anchor="ctr"/>
+          <a:lstStyle/>
+          <a:p>
+            <a:pPr algn="ctr"/>
+            <a:endParaRPr lang="en-US"/>
+          </a:p>
+        </p:txBody>
+      </p:sp>
+      <p:graphicFrame>
+        <p:nvGraphicFramePr>
+          <p:cNvPr id="23" name="Table 22">
+            <a:extLst>
+              <a:ext uri="{FF2B5EF4-FFF2-40B4-BE49-F238E27FC236}">
+                <a16:creationId xmlns:a16="http://schemas.microsoft.com/office/drawing/2014/main" id="{BC299207-EC83-81F5-98B8-4406B9D2CB92}"/>
+              </a:ext>
+            </a:extLst>
+          </p:cNvPr>
+          <p:cNvGraphicFramePr>
+            <a:graphicFrameLocks noGrp="1"/>
+          </p:cNvGraphicFramePr>
+          <p:nvPr>
+            <p:extLst>
+              <p:ext uri="{D42A27DB-BD31-4B8C-83A1-F6EECF244321}">
+                <p14:modId xmlns:p14="http://schemas.microsoft.com/office/powerpoint/2010/main" val="1077996544"/>
+              </p:ext>
+            </p:extLst>
+          </p:nvPr>
+        </p:nvGraphicFramePr>
+        <p:xfrm>
+          <a:off x="8393284" y="2786379"/>
+          <a:ext cx="3289300" cy="1285240"/>
+        </p:xfrm>
+        <a:graphic>
+          <a:graphicData uri="http://schemas.openxmlformats.org/drawingml/2006/table">
+            <a:tbl>
+              <a:tblPr firstRow="1" bandRow="1">
+                <a:tableStyleId>{5C22544A-7EE6-4342-B048-85BDC9FD1C3A}</a:tableStyleId>
+              </a:tblPr>
+              <a:tblGrid>
+                <a:gridCol w="3289300">
+                  <a:extLst>
+                    <a:ext uri="{9D8B030D-6E8A-4147-A177-3AD203B41FA5}">
+                      <a16:colId xmlns:a16="http://schemas.microsoft.com/office/drawing/2014/main" val="1033090965"/>
+                    </a:ext>
+                  </a:extLst>
+                </a:gridCol>
+              </a:tblGrid>
+              <a:tr h="370840">
+                <a:tc>
+                  <a:txBody>
+                    <a:bodyPr/>
+                    <a:lstStyle/>
+                    <a:p>
+                      <a:pPr algn="ctr"/>
+                      <a:r>
+                        <a:rPr lang="en-US" dirty="0">
+                          <a:solidFill>
+                            <a:schemeClr val="tx1"/>
+                          </a:solidFill>
+                        </a:rPr>
+                        <a:t>Extension Output</a:t>
+                      </a:r>
+                    </a:p>
+                  </a:txBody>
+                  <a:tcPr>
+                    <a:lnL w="12700" cap="flat" cmpd="sng" algn="ctr">
+                      <a:solidFill>
+                        <a:schemeClr val="tx1"/>
+                      </a:solidFill>
+                      <a:prstDash val="solid"/>
+                      <a:round/>
+                      <a:headEnd type="none" w="med" len="med"/>
+                      <a:tailEnd type="none" w="med" len="med"/>
+                    </a:lnL>
+                    <a:lnR w="12700" cap="flat" cmpd="sng" algn="ctr">
+                      <a:solidFill>
+                        <a:schemeClr val="tx1"/>
+                      </a:solidFill>
+                      <a:prstDash val="solid"/>
+                      <a:round/>
+                      <a:headEnd type="none" w="med" len="med"/>
+                      <a:tailEnd type="none" w="med" len="med"/>
+                    </a:lnR>
+                    <a:lnT w="12700" cap="flat" cmpd="sng" algn="ctr">
+                      <a:solidFill>
+                        <a:schemeClr val="tx1"/>
+                      </a:solidFill>
+                      <a:prstDash val="solid"/>
+                      <a:round/>
+                      <a:headEnd type="none" w="med" len="med"/>
+                      <a:tailEnd type="none" w="med" len="med"/>
+                    </a:lnT>
+                    <a:lnB w="12700" cap="flat" cmpd="sng" algn="ctr">
+                      <a:solidFill>
+                        <a:schemeClr val="tx1"/>
+                      </a:solidFill>
+                      <a:prstDash val="solid"/>
+                      <a:round/>
+                      <a:headEnd type="none" w="med" len="med"/>
+                      <a:tailEnd type="none" w="med" len="med"/>
+                    </a:lnB>
+                    <a:solidFill>
+                      <a:srgbClr val="F8ED08"/>
+                    </a:solidFill>
+                  </a:tcPr>
+                </a:tc>
+                <a:extLst>
+                  <a:ext uri="{0D108BD9-81ED-4DB2-BD59-A6C34878D82A}">
+                    <a16:rowId xmlns:a16="http://schemas.microsoft.com/office/drawing/2014/main" val="1183902942"/>
+                  </a:ext>
+                </a:extLst>
+              </a:tr>
+              <a:tr h="370840">
+                <a:tc>
+                  <a:txBody>
+                    <a:bodyPr/>
+                    <a:lstStyle/>
+                    <a:p>
+                      <a:pPr marL="285750" marR="0" lvl="0" indent="-285750" algn="l" defTabSz="914400" rtl="0" eaLnBrk="1" fontAlgn="auto" latinLnBrk="0" hangingPunct="1">
+                        <a:lnSpc>
+                          <a:spcPct val="100000"/>
+                        </a:lnSpc>
+                        <a:spcBef>
+                          <a:spcPts val="0"/>
+                        </a:spcBef>
+                        <a:spcAft>
+                          <a:spcPts val="0"/>
+                        </a:spcAft>
+                        <a:buClrTx/>
+                        <a:buSzTx/>
+                        <a:buFont typeface="Arial" panose="020B0604020202020204" pitchFamily="34" charset="0"/>
+                        <a:buChar char="•"/>
+                        <a:tabLst/>
+                        <a:defRPr/>
+                      </a:pPr>
+                      <a:r>
+                        <a:rPr lang="en-US" sz="1800" dirty="0"/>
+                        <a:t>Where the extension shows its work</a:t>
+                      </a:r>
+                    </a:p>
+                    <a:p>
+                      <a:pPr marL="285750" marR="0" lvl="0" indent="-285750" algn="l" defTabSz="914400" rtl="0" eaLnBrk="1" fontAlgn="auto" latinLnBrk="0" hangingPunct="1">
+                        <a:lnSpc>
+                          <a:spcPct val="100000"/>
+                        </a:lnSpc>
+                        <a:spcBef>
+                          <a:spcPts val="0"/>
+                        </a:spcBef>
+                        <a:spcAft>
+                          <a:spcPts val="0"/>
+                        </a:spcAft>
+                        <a:buClrTx/>
+                        <a:buSzTx/>
+                        <a:buFont typeface="Arial" panose="020B0604020202020204" pitchFamily="34" charset="0"/>
+                        <a:buChar char="•"/>
+                        <a:tabLst/>
+                        <a:defRPr/>
+                      </a:pPr>
+                      <a:r>
+                        <a:rPr lang="en-US" sz="1800" dirty="0"/>
+                        <a:t>(Not interactive)</a:t>
+                      </a:r>
+                    </a:p>
+                  </a:txBody>
+                  <a:tcPr>
+                    <a:lnL w="12700" cap="flat" cmpd="sng" algn="ctr">
+                      <a:solidFill>
+                        <a:schemeClr val="tx1"/>
+                      </a:solidFill>
+                      <a:prstDash val="solid"/>
+                      <a:round/>
+                      <a:headEnd type="none" w="med" len="med"/>
+                      <a:tailEnd type="none" w="med" len="med"/>
+                    </a:lnL>
+                    <a:lnR w="12700" cap="flat" cmpd="sng" algn="ctr">
+                      <a:solidFill>
+                        <a:schemeClr val="tx1"/>
+                      </a:solidFill>
+                      <a:prstDash val="solid"/>
+                      <a:round/>
+                      <a:headEnd type="none" w="med" len="med"/>
+                      <a:tailEnd type="none" w="med" len="med"/>
+                    </a:lnR>
+                    <a:lnT w="12700" cap="flat" cmpd="sng" algn="ctr">
+                      <a:solidFill>
+                        <a:schemeClr val="tx1"/>
+                      </a:solidFill>
+                      <a:prstDash val="solid"/>
+                      <a:round/>
+                      <a:headEnd type="none" w="med" len="med"/>
+                      <a:tailEnd type="none" w="med" len="med"/>
+                    </a:lnT>
+                    <a:lnB w="12700" cap="flat" cmpd="sng" algn="ctr">
+                      <a:solidFill>
+                        <a:schemeClr val="tx1"/>
+                      </a:solidFill>
+                      <a:prstDash val="solid"/>
+                      <a:round/>
+                      <a:headEnd type="none" w="med" len="med"/>
+                      <a:tailEnd type="none" w="med" len="med"/>
+                    </a:lnB>
+                    <a:solidFill>
+                      <a:srgbClr val="FFFF00"/>
+                    </a:solidFill>
+                  </a:tcPr>
+                </a:tc>
+                <a:extLst>
+                  <a:ext uri="{0D108BD9-81ED-4DB2-BD59-A6C34878D82A}">
+                    <a16:rowId xmlns:a16="http://schemas.microsoft.com/office/drawing/2014/main" val="323350065"/>
+                  </a:ext>
+                </a:extLst>
+              </a:tr>
+            </a:tbl>
+          </a:graphicData>
+        </a:graphic>
+      </p:graphicFrame>
+      <p:graphicFrame>
+        <p:nvGraphicFramePr>
+          <p:cNvPr id="24" name="Table 23">
+            <a:extLst>
+              <a:ext uri="{FF2B5EF4-FFF2-40B4-BE49-F238E27FC236}">
+                <a16:creationId xmlns:a16="http://schemas.microsoft.com/office/drawing/2014/main" id="{1F0EAC2B-E324-240F-87DF-43999F76A224}"/>
+              </a:ext>
+            </a:extLst>
+          </p:cNvPr>
+          <p:cNvGraphicFramePr>
+            <a:graphicFrameLocks noGrp="1"/>
+          </p:cNvGraphicFramePr>
+          <p:nvPr>
+            <p:extLst>
+              <p:ext uri="{D42A27DB-BD31-4B8C-83A1-F6EECF244321}">
+                <p14:modId xmlns:p14="http://schemas.microsoft.com/office/powerpoint/2010/main" val="500575850"/>
+              </p:ext>
+            </p:extLst>
+          </p:nvPr>
+        </p:nvGraphicFramePr>
+        <p:xfrm>
+          <a:off x="4097519" y="2786379"/>
+          <a:ext cx="3289300" cy="1285240"/>
+        </p:xfrm>
+        <a:graphic>
+          <a:graphicData uri="http://schemas.openxmlformats.org/drawingml/2006/table">
+            <a:tbl>
+              <a:tblPr firstRow="1" bandRow="1">
+                <a:tableStyleId>{5C22544A-7EE6-4342-B048-85BDC9FD1C3A}</a:tableStyleId>
+              </a:tblPr>
+              <a:tblGrid>
+                <a:gridCol w="3289300">
+                  <a:extLst>
+                    <a:ext uri="{9D8B030D-6E8A-4147-A177-3AD203B41FA5}">
+                      <a16:colId xmlns:a16="http://schemas.microsoft.com/office/drawing/2014/main" val="1033090965"/>
+                    </a:ext>
+                  </a:extLst>
+                </a:gridCol>
+              </a:tblGrid>
+              <a:tr h="370840">
+                <a:tc>
+                  <a:txBody>
+                    <a:bodyPr/>
+                    <a:lstStyle/>
+                    <a:p>
+                      <a:pPr algn="ctr"/>
+                      <a:r>
+                        <a:rPr lang="en-US" dirty="0">
+                          <a:solidFill>
+                            <a:schemeClr val="tx1"/>
+                          </a:solidFill>
+                        </a:rPr>
+                        <a:t>AI CLI Terminal</a:t>
+                      </a:r>
+                    </a:p>
+                  </a:txBody>
+                  <a:tcPr>
+                    <a:lnL w="12700" cap="flat" cmpd="sng" algn="ctr">
+                      <a:solidFill>
+                        <a:schemeClr val="tx1"/>
+                      </a:solidFill>
+                      <a:prstDash val="solid"/>
+                      <a:round/>
+                      <a:headEnd type="none" w="med" len="med"/>
+                      <a:tailEnd type="none" w="med" len="med"/>
+                    </a:lnL>
+                    <a:lnR w="12700" cap="flat" cmpd="sng" algn="ctr">
+                      <a:solidFill>
+                        <a:schemeClr val="tx1"/>
+                      </a:solidFill>
+                      <a:prstDash val="solid"/>
+                      <a:round/>
+                      <a:headEnd type="none" w="med" len="med"/>
+                      <a:tailEnd type="none" w="med" len="med"/>
+                    </a:lnR>
+                    <a:lnT w="12700" cap="flat" cmpd="sng" algn="ctr">
+                      <a:solidFill>
+                        <a:schemeClr val="tx1"/>
+                      </a:solidFill>
+                      <a:prstDash val="solid"/>
+                      <a:round/>
+                      <a:headEnd type="none" w="med" len="med"/>
+                      <a:tailEnd type="none" w="med" len="med"/>
+                    </a:lnT>
+                    <a:lnB w="12700" cap="flat" cmpd="sng" algn="ctr">
+                      <a:solidFill>
+                        <a:schemeClr val="tx1"/>
+                      </a:solidFill>
+                      <a:prstDash val="solid"/>
+                      <a:round/>
+                      <a:headEnd type="none" w="med" len="med"/>
+                      <a:tailEnd type="none" w="med" len="med"/>
+                    </a:lnB>
+                    <a:solidFill>
+                      <a:srgbClr val="F8ED08"/>
+                    </a:solidFill>
+                  </a:tcPr>
+                </a:tc>
+                <a:extLst>
+                  <a:ext uri="{0D108BD9-81ED-4DB2-BD59-A6C34878D82A}">
+                    <a16:rowId xmlns:a16="http://schemas.microsoft.com/office/drawing/2014/main" val="1183902942"/>
+                  </a:ext>
+                </a:extLst>
+              </a:tr>
+              <a:tr h="370840">
+                <a:tc>
+                  <a:txBody>
+                    <a:bodyPr/>
+                    <a:lstStyle/>
+                    <a:p>
+                      <a:pPr marL="285750" marR="0" lvl="0" indent="-285750" algn="l" defTabSz="914400" rtl="0" eaLnBrk="1" fontAlgn="auto" latinLnBrk="0" hangingPunct="1">
+                        <a:lnSpc>
+                          <a:spcPct val="100000"/>
+                        </a:lnSpc>
+                        <a:spcBef>
+                          <a:spcPts val="0"/>
+                        </a:spcBef>
+                        <a:spcAft>
+                          <a:spcPts val="0"/>
+                        </a:spcAft>
+                        <a:buClrTx/>
+                        <a:buSzTx/>
+                        <a:buFont typeface="Arial" panose="020B0604020202020204" pitchFamily="34" charset="0"/>
+                        <a:buChar char="•"/>
+                        <a:tabLst/>
+                        <a:defRPr/>
+                      </a:pPr>
+                      <a:r>
+                        <a:rPr lang="en-US" sz="1800" dirty="0"/>
+                        <a:t>Where AI shows its work</a:t>
+                      </a:r>
+                    </a:p>
+                    <a:p>
+                      <a:pPr marL="285750" marR="0" lvl="0" indent="-285750" algn="l" defTabSz="914400" rtl="0" eaLnBrk="1" fontAlgn="auto" latinLnBrk="0" hangingPunct="1">
+                        <a:lnSpc>
+                          <a:spcPct val="100000"/>
+                        </a:lnSpc>
+                        <a:spcBef>
+                          <a:spcPts val="0"/>
+                        </a:spcBef>
+                        <a:spcAft>
+                          <a:spcPts val="0"/>
+                        </a:spcAft>
+                        <a:buClrTx/>
+                        <a:buSzTx/>
+                        <a:buFont typeface="Arial" panose="020B0604020202020204" pitchFamily="34" charset="0"/>
+                        <a:buChar char="•"/>
+                        <a:tabLst/>
+                        <a:defRPr/>
+                      </a:pPr>
+                      <a:r>
+                        <a:rPr lang="en-US" sz="1800" dirty="0"/>
+                        <a:t>Where a human user can interact with AI</a:t>
+                      </a:r>
+                    </a:p>
+                  </a:txBody>
+                  <a:tcPr>
+                    <a:lnL w="12700" cap="flat" cmpd="sng" algn="ctr">
+                      <a:solidFill>
+                        <a:schemeClr val="tx1"/>
+                      </a:solidFill>
+                      <a:prstDash val="solid"/>
+                      <a:round/>
+                      <a:headEnd type="none" w="med" len="med"/>
+                      <a:tailEnd type="none" w="med" len="med"/>
+                    </a:lnL>
+                    <a:lnR w="12700" cap="flat" cmpd="sng" algn="ctr">
+                      <a:solidFill>
+                        <a:schemeClr val="tx1"/>
+                      </a:solidFill>
+                      <a:prstDash val="solid"/>
+                      <a:round/>
+                      <a:headEnd type="none" w="med" len="med"/>
+                      <a:tailEnd type="none" w="med" len="med"/>
+                    </a:lnR>
+                    <a:lnT w="12700" cap="flat" cmpd="sng" algn="ctr">
+                      <a:solidFill>
+                        <a:schemeClr val="tx1"/>
+                      </a:solidFill>
+                      <a:prstDash val="solid"/>
+                      <a:round/>
+                      <a:headEnd type="none" w="med" len="med"/>
+                      <a:tailEnd type="none" w="med" len="med"/>
+                    </a:lnT>
+                    <a:lnB w="12700" cap="flat" cmpd="sng" algn="ctr">
+                      <a:solidFill>
+                        <a:schemeClr val="tx1"/>
+                      </a:solidFill>
+                      <a:prstDash val="solid"/>
+                      <a:round/>
+                      <a:headEnd type="none" w="med" len="med"/>
+                      <a:tailEnd type="none" w="med" len="med"/>
+                    </a:lnB>
+                    <a:solidFill>
+                      <a:srgbClr val="FFFF00"/>
+                    </a:solidFill>
+                  </a:tcPr>
+                </a:tc>
+                <a:extLst>
+                  <a:ext uri="{0D108BD9-81ED-4DB2-BD59-A6C34878D82A}">
+                    <a16:rowId xmlns:a16="http://schemas.microsoft.com/office/drawing/2014/main" val="323350065"/>
+                  </a:ext>
+                </a:extLst>
+              </a:tr>
+            </a:tbl>
+          </a:graphicData>
+        </a:graphic>
+      </p:graphicFrame>
+      <p:graphicFrame>
+        <p:nvGraphicFramePr>
+          <p:cNvPr id="25" name="Table 24">
+            <a:extLst>
+              <a:ext uri="{FF2B5EF4-FFF2-40B4-BE49-F238E27FC236}">
+                <a16:creationId xmlns:a16="http://schemas.microsoft.com/office/drawing/2014/main" id="{89D059EA-8F57-1B6E-0B4D-FDE9D5052B6A}"/>
+              </a:ext>
+            </a:extLst>
+          </p:cNvPr>
+          <p:cNvGraphicFramePr>
+            <a:graphicFrameLocks noGrp="1"/>
+          </p:cNvGraphicFramePr>
+          <p:nvPr>
+            <p:extLst>
+              <p:ext uri="{D42A27DB-BD31-4B8C-83A1-F6EECF244321}">
+                <p14:modId xmlns:p14="http://schemas.microsoft.com/office/powerpoint/2010/main" val="59113919"/>
+              </p:ext>
+            </p:extLst>
+          </p:nvPr>
+        </p:nvGraphicFramePr>
+        <p:xfrm>
+          <a:off x="1836919" y="5266286"/>
+          <a:ext cx="2531881" cy="1010920"/>
+        </p:xfrm>
+        <a:graphic>
+          <a:graphicData uri="http://schemas.openxmlformats.org/drawingml/2006/table">
+            <a:tbl>
+              <a:tblPr firstRow="1" bandRow="1">
+                <a:tableStyleId>{5C22544A-7EE6-4342-B048-85BDC9FD1C3A}</a:tableStyleId>
+              </a:tblPr>
+              <a:tblGrid>
+                <a:gridCol w="2531881">
+                  <a:extLst>
+                    <a:ext uri="{9D8B030D-6E8A-4147-A177-3AD203B41FA5}">
+                      <a16:colId xmlns:a16="http://schemas.microsoft.com/office/drawing/2014/main" val="1033090965"/>
+                    </a:ext>
+                  </a:extLst>
+                </a:gridCol>
+              </a:tblGrid>
+              <a:tr h="370840">
+                <a:tc>
+                  <a:txBody>
+                    <a:bodyPr/>
+                    <a:lstStyle/>
+                    <a:p>
+                      <a:pPr algn="ctr"/>
+                      <a:r>
+                        <a:rPr lang="en-US" dirty="0">
+                          <a:solidFill>
+                            <a:schemeClr val="tx1"/>
+                          </a:solidFill>
+                        </a:rPr>
+                        <a:t>Work Explorer</a:t>
+                      </a:r>
+                    </a:p>
+                  </a:txBody>
+                  <a:tcPr>
+                    <a:lnL w="12700" cap="flat" cmpd="sng" algn="ctr">
+                      <a:solidFill>
+                        <a:schemeClr val="tx1"/>
+                      </a:solidFill>
+                      <a:prstDash val="solid"/>
+                      <a:round/>
+                      <a:headEnd type="none" w="med" len="med"/>
+                      <a:tailEnd type="none" w="med" len="med"/>
+                    </a:lnL>
+                    <a:lnR w="12700" cap="flat" cmpd="sng" algn="ctr">
+                      <a:solidFill>
+                        <a:schemeClr val="tx1"/>
+                      </a:solidFill>
+                      <a:prstDash val="solid"/>
+                      <a:round/>
+                      <a:headEnd type="none" w="med" len="med"/>
+                      <a:tailEnd type="none" w="med" len="med"/>
+                    </a:lnR>
+                    <a:lnT w="12700" cap="flat" cmpd="sng" algn="ctr">
+                      <a:solidFill>
+                        <a:schemeClr val="tx1"/>
+                      </a:solidFill>
+                      <a:prstDash val="solid"/>
+                      <a:round/>
+                      <a:headEnd type="none" w="med" len="med"/>
+                      <a:tailEnd type="none" w="med" len="med"/>
+                    </a:lnT>
+                    <a:lnB w="12700" cap="flat" cmpd="sng" algn="ctr">
+                      <a:solidFill>
+                        <a:schemeClr val="tx1"/>
+                      </a:solidFill>
+                      <a:prstDash val="solid"/>
+                      <a:round/>
+                      <a:headEnd type="none" w="med" len="med"/>
+                      <a:tailEnd type="none" w="med" len="med"/>
+                    </a:lnB>
+                    <a:solidFill>
+                      <a:srgbClr val="F8ED08"/>
+                    </a:solidFill>
+                  </a:tcPr>
+                </a:tc>
+                <a:extLst>
+                  <a:ext uri="{0D108BD9-81ED-4DB2-BD59-A6C34878D82A}">
+                    <a16:rowId xmlns:a16="http://schemas.microsoft.com/office/drawing/2014/main" val="1183902942"/>
+                  </a:ext>
+                </a:extLst>
+              </a:tr>
+              <a:tr h="370840">
+                <a:tc>
+                  <a:txBody>
+                    <a:bodyPr/>
+                    <a:lstStyle/>
+                    <a:p>
+                      <a:pPr marL="285750" marR="0" lvl="0" indent="-285750" algn="l" defTabSz="914400" rtl="0" eaLnBrk="1" fontAlgn="auto" latinLnBrk="0" hangingPunct="1">
+                        <a:lnSpc>
+                          <a:spcPct val="100000"/>
+                        </a:lnSpc>
+                        <a:spcBef>
+                          <a:spcPts val="0"/>
+                        </a:spcBef>
+                        <a:spcAft>
+                          <a:spcPts val="0"/>
+                        </a:spcAft>
+                        <a:buClrTx/>
+                        <a:buSzTx/>
+                        <a:buFont typeface="Arial" panose="020B0604020202020204" pitchFamily="34" charset="0"/>
+                        <a:buChar char="•"/>
+                        <a:tabLst/>
+                        <a:defRPr/>
+                      </a:pPr>
+                      <a:r>
+                        <a:rPr lang="en-US" sz="1800" dirty="0"/>
+                        <a:t>Where you start and track AI sessions</a:t>
+                      </a:r>
+                    </a:p>
+                  </a:txBody>
+                  <a:tcPr>
+                    <a:lnL w="12700" cap="flat" cmpd="sng" algn="ctr">
+                      <a:solidFill>
+                        <a:schemeClr val="tx1"/>
+                      </a:solidFill>
+                      <a:prstDash val="solid"/>
+                      <a:round/>
+                      <a:headEnd type="none" w="med" len="med"/>
+                      <a:tailEnd type="none" w="med" len="med"/>
+                    </a:lnL>
+                    <a:lnR w="12700" cap="flat" cmpd="sng" algn="ctr">
+                      <a:solidFill>
+                        <a:schemeClr val="tx1"/>
+                      </a:solidFill>
+                      <a:prstDash val="solid"/>
+                      <a:round/>
+                      <a:headEnd type="none" w="med" len="med"/>
+                      <a:tailEnd type="none" w="med" len="med"/>
+                    </a:lnR>
+                    <a:lnT w="12700" cap="flat" cmpd="sng" algn="ctr">
+                      <a:solidFill>
+                        <a:schemeClr val="tx1"/>
+                      </a:solidFill>
+                      <a:prstDash val="solid"/>
+                      <a:round/>
+                      <a:headEnd type="none" w="med" len="med"/>
+                      <a:tailEnd type="none" w="med" len="med"/>
+                    </a:lnT>
+                    <a:lnB w="12700" cap="flat" cmpd="sng" algn="ctr">
+                      <a:solidFill>
+                        <a:schemeClr val="tx1"/>
+                      </a:solidFill>
+                      <a:prstDash val="solid"/>
+                      <a:round/>
+                      <a:headEnd type="none" w="med" len="med"/>
+                      <a:tailEnd type="none" w="med" len="med"/>
+                    </a:lnB>
+                    <a:solidFill>
+                      <a:srgbClr val="FFFF00"/>
+                    </a:solidFill>
+                  </a:tcPr>
+                </a:tc>
+                <a:extLst>
+                  <a:ext uri="{0D108BD9-81ED-4DB2-BD59-A6C34878D82A}">
+                    <a16:rowId xmlns:a16="http://schemas.microsoft.com/office/drawing/2014/main" val="323350065"/>
+                  </a:ext>
+                </a:extLst>
+              </a:tr>
+            </a:tbl>
+          </a:graphicData>
+        </a:graphic>
+      </p:graphicFrame>
+      <p:graphicFrame>
+        <p:nvGraphicFramePr>
+          <p:cNvPr id="26" name="Table 25">
+            <a:extLst>
+              <a:ext uri="{FF2B5EF4-FFF2-40B4-BE49-F238E27FC236}">
+                <a16:creationId xmlns:a16="http://schemas.microsoft.com/office/drawing/2014/main" id="{8E5517B2-B3BA-F64B-9C33-98CC7B96A12C}"/>
+              </a:ext>
+            </a:extLst>
+          </p:cNvPr>
+          <p:cNvGraphicFramePr>
+            <a:graphicFrameLocks noGrp="1"/>
+          </p:cNvGraphicFramePr>
+          <p:nvPr>
+            <p:extLst>
+              <p:ext uri="{D42A27DB-BD31-4B8C-83A1-F6EECF244321}">
+                <p14:modId xmlns:p14="http://schemas.microsoft.com/office/powerpoint/2010/main" val="1920859465"/>
+              </p:ext>
+            </p:extLst>
+          </p:nvPr>
+        </p:nvGraphicFramePr>
+        <p:xfrm>
+          <a:off x="1194582" y="1967872"/>
+          <a:ext cx="2833087" cy="1833880"/>
+        </p:xfrm>
+        <a:graphic>
+          <a:graphicData uri="http://schemas.openxmlformats.org/drawingml/2006/table">
+            <a:tbl>
+              <a:tblPr firstRow="1" bandRow="1">
+                <a:tableStyleId>{5C22544A-7EE6-4342-B048-85BDC9FD1C3A}</a:tableStyleId>
+              </a:tblPr>
+              <a:tblGrid>
+                <a:gridCol w="2833087">
+                  <a:extLst>
+                    <a:ext uri="{9D8B030D-6E8A-4147-A177-3AD203B41FA5}">
+                      <a16:colId xmlns:a16="http://schemas.microsoft.com/office/drawing/2014/main" val="1033090965"/>
+                    </a:ext>
+                  </a:extLst>
+                </a:gridCol>
+              </a:tblGrid>
+              <a:tr h="370840">
+                <a:tc>
+                  <a:txBody>
+                    <a:bodyPr/>
+                    <a:lstStyle/>
+                    <a:p>
+                      <a:pPr algn="ctr"/>
+                      <a:r>
+                        <a:rPr lang="en-US" dirty="0">
+                          <a:solidFill>
+                            <a:schemeClr val="tx1"/>
+                          </a:solidFill>
+                        </a:rPr>
+                        <a:t>Solution Explorer</a:t>
+                      </a:r>
+                    </a:p>
+                  </a:txBody>
+                  <a:tcPr>
+                    <a:lnL w="12700" cap="flat" cmpd="sng" algn="ctr">
+                      <a:solidFill>
+                        <a:schemeClr val="tx1"/>
+                      </a:solidFill>
+                      <a:prstDash val="solid"/>
+                      <a:round/>
+                      <a:headEnd type="none" w="med" len="med"/>
+                      <a:tailEnd type="none" w="med" len="med"/>
+                    </a:lnL>
+                    <a:lnR w="12700" cap="flat" cmpd="sng" algn="ctr">
+                      <a:solidFill>
+                        <a:schemeClr val="tx1"/>
+                      </a:solidFill>
+                      <a:prstDash val="solid"/>
+                      <a:round/>
+                      <a:headEnd type="none" w="med" len="med"/>
+                      <a:tailEnd type="none" w="med" len="med"/>
+                    </a:lnR>
+                    <a:lnT w="12700" cap="flat" cmpd="sng" algn="ctr">
+                      <a:solidFill>
+                        <a:schemeClr val="tx1"/>
+                      </a:solidFill>
+                      <a:prstDash val="solid"/>
+                      <a:round/>
+                      <a:headEnd type="none" w="med" len="med"/>
+                      <a:tailEnd type="none" w="med" len="med"/>
+                    </a:lnT>
+                    <a:lnB w="12700" cap="flat" cmpd="sng" algn="ctr">
+                      <a:solidFill>
+                        <a:schemeClr val="tx1"/>
+                      </a:solidFill>
+                      <a:prstDash val="solid"/>
+                      <a:round/>
+                      <a:headEnd type="none" w="med" len="med"/>
+                      <a:tailEnd type="none" w="med" len="med"/>
+                    </a:lnB>
+                    <a:solidFill>
+                      <a:srgbClr val="F8ED08"/>
+                    </a:solidFill>
+                  </a:tcPr>
+                </a:tc>
+                <a:extLst>
+                  <a:ext uri="{0D108BD9-81ED-4DB2-BD59-A6C34878D82A}">
+                    <a16:rowId xmlns:a16="http://schemas.microsoft.com/office/drawing/2014/main" val="1183902942"/>
+                  </a:ext>
+                </a:extLst>
+              </a:tr>
+              <a:tr h="370840">
+                <a:tc>
+                  <a:txBody>
+                    <a:bodyPr/>
+                    <a:lstStyle/>
+                    <a:p>
+                      <a:pPr marL="285750" marR="0" lvl="0" indent="-285750" algn="l" defTabSz="914400" rtl="0" eaLnBrk="1" fontAlgn="auto" latinLnBrk="0" hangingPunct="1">
+                        <a:lnSpc>
+                          <a:spcPct val="100000"/>
+                        </a:lnSpc>
+                        <a:spcBef>
+                          <a:spcPts val="0"/>
+                        </a:spcBef>
+                        <a:spcAft>
+                          <a:spcPts val="0"/>
+                        </a:spcAft>
+                        <a:buClrTx/>
+                        <a:buSzTx/>
+                        <a:buFont typeface="Arial" panose="020B0604020202020204" pitchFamily="34" charset="0"/>
+                        <a:buChar char="•"/>
+                        <a:tabLst/>
+                        <a:defRPr/>
+                      </a:pPr>
+                      <a:r>
+                        <a:rPr lang="en-US" sz="1800" dirty="0"/>
+                        <a:t>Where you choose AI models for sessions</a:t>
+                      </a:r>
+                    </a:p>
+                    <a:p>
+                      <a:pPr marL="285750" marR="0" lvl="0" indent="-285750" algn="l" defTabSz="914400" rtl="0" eaLnBrk="1" fontAlgn="auto" latinLnBrk="0" hangingPunct="1">
+                        <a:lnSpc>
+                          <a:spcPct val="100000"/>
+                        </a:lnSpc>
+                        <a:spcBef>
+                          <a:spcPts val="0"/>
+                        </a:spcBef>
+                        <a:spcAft>
+                          <a:spcPts val="0"/>
+                        </a:spcAft>
+                        <a:buClrTx/>
+                        <a:buSzTx/>
+                        <a:buFont typeface="Arial" panose="020B0604020202020204" pitchFamily="34" charset="0"/>
+                        <a:buChar char="•"/>
+                        <a:tabLst/>
+                        <a:defRPr/>
+                      </a:pPr>
+                      <a:r>
+                        <a:rPr lang="en-US" sz="1800" dirty="0"/>
+                        <a:t>Where any solution projects/modules are shown</a:t>
+                      </a:r>
+                    </a:p>
+                  </a:txBody>
+                  <a:tcPr>
+                    <a:lnL w="12700" cap="flat" cmpd="sng" algn="ctr">
+                      <a:solidFill>
+                        <a:schemeClr val="tx1"/>
+                      </a:solidFill>
+                      <a:prstDash val="solid"/>
+                      <a:round/>
+                      <a:headEnd type="none" w="med" len="med"/>
+                      <a:tailEnd type="none" w="med" len="med"/>
+                    </a:lnL>
+                    <a:lnR w="12700" cap="flat" cmpd="sng" algn="ctr">
+                      <a:solidFill>
+                        <a:schemeClr val="tx1"/>
+                      </a:solidFill>
+                      <a:prstDash val="solid"/>
+                      <a:round/>
+                      <a:headEnd type="none" w="med" len="med"/>
+                      <a:tailEnd type="none" w="med" len="med"/>
+                    </a:lnR>
+                    <a:lnT w="12700" cap="flat" cmpd="sng" algn="ctr">
+                      <a:solidFill>
+                        <a:schemeClr val="tx1"/>
+                      </a:solidFill>
+                      <a:prstDash val="solid"/>
+                      <a:round/>
+                      <a:headEnd type="none" w="med" len="med"/>
+                      <a:tailEnd type="none" w="med" len="med"/>
+                    </a:lnT>
+                    <a:lnB w="12700" cap="flat" cmpd="sng" algn="ctr">
+                      <a:solidFill>
+                        <a:schemeClr val="tx1"/>
+                      </a:solidFill>
+                      <a:prstDash val="solid"/>
+                      <a:round/>
+                      <a:headEnd type="none" w="med" len="med"/>
+                      <a:tailEnd type="none" w="med" len="med"/>
+                    </a:lnB>
+                    <a:solidFill>
+                      <a:srgbClr val="FFFF00"/>
+                    </a:solidFill>
+                  </a:tcPr>
+                </a:tc>
+                <a:extLst>
+                  <a:ext uri="{0D108BD9-81ED-4DB2-BD59-A6C34878D82A}">
+                    <a16:rowId xmlns:a16="http://schemas.microsoft.com/office/drawing/2014/main" val="323350065"/>
+                  </a:ext>
+                </a:extLst>
+              </a:tr>
+            </a:tbl>
+          </a:graphicData>
+        </a:graphic>
+      </p:graphicFrame>
+    </p:spTree>
+    <p:extLst>
+      <p:ext uri="{BB962C8B-B14F-4D97-AF65-F5344CB8AC3E}">
+        <p14:creationId xmlns:p14="http://schemas.microsoft.com/office/powerpoint/2010/main" val="1026660321"/>
+      </p:ext>
+    </p:extLst>
+  </p:cSld>
+  <p:clrMapOvr>
+    <a:masterClrMapping/>
+  </p:clrMapOvr>
+</p:sld>
+</file>
+
+<file path=ppt/slides/slide7.xml><?xml version="1.0" encoding="utf-8"?>
+<p:sld xmlns:a="http://schemas.openxmlformats.org/drawingml/2006/main" xmlns:r="http://schemas.openxmlformats.org/officeDocument/2006/relationships" xmlns:p="http://schemas.openxmlformats.org/presentationml/2006/main">
+  <p:cSld>
+    <p:spTree>
+      <p:nvGrpSpPr>
+        <p:cNvPr id="1" name="">
+          <a:extLst>
+            <a:ext uri="{FF2B5EF4-FFF2-40B4-BE49-F238E27FC236}">
+              <a16:creationId xmlns:a16="http://schemas.microsoft.com/office/drawing/2014/main" id="{804D9B25-0B4F-AD94-2685-8A0C6C6C5AF5}"/>
+            </a:ext>
+          </a:extLst>
+        </p:cNvPr>
+        <p:cNvGrpSpPr/>
+        <p:nvPr/>
+      </p:nvGrpSpPr>
+      <p:grpSpPr>
+        <a:xfrm>
+          <a:off x="0" y="0"/>
+          <a:ext cx="0" cy="0"/>
+          <a:chOff x="0" y="0"/>
+          <a:chExt cx="0" cy="0"/>
+        </a:xfrm>
+      </p:grpSpPr>
+      <p:sp>
+        <p:nvSpPr>
+          <p:cNvPr id="2" name="Title 1">
+            <a:extLst>
+              <a:ext uri="{FF2B5EF4-FFF2-40B4-BE49-F238E27FC236}">
+                <a16:creationId xmlns:a16="http://schemas.microsoft.com/office/drawing/2014/main" id="{0CC7FB37-2EA3-80F9-6C02-4BF245E77A60}"/>
+              </a:ext>
+            </a:extLst>
+          </p:cNvPr>
+          <p:cNvSpPr>
+            <a:spLocks noGrp="1"/>
+          </p:cNvSpPr>
+          <p:nvPr>
+            <p:ph type="title"/>
+          </p:nvPr>
+        </p:nvSpPr>
+        <p:spPr>
+          <a:xfrm>
+            <a:off x="838200" y="365126"/>
+            <a:ext cx="10515600" cy="835602"/>
+          </a:xfrm>
+        </p:spPr>
+        <p:txBody>
+          <a:bodyPr/>
+          <a:lstStyle/>
+          <a:p>
+            <a:r>
+              <a:rPr lang="en-US" i="1" dirty="0"/>
+              <a:t>Getting Started – Starter Sessions</a:t>
+            </a:r>
+          </a:p>
+        </p:txBody>
+      </p:sp>
+      <p:sp>
+        <p:nvSpPr>
+          <p:cNvPr id="3" name="Content Placeholder 2">
+            <a:extLst>
+              <a:ext uri="{FF2B5EF4-FFF2-40B4-BE49-F238E27FC236}">
+                <a16:creationId xmlns:a16="http://schemas.microsoft.com/office/drawing/2014/main" id="{29381454-0FCE-C413-4530-1CD2CF5EDA97}"/>
+              </a:ext>
+            </a:extLst>
+          </p:cNvPr>
+          <p:cNvSpPr>
+            <a:spLocks noGrp="1"/>
+          </p:cNvSpPr>
+          <p:nvPr>
+            <p:ph idx="1"/>
+          </p:nvPr>
+        </p:nvSpPr>
+        <p:spPr>
+          <a:xfrm>
+            <a:off x="838200" y="1358900"/>
+            <a:ext cx="10515600" cy="5384800"/>
+          </a:xfrm>
+        </p:spPr>
+        <p:txBody>
+          <a:bodyPr>
+            <a:noAutofit/>
+          </a:bodyPr>
+          <a:lstStyle/>
+          <a:p>
+            <a:r>
+              <a:rPr lang="en-US" sz="2600" dirty="0"/>
+              <a:t>When set up a new project, the extension will create two starter sessions:</a:t>
+            </a:r>
+            <a:br>
+              <a:rPr lang="en-US" sz="2600" dirty="0"/>
+            </a:br>
+            <a:endParaRPr lang="en-US" sz="2600" dirty="0"/>
+          </a:p>
+          <a:p>
+            <a:pPr marL="914400" lvl="1" indent="-457200">
+              <a:buFont typeface="+mj-lt"/>
+              <a:buAutoNum type="arabicPeriod"/>
+            </a:pPr>
+            <a:r>
+              <a:rPr lang="en-US" dirty="0"/>
+              <a:t>"001 · Author or import the solution plan" </a:t>
+            </a:r>
+          </a:p>
+          <a:p>
+            <a:pPr lvl="2"/>
+            <a:r>
+              <a:rPr lang="en-US" dirty="0"/>
+              <a:t>User can import an existing project plan</a:t>
+            </a:r>
+          </a:p>
+          <a:p>
+            <a:pPr lvl="2"/>
+            <a:r>
+              <a:rPr lang="en-US" dirty="0"/>
+              <a:t>User can work with AI interactively to creates a new project plan</a:t>
+            </a:r>
+            <a:br>
+              <a:rPr lang="en-US" dirty="0"/>
+            </a:br>
+            <a:endParaRPr lang="en-US" dirty="0"/>
+          </a:p>
+          <a:p>
+            <a:pPr marL="914400" lvl="1" indent="-457200">
+              <a:buFont typeface="+mj-lt"/>
+              <a:buAutoNum type="arabicPeriod"/>
+            </a:pPr>
+            <a:r>
+              <a:rPr lang="en-US" dirty="0"/>
+              <a:t>"002 · Challenge the plan, then break it into numbered sessions"</a:t>
+            </a:r>
+          </a:p>
+          <a:p>
+            <a:pPr lvl="2"/>
+            <a:r>
+              <a:rPr lang="en-US" dirty="0"/>
+              <a:t>Breaks down the project plan into a sequence of sessions</a:t>
+            </a:r>
+          </a:p>
+          <a:p>
+            <a:pPr lvl="2"/>
+            <a:r>
+              <a:rPr lang="en-US" dirty="0"/>
+              <a:t>Organizes the solution into projects or modules when helpful or where specified – but ensures that the solution decomposition is really warranted (the "challenge")</a:t>
+            </a:r>
+          </a:p>
+          <a:p>
+            <a:pPr lvl="2"/>
+            <a:endParaRPr lang="en-US" dirty="0"/>
+          </a:p>
+          <a:p>
+            <a:r>
+              <a:rPr lang="en-US" sz="2600" dirty="0"/>
+              <a:t>Run these sessions in order at the start of each project</a:t>
+            </a:r>
+          </a:p>
+          <a:p>
+            <a:r>
+              <a:rPr lang="en-US" sz="2600" dirty="0"/>
+              <a:t>Often, you will add additional sessions for additional work later</a:t>
+            </a:r>
+          </a:p>
+        </p:txBody>
+      </p:sp>
+    </p:spTree>
+    <p:extLst>
+      <p:ext uri="{BB962C8B-B14F-4D97-AF65-F5344CB8AC3E}">
+        <p14:creationId xmlns:p14="http://schemas.microsoft.com/office/powerpoint/2010/main" val="2367043460"/>
+      </p:ext>
+    </p:extLst>
+  </p:cSld>
+  <p:clrMapOvr>
+    <a:masterClrMapping/>
+  </p:clrMapOvr>
+</p:sld>
+</file>
+
+<file path=ppt/slides/slide8.xml><?xml version="1.0" encoding="utf-8"?>
+<p:sld xmlns:a="http://schemas.openxmlformats.org/drawingml/2006/main" xmlns:r="http://schemas.openxmlformats.org/officeDocument/2006/relationships" xmlns:p="http://schemas.openxmlformats.org/presentationml/2006/main">
+  <p:cSld>
+    <p:spTree>
+      <p:nvGrpSpPr>
+        <p:cNvPr id="1" name=""/>
+        <p:cNvGrpSpPr/>
+        <p:nvPr/>
+      </p:nvGrpSpPr>
+      <p:grpSpPr>
+        <a:xfrm>
+          <a:off x="0" y="0"/>
+          <a:ext cx="0" cy="0"/>
+          <a:chOff x="0" y="0"/>
+          <a:chExt cx="0" cy="0"/>
+        </a:xfrm>
+      </p:grpSpPr>
+      <p:pic>
+        <p:nvPicPr>
+          <p:cNvPr id="7" name="Picture 6">
+            <a:extLst>
+              <a:ext uri="{FF2B5EF4-FFF2-40B4-BE49-F238E27FC236}">
+                <a16:creationId xmlns:a16="http://schemas.microsoft.com/office/drawing/2014/main" id="{15F11CCF-549F-E107-D5A6-C3411B6E577A}"/>
+              </a:ext>
+            </a:extLst>
+          </p:cNvPr>
+          <p:cNvPicPr>
+            <a:picLocks noChangeAspect="1"/>
+          </p:cNvPicPr>
+          <p:nvPr/>
+        </p:nvPicPr>
+        <p:blipFill>
+          <a:blip r:embed="rId2"/>
+          <a:stretch>
+            <a:fillRect/>
+          </a:stretch>
+        </p:blipFill>
+        <p:spPr>
+          <a:xfrm>
+            <a:off x="6209970" y="2441414"/>
+            <a:ext cx="4725059" cy="2305372"/>
+          </a:xfrm>
+          <a:prstGeom prst="rect">
+            <a:avLst/>
+          </a:prstGeom>
+        </p:spPr>
+      </p:pic>
+      <p:sp>
+        <p:nvSpPr>
+          <p:cNvPr id="8" name="Title 7">
+            <a:extLst>
+              <a:ext uri="{FF2B5EF4-FFF2-40B4-BE49-F238E27FC236}">
+                <a16:creationId xmlns:a16="http://schemas.microsoft.com/office/drawing/2014/main" id="{0FEC81DB-8592-20EA-FA5D-453C781CEC43}"/>
+              </a:ext>
+            </a:extLst>
+          </p:cNvPr>
+          <p:cNvSpPr>
+            <a:spLocks noGrp="1"/>
+          </p:cNvSpPr>
+          <p:nvPr>
+            <p:ph type="title"/>
+          </p:nvPr>
+        </p:nvSpPr>
+        <p:spPr>
+          <a:xfrm>
+            <a:off x="838200" y="492126"/>
+            <a:ext cx="10515600" cy="811450"/>
+          </a:xfrm>
+        </p:spPr>
+        <p:txBody>
+          <a:bodyPr/>
+          <a:lstStyle/>
+          <a:p>
+            <a:r>
+              <a:rPr lang="en-US" i="1" dirty="0"/>
+              <a:t>Starting a Session</a:t>
+            </a:r>
+          </a:p>
+        </p:txBody>
+      </p:sp>
+      <p:sp>
+        <p:nvSpPr>
+          <p:cNvPr id="9" name="Content Placeholder 8">
+            <a:extLst>
+              <a:ext uri="{FF2B5EF4-FFF2-40B4-BE49-F238E27FC236}">
+                <a16:creationId xmlns:a16="http://schemas.microsoft.com/office/drawing/2014/main" id="{6903AD9D-3EA9-A901-13DB-6C20935CC738}"/>
+              </a:ext>
+            </a:extLst>
+          </p:cNvPr>
+          <p:cNvSpPr>
+            <a:spLocks noGrp="1"/>
+          </p:cNvSpPr>
+          <p:nvPr>
+            <p:ph idx="1"/>
+          </p:nvPr>
+        </p:nvSpPr>
+        <p:spPr>
+          <a:xfrm>
+            <a:off x="838200" y="1825625"/>
+            <a:ext cx="4635500" cy="4351338"/>
+          </a:xfrm>
+        </p:spPr>
+        <p:txBody>
+          <a:bodyPr>
+            <a:normAutofit fontScale="92500" lnSpcReduction="10000"/>
+          </a:bodyPr>
+          <a:lstStyle/>
+          <a:p>
+            <a:r>
+              <a:rPr lang="en-US" sz="2600" dirty="0"/>
+              <a:t>To start a session, right click on the next session and select "Start Session"</a:t>
+            </a:r>
+          </a:p>
+          <a:p>
+            <a:r>
+              <a:rPr lang="en-US" sz="2600" dirty="0"/>
+              <a:t>At the top of the screen, you will be prompted to confirm you AI tool and model</a:t>
+            </a:r>
+          </a:p>
+          <a:p>
+            <a:r>
+              <a:rPr lang="en-US" sz="2600" dirty="0"/>
+              <a:t>You can cancel a session by right clicking and choosing "Cancel Session"</a:t>
+            </a:r>
+          </a:p>
+          <a:p>
+            <a:r>
+              <a:rPr lang="en-US" sz="2600" dirty="0"/>
+              <a:t>You must run sessions in order, but you can have AI change to order of sessions (when you are between sessions) </a:t>
+            </a:r>
+          </a:p>
+        </p:txBody>
+      </p:sp>
+    </p:spTree>
+    <p:extLst>
+      <p:ext uri="{BB962C8B-B14F-4D97-AF65-F5344CB8AC3E}">
+        <p14:creationId xmlns:p14="http://schemas.microsoft.com/office/powerpoint/2010/main" val="1788143237"/>
+      </p:ext>
+    </p:extLst>
+  </p:cSld>
+  <p:clrMapOvr>
+    <a:masterClrMapping/>
+  </p:clrMapOvr>
+</p:sld>
+</file>
+
+<file path=ppt/slides/slide9.xml><?xml version="1.0" encoding="utf-8"?>
+<p:sld xmlns:a="http://schemas.openxmlformats.org/drawingml/2006/main" xmlns:r="http://schemas.openxmlformats.org/officeDocument/2006/relationships" xmlns:p="http://schemas.openxmlformats.org/presentationml/2006/main">
+  <p:cSld>
+    <p:spTree>
+      <p:nvGrpSpPr>
+        <p:cNvPr id="1" name=""/>
+        <p:cNvGrpSpPr/>
+        <p:nvPr/>
+      </p:nvGrpSpPr>
+      <p:grpSpPr>
+        <a:xfrm>
+          <a:off x="0" y="0"/>
+          <a:ext cx="0" cy="0"/>
+          <a:chOff x="0" y="0"/>
+          <a:chExt cx="0" cy="0"/>
+        </a:xfrm>
+      </p:grpSpPr>
+      <p:sp>
+        <p:nvSpPr>
+          <p:cNvPr id="2" name="Title 1">
+            <a:extLst>
+              <a:ext uri="{FF2B5EF4-FFF2-40B4-BE49-F238E27FC236}">
+                <a16:creationId xmlns:a16="http://schemas.microsoft.com/office/drawing/2014/main" id="{E12EF12D-46C0-5B31-F59D-6A32246E1740}"/>
+              </a:ext>
+            </a:extLst>
+          </p:cNvPr>
+          <p:cNvSpPr>
+            <a:spLocks noGrp="1"/>
+          </p:cNvSpPr>
+          <p:nvPr>
+            <p:ph type="title"/>
+          </p:nvPr>
+        </p:nvSpPr>
+        <p:spPr/>
+        <p:txBody>
+          <a:bodyPr/>
+          <a:lstStyle/>
+          <a:p>
+            <a:r>
+              <a:rPr lang="en-US" i="1" dirty="0"/>
+              <a:t>Tracking a Session</a:t>
+            </a:r>
+          </a:p>
+        </p:txBody>
+      </p:sp>
+      <p:sp>
+        <p:nvSpPr>
+          <p:cNvPr id="3" name="Content Placeholder 2">
+            <a:extLst>
+              <a:ext uri="{FF2B5EF4-FFF2-40B4-BE49-F238E27FC236}">
+                <a16:creationId xmlns:a16="http://schemas.microsoft.com/office/drawing/2014/main" id="{774329B2-A4A0-E9C8-5A88-4758282B571A}"/>
+              </a:ext>
+            </a:extLst>
+          </p:cNvPr>
+          <p:cNvSpPr>
+            <a:spLocks noGrp="1"/>
+          </p:cNvSpPr>
+          <p:nvPr>
+            <p:ph idx="1"/>
+          </p:nvPr>
+        </p:nvSpPr>
+        <p:spPr>
+          <a:xfrm>
+            <a:off x="838200" y="1825625"/>
+            <a:ext cx="4107287" cy="4351338"/>
+          </a:xfrm>
+        </p:spPr>
+        <p:txBody>
+          <a:bodyPr>
+            <a:normAutofit fontScale="92500" lnSpcReduction="10000"/>
+          </a:bodyPr>
+          <a:lstStyle/>
+          <a:p>
+            <a:r>
+              <a:rPr lang="en-US" sz="2600" dirty="0"/>
+              <a:t>When you start a session, it is labeled as "In Progress" (also called </a:t>
+            </a:r>
+            <a:r>
+              <a:rPr lang="en-US" sz="2600" i="1" dirty="0"/>
+              <a:t>in flight</a:t>
+            </a:r>
+            <a:r>
+              <a:rPr lang="en-US" sz="2600" dirty="0"/>
+              <a:t>)</a:t>
+            </a:r>
+          </a:p>
+          <a:p>
+            <a:r>
+              <a:rPr lang="en-US" sz="2600" dirty="0"/>
+              <a:t>An in-progress session displays its lifecycle phases (register, plan … etc.)</a:t>
+            </a:r>
+          </a:p>
+          <a:p>
+            <a:r>
+              <a:rPr lang="en-US" sz="2600" dirty="0"/>
+              <a:t>When the work phase starts, it displays a list of work steps.</a:t>
+            </a:r>
+          </a:p>
+          <a:p>
+            <a:r>
+              <a:rPr lang="en-US" sz="2600" dirty="0"/>
+              <a:t>When the session is done, it is moved to the "Complete" node in the Work Explorer. </a:t>
+            </a:r>
+          </a:p>
+        </p:txBody>
+      </p:sp>
+      <p:pic>
+        <p:nvPicPr>
+          <p:cNvPr id="5" name="Picture 4">
+            <a:extLst>
+              <a:ext uri="{FF2B5EF4-FFF2-40B4-BE49-F238E27FC236}">
+                <a16:creationId xmlns:a16="http://schemas.microsoft.com/office/drawing/2014/main" id="{964DD055-C21C-FB9F-F138-98D8F5693FA9}"/>
+              </a:ext>
+            </a:extLst>
+          </p:cNvPr>
+          <p:cNvPicPr>
+            <a:picLocks noChangeAspect="1"/>
+          </p:cNvPicPr>
+          <p:nvPr/>
+        </p:nvPicPr>
+        <p:blipFill>
+          <a:blip r:embed="rId2"/>
+          <a:srcRect l="4237" t="56199" r="71367" b="-182"/>
+          <a:stretch>
+            <a:fillRect/>
+          </a:stretch>
+        </p:blipFill>
+        <p:spPr>
+          <a:xfrm>
+            <a:off x="6285426" y="1690688"/>
+            <a:ext cx="4484174" cy="4372410"/>
+          </a:xfrm>
+          <a:prstGeom prst="rect">
+            <a:avLst/>
+          </a:prstGeom>
+        </p:spPr>
+      </p:pic>
+    </p:spTree>
+    <p:extLst>
+      <p:ext uri="{BB962C8B-B14F-4D97-AF65-F5344CB8AC3E}">
+        <p14:creationId xmlns:p14="http://schemas.microsoft.com/office/powerpoint/2010/main" val="3985681127"/>
       </p:ext>
     </p:extLst>
   </p:cSld>

</xml_diff>

<commit_message>
Updated PowerPoint -- Sample Planning Prompts
</commit_message>
<xml_diff>
--- a/docs/onboarding/ai-orchestration.pptx
+++ b/docs/onboarding/ai-orchestration.pptx
@@ -17,7 +17,10 @@
     <p:sldId id="265" r:id="rId11"/>
     <p:sldId id="266" r:id="rId12"/>
     <p:sldId id="267" r:id="rId13"/>
-    <p:sldId id="268" r:id="rId14"/>
+    <p:sldId id="271" r:id="rId14"/>
+    <p:sldId id="268" r:id="rId15"/>
+    <p:sldId id="269" r:id="rId16"/>
+    <p:sldId id="270" r:id="rId17"/>
   </p:sldIdLst>
   <p:sldSz cx="12192000" cy="6858000"/>
   <p:notesSz cx="6858000" cy="9144000"/>
@@ -3400,7 +3403,7 @@
           <a:p>
             <a:r>
               <a:rPr lang="en-US" dirty="0"/>
-              <a:t>Overview and Tutorial Walkthrough</a:t>
+              <a:t>An Overview with Sample Planning Prompts to Get You Started</a:t>
             </a:r>
           </a:p>
         </p:txBody>
@@ -3862,6 +3865,117 @@
         <p:cNvPr id="1" name="">
           <a:extLst>
             <a:ext uri="{FF2B5EF4-FFF2-40B4-BE49-F238E27FC236}">
+              <a16:creationId xmlns:a16="http://schemas.microsoft.com/office/drawing/2014/main" id="{363D9EBF-4A8F-FE28-69C6-0567DF064CBF}"/>
+            </a:ext>
+          </a:extLst>
+        </p:cNvPr>
+        <p:cNvGrpSpPr/>
+        <p:nvPr/>
+      </p:nvGrpSpPr>
+      <p:grpSpPr>
+        <a:xfrm>
+          <a:off x="0" y="0"/>
+          <a:ext cx="0" cy="0"/>
+          <a:chOff x="0" y="0"/>
+          <a:chExt cx="0" cy="0"/>
+        </a:xfrm>
+      </p:grpSpPr>
+      <p:sp>
+        <p:nvSpPr>
+          <p:cNvPr id="2" name="Title 1">
+            <a:extLst>
+              <a:ext uri="{FF2B5EF4-FFF2-40B4-BE49-F238E27FC236}">
+                <a16:creationId xmlns:a16="http://schemas.microsoft.com/office/drawing/2014/main" id="{3A923EA5-8B9D-1DA5-7F45-6328219F3EA9}"/>
+              </a:ext>
+            </a:extLst>
+          </p:cNvPr>
+          <p:cNvSpPr>
+            <a:spLocks noGrp="1"/>
+          </p:cNvSpPr>
+          <p:nvPr>
+            <p:ph type="title"/>
+          </p:nvPr>
+        </p:nvSpPr>
+        <p:spPr/>
+        <p:txBody>
+          <a:bodyPr/>
+          <a:lstStyle/>
+          <a:p>
+            <a:r>
+              <a:rPr lang="en-US" i="1" dirty="0"/>
+              <a:t>Additional Q&amp;A</a:t>
+            </a:r>
+            <a:endParaRPr lang="en-US" dirty="0"/>
+          </a:p>
+        </p:txBody>
+      </p:sp>
+      <p:sp>
+        <p:nvSpPr>
+          <p:cNvPr id="3" name="Content Placeholder 2">
+            <a:extLst>
+              <a:ext uri="{FF2B5EF4-FFF2-40B4-BE49-F238E27FC236}">
+                <a16:creationId xmlns:a16="http://schemas.microsoft.com/office/drawing/2014/main" id="{8D37E5C1-E167-AD45-7C59-55A30AB4188E}"/>
+              </a:ext>
+            </a:extLst>
+          </p:cNvPr>
+          <p:cNvSpPr>
+            <a:spLocks noGrp="1"/>
+          </p:cNvSpPr>
+          <p:nvPr>
+            <p:ph idx="1"/>
+          </p:nvPr>
+        </p:nvSpPr>
+        <p:spPr/>
+        <p:txBody>
+          <a:bodyPr/>
+          <a:lstStyle/>
+          <a:p>
+            <a:r>
+              <a:rPr lang="en-US" dirty="0"/>
+              <a:t>Question: </a:t>
+            </a:r>
+            <a:r>
+              <a:rPr lang="en-US" i="1" dirty="0"/>
+              <a:t>This extension seems to be tailored toward .NET and Java solutions.  Can you use it for other things?</a:t>
+            </a:r>
+            <a:br>
+              <a:rPr lang="en-US" dirty="0"/>
+            </a:br>
+            <a:endParaRPr lang="en-US" dirty="0"/>
+          </a:p>
+          <a:p>
+            <a:r>
+              <a:rPr lang="en-US" dirty="0"/>
+              <a:t>Answer: </a:t>
+            </a:r>
+            <a:r>
+              <a:rPr lang="en-US" i="1" dirty="0"/>
+              <a:t>Yes.  The framework author has used past versions of the extension for a python application, a Scheme application, multiple HTML applications, and scripts that extend the functionality of Inkscape and GIMP.  Of course, if you want special functionality that supports a particular language or framework, you can fork the repo in GitHub.</a:t>
+            </a:r>
+          </a:p>
+        </p:txBody>
+      </p:sp>
+    </p:spTree>
+    <p:extLst>
+      <p:ext uri="{BB962C8B-B14F-4D97-AF65-F5344CB8AC3E}">
+        <p14:creationId xmlns:p14="http://schemas.microsoft.com/office/powerpoint/2010/main" val="3403301188"/>
+      </p:ext>
+    </p:extLst>
+  </p:cSld>
+  <p:clrMapOvr>
+    <a:masterClrMapping/>
+  </p:clrMapOvr>
+</p:sld>
+</file>
+
+<file path=ppt/slides/slide14.xml><?xml version="1.0" encoding="utf-8"?>
+<p:sld xmlns:a="http://schemas.openxmlformats.org/drawingml/2006/main" xmlns:r="http://schemas.openxmlformats.org/officeDocument/2006/relationships" xmlns:p="http://schemas.openxmlformats.org/presentationml/2006/main">
+  <p:cSld>
+    <p:spTree>
+      <p:nvGrpSpPr>
+        <p:cNvPr id="1" name="">
+          <a:extLst>
+            <a:ext uri="{FF2B5EF4-FFF2-40B4-BE49-F238E27FC236}">
               <a16:creationId xmlns:a16="http://schemas.microsoft.com/office/drawing/2014/main" id="{9F414F7E-05FB-7173-096B-35DDA6EF93D4}"/>
             </a:ext>
           </a:extLst>
@@ -3956,6 +4070,294 @@
     <p:extLst>
       <p:ext uri="{BB962C8B-B14F-4D97-AF65-F5344CB8AC3E}">
         <p14:creationId xmlns:p14="http://schemas.microsoft.com/office/powerpoint/2010/main" val="2159532116"/>
+      </p:ext>
+    </p:extLst>
+  </p:cSld>
+  <p:clrMapOvr>
+    <a:masterClrMapping/>
+  </p:clrMapOvr>
+</p:sld>
+</file>
+
+<file path=ppt/slides/slide15.xml><?xml version="1.0" encoding="utf-8"?>
+<p:sld xmlns:a="http://schemas.openxmlformats.org/drawingml/2006/main" xmlns:r="http://schemas.openxmlformats.org/officeDocument/2006/relationships" xmlns:p="http://schemas.openxmlformats.org/presentationml/2006/main">
+  <p:cSld>
+    <p:spTree>
+      <p:nvGrpSpPr>
+        <p:cNvPr id="1" name=""/>
+        <p:cNvGrpSpPr/>
+        <p:nvPr/>
+      </p:nvGrpSpPr>
+      <p:grpSpPr>
+        <a:xfrm>
+          <a:off x="0" y="0"/>
+          <a:ext cx="0" cy="0"/>
+          <a:chOff x="0" y="0"/>
+          <a:chExt cx="0" cy="0"/>
+        </a:xfrm>
+      </p:grpSpPr>
+      <p:sp>
+        <p:nvSpPr>
+          <p:cNvPr id="2" name="Title 1">
+            <a:extLst>
+              <a:ext uri="{FF2B5EF4-FFF2-40B4-BE49-F238E27FC236}">
+                <a16:creationId xmlns:a16="http://schemas.microsoft.com/office/drawing/2014/main" id="{3CFE21C9-0750-8D03-4BFF-AAC1E5C31051}"/>
+              </a:ext>
+            </a:extLst>
+          </p:cNvPr>
+          <p:cNvSpPr>
+            <a:spLocks noGrp="1"/>
+          </p:cNvSpPr>
+          <p:nvPr>
+            <p:ph type="title"/>
+          </p:nvPr>
+        </p:nvSpPr>
+        <p:spPr/>
+        <p:txBody>
+          <a:bodyPr/>
+          <a:lstStyle/>
+          <a:p>
+            <a:r>
+              <a:rPr lang="en-US" i="1" dirty="0"/>
+              <a:t>Sample Planning Prompts – .NET </a:t>
+            </a:r>
+          </a:p>
+        </p:txBody>
+      </p:sp>
+      <p:sp>
+        <p:nvSpPr>
+          <p:cNvPr id="3" name="Content Placeholder 2">
+            <a:extLst>
+              <a:ext uri="{FF2B5EF4-FFF2-40B4-BE49-F238E27FC236}">
+                <a16:creationId xmlns:a16="http://schemas.microsoft.com/office/drawing/2014/main" id="{E92EFCE2-38A2-D601-21E8-5C6EF7FE3D3B}"/>
+              </a:ext>
+            </a:extLst>
+          </p:cNvPr>
+          <p:cNvSpPr>
+            <a:spLocks noGrp="1"/>
+          </p:cNvSpPr>
+          <p:nvPr>
+            <p:ph idx="1"/>
+          </p:nvPr>
+        </p:nvSpPr>
+        <p:spPr>
+          <a:xfrm>
+            <a:off x="838200" y="1690688"/>
+            <a:ext cx="10515600" cy="4802187"/>
+          </a:xfrm>
+        </p:spPr>
+        <p:txBody>
+          <a:bodyPr>
+            <a:normAutofit fontScale="85000" lnSpcReduction="20000"/>
+          </a:bodyPr>
+          <a:lstStyle/>
+          <a:p>
+            <a:r>
+              <a:rPr lang="en-US" dirty="0"/>
+              <a:t>If you would like to see how the extension works, follow the instructions on previous slides to set up a project, and then after you start session 001, when AI prompts you for information, enter this prompt:</a:t>
+            </a:r>
+            <a:br>
+              <a:rPr lang="en-US" dirty="0"/>
+            </a:br>
+            <a:endParaRPr lang="en-US" dirty="0"/>
+          </a:p>
+          <a:p>
+            <a:pPr marL="457200" lvl="1" indent="0">
+              <a:buNone/>
+            </a:pPr>
+            <a:r>
+              <a:rPr lang="en-US" i="1" dirty="0">
+                <a:latin typeface="Courier New" panose="02070309020205020404" pitchFamily="49" charset="0"/>
+                <a:cs typeface="Courier New" panose="02070309020205020404" pitchFamily="49" charset="0"/>
+              </a:rPr>
+              <a:t>The true purpose of this solution is to learn the Dabbler AI Orchestration platform. The exercise will take the form of a solution whose main project is a console app that reads in CSV files from a folder, deserializes the files into Person objects, persists the objects to a SQLite database using Entity Framework, and then displays all records from the database in the console.  I would like to break the project up into several projects -- a Person model library project, a </a:t>
+            </a:r>
+            <a:r>
+              <a:rPr lang="en-US" i="1" dirty="0" err="1">
+                <a:latin typeface="Courier New" panose="02070309020205020404" pitchFamily="49" charset="0"/>
+                <a:cs typeface="Courier New" panose="02070309020205020404" pitchFamily="49" charset="0"/>
+              </a:rPr>
+              <a:t>deserializer</a:t>
+            </a:r>
+            <a:r>
+              <a:rPr lang="en-US" i="1" dirty="0">
+                <a:latin typeface="Courier New" panose="02070309020205020404" pitchFamily="49" charset="0"/>
+                <a:cs typeface="Courier New" panose="02070309020205020404" pitchFamily="49" charset="0"/>
+              </a:rPr>
+              <a:t> project, a project that does the persisting to the database and the querying, and the console application.  I would like this to be a .NET 10 solution.</a:t>
+            </a:r>
+            <a:br>
+              <a:rPr lang="en-US" i="1" dirty="0">
+                <a:latin typeface="Courier New" panose="02070309020205020404" pitchFamily="49" charset="0"/>
+                <a:cs typeface="Courier New" panose="02070309020205020404" pitchFamily="49" charset="0"/>
+              </a:rPr>
+            </a:br>
+            <a:endParaRPr lang="en-US" i="1" dirty="0">
+              <a:latin typeface="Courier New" panose="02070309020205020404" pitchFamily="49" charset="0"/>
+              <a:cs typeface="Courier New" panose="02070309020205020404" pitchFamily="49" charset="0"/>
+            </a:endParaRPr>
+          </a:p>
+          <a:p>
+            <a:r>
+              <a:rPr lang="en-US" dirty="0"/>
+              <a:t>NOTE: To keep costs down, you should use less expensive models for this work – e.g., Luna, Haiku, or older versions of Flash.</a:t>
+            </a:r>
+          </a:p>
+        </p:txBody>
+      </p:sp>
+    </p:spTree>
+    <p:extLst>
+      <p:ext uri="{BB962C8B-B14F-4D97-AF65-F5344CB8AC3E}">
+        <p14:creationId xmlns:p14="http://schemas.microsoft.com/office/powerpoint/2010/main" val="1755984107"/>
+      </p:ext>
+    </p:extLst>
+  </p:cSld>
+  <p:clrMapOvr>
+    <a:masterClrMapping/>
+  </p:clrMapOvr>
+</p:sld>
+</file>
+
+<file path=ppt/slides/slide16.xml><?xml version="1.0" encoding="utf-8"?>
+<p:sld xmlns:a="http://schemas.openxmlformats.org/drawingml/2006/main" xmlns:r="http://schemas.openxmlformats.org/officeDocument/2006/relationships" xmlns:p="http://schemas.openxmlformats.org/presentationml/2006/main">
+  <p:cSld>
+    <p:spTree>
+      <p:nvGrpSpPr>
+        <p:cNvPr id="1" name="">
+          <a:extLst>
+            <a:ext uri="{FF2B5EF4-FFF2-40B4-BE49-F238E27FC236}">
+              <a16:creationId xmlns:a16="http://schemas.microsoft.com/office/drawing/2014/main" id="{7F208608-07EC-ED0B-7865-4BFD642D4A36}"/>
+            </a:ext>
+          </a:extLst>
+        </p:cNvPr>
+        <p:cNvGrpSpPr/>
+        <p:nvPr/>
+      </p:nvGrpSpPr>
+      <p:grpSpPr>
+        <a:xfrm>
+          <a:off x="0" y="0"/>
+          <a:ext cx="0" cy="0"/>
+          <a:chOff x="0" y="0"/>
+          <a:chExt cx="0" cy="0"/>
+        </a:xfrm>
+      </p:grpSpPr>
+      <p:sp>
+        <p:nvSpPr>
+          <p:cNvPr id="2" name="Title 1">
+            <a:extLst>
+              <a:ext uri="{FF2B5EF4-FFF2-40B4-BE49-F238E27FC236}">
+                <a16:creationId xmlns:a16="http://schemas.microsoft.com/office/drawing/2014/main" id="{1A84BF81-7AD6-D479-F7E2-1C95C1AC472A}"/>
+              </a:ext>
+            </a:extLst>
+          </p:cNvPr>
+          <p:cNvSpPr>
+            <a:spLocks noGrp="1"/>
+          </p:cNvSpPr>
+          <p:nvPr>
+            <p:ph type="title"/>
+          </p:nvPr>
+        </p:nvSpPr>
+        <p:spPr/>
+        <p:txBody>
+          <a:bodyPr/>
+          <a:lstStyle/>
+          <a:p>
+            <a:r>
+              <a:rPr lang="en-US" i="1"/>
+              <a:t>Sample Planning Prompts – </a:t>
+            </a:r>
+            <a:r>
+              <a:rPr lang="en-US" i="1" dirty="0"/>
+              <a:t>Java </a:t>
+            </a:r>
+          </a:p>
+        </p:txBody>
+      </p:sp>
+      <p:sp>
+        <p:nvSpPr>
+          <p:cNvPr id="3" name="Content Placeholder 2">
+            <a:extLst>
+              <a:ext uri="{FF2B5EF4-FFF2-40B4-BE49-F238E27FC236}">
+                <a16:creationId xmlns:a16="http://schemas.microsoft.com/office/drawing/2014/main" id="{23FE49B7-3D01-C731-0083-E2017F8BE3C3}"/>
+              </a:ext>
+            </a:extLst>
+          </p:cNvPr>
+          <p:cNvSpPr>
+            <a:spLocks noGrp="1"/>
+          </p:cNvSpPr>
+          <p:nvPr>
+            <p:ph idx="1"/>
+          </p:nvPr>
+        </p:nvSpPr>
+        <p:spPr>
+          <a:xfrm>
+            <a:off x="838200" y="1690688"/>
+            <a:ext cx="10515600" cy="4802187"/>
+          </a:xfrm>
+        </p:spPr>
+        <p:txBody>
+          <a:bodyPr>
+            <a:normAutofit fontScale="85000" lnSpcReduction="20000"/>
+          </a:bodyPr>
+          <a:lstStyle/>
+          <a:p>
+            <a:r>
+              <a:rPr lang="en-US" dirty="0"/>
+              <a:t>If you would like to see how the extension works, follow the instructions on previous slides to set up a project, and then after you start session 001, when AI prompts you for information, enter this prompt:</a:t>
+            </a:r>
+            <a:br>
+              <a:rPr lang="en-US" dirty="0"/>
+            </a:br>
+            <a:endParaRPr lang="en-US" dirty="0"/>
+          </a:p>
+          <a:p>
+            <a:pPr marL="457200" lvl="1" indent="0">
+              <a:buNone/>
+            </a:pPr>
+            <a:r>
+              <a:rPr lang="en-US" i="1" dirty="0">
+                <a:latin typeface="Courier New" panose="02070309020205020404" pitchFamily="49" charset="0"/>
+                <a:cs typeface="Courier New" panose="02070309020205020404" pitchFamily="49" charset="0"/>
+              </a:rPr>
+              <a:t>The true purpose of this solution is to learn the Dabbler AI Orchestration platform. The exercise will take the form of a solution whose main project is a console app that reads in CSV files from a folder, deserializes the files into Person objects, persists the objects to a SQLite database using JPA, and then displays all records from the database in the console.  I would like for the project to break the project up into several modules -- a Person model library module, a </a:t>
+            </a:r>
+            <a:r>
+              <a:rPr lang="en-US" i="1" dirty="0" err="1">
+                <a:latin typeface="Courier New" panose="02070309020205020404" pitchFamily="49" charset="0"/>
+                <a:cs typeface="Courier New" panose="02070309020205020404" pitchFamily="49" charset="0"/>
+              </a:rPr>
+              <a:t>deserializer</a:t>
+            </a:r>
+            <a:r>
+              <a:rPr lang="en-US" i="1" dirty="0">
+                <a:latin typeface="Courier New" panose="02070309020205020404" pitchFamily="49" charset="0"/>
+                <a:cs typeface="Courier New" panose="02070309020205020404" pitchFamily="49" charset="0"/>
+              </a:rPr>
+              <a:t> module, a module that does the persisting to the database and the querying, and the console application.  I would like this to be a Java Maven solution.</a:t>
+            </a:r>
+            <a:br>
+              <a:rPr lang="en-US" i="1" dirty="0">
+                <a:latin typeface="Courier New" panose="02070309020205020404" pitchFamily="49" charset="0"/>
+                <a:cs typeface="Courier New" panose="02070309020205020404" pitchFamily="49" charset="0"/>
+              </a:rPr>
+            </a:br>
+            <a:endParaRPr lang="en-US" i="1" dirty="0">
+              <a:latin typeface="Courier New" panose="02070309020205020404" pitchFamily="49" charset="0"/>
+              <a:cs typeface="Courier New" panose="02070309020205020404" pitchFamily="49" charset="0"/>
+            </a:endParaRPr>
+          </a:p>
+          <a:p>
+            <a:r>
+              <a:rPr lang="en-US" dirty="0"/>
+              <a:t>NOTE: To keep costs down, you should use less expensive models for this work – e.g., Luna, Haiku, or older versions of Flash.</a:t>
+            </a:r>
+          </a:p>
+        </p:txBody>
+      </p:sp>
+    </p:spTree>
+    <p:extLst>
+      <p:ext uri="{BB962C8B-B14F-4D97-AF65-F5344CB8AC3E}">
+        <p14:creationId xmlns:p14="http://schemas.microsoft.com/office/powerpoint/2010/main" val="482627106"/>
       </p:ext>
     </p:extLst>
   </p:cSld>

</xml_diff>

<commit_message>
Add slide to PowerPoint that addresses adding and modify sessions.
</commit_message>
<xml_diff>
--- a/docs/onboarding/ai-orchestration.pptx
+++ b/docs/onboarding/ai-orchestration.pptx
@@ -14,13 +14,14 @@
     <p:sldId id="263" r:id="rId8"/>
     <p:sldId id="262" r:id="rId9"/>
     <p:sldId id="264" r:id="rId10"/>
-    <p:sldId id="265" r:id="rId11"/>
-    <p:sldId id="266" r:id="rId12"/>
-    <p:sldId id="267" r:id="rId13"/>
-    <p:sldId id="271" r:id="rId14"/>
-    <p:sldId id="268" r:id="rId15"/>
-    <p:sldId id="269" r:id="rId16"/>
-    <p:sldId id="270" r:id="rId17"/>
+    <p:sldId id="272" r:id="rId11"/>
+    <p:sldId id="265" r:id="rId12"/>
+    <p:sldId id="266" r:id="rId13"/>
+    <p:sldId id="267" r:id="rId14"/>
+    <p:sldId id="271" r:id="rId15"/>
+    <p:sldId id="268" r:id="rId16"/>
+    <p:sldId id="269" r:id="rId17"/>
+    <p:sldId id="270" r:id="rId18"/>
   </p:sldIdLst>
   <p:sldSz cx="12192000" cy="6858000"/>
   <p:notesSz cx="6858000" cy="9144000"/>
@@ -285,7 +286,7 @@
           <a:p>
             <a:fld id="{89743378-6FBE-468B-B28B-85AEB7ADD678}" type="datetimeFigureOut">
               <a:rPr lang="en-US" smtClean="0"/>
-              <a:t>9/16/2026</a:t>
+              <a:t>9/17/2026</a:t>
             </a:fld>
             <a:endParaRPr lang="en-US"/>
           </a:p>
@@ -483,7 +484,7 @@
           <a:p>
             <a:fld id="{89743378-6FBE-468B-B28B-85AEB7ADD678}" type="datetimeFigureOut">
               <a:rPr lang="en-US" smtClean="0"/>
-              <a:t>9/16/2026</a:t>
+              <a:t>9/17/2026</a:t>
             </a:fld>
             <a:endParaRPr lang="en-US"/>
           </a:p>
@@ -691,7 +692,7 @@
           <a:p>
             <a:fld id="{89743378-6FBE-468B-B28B-85AEB7ADD678}" type="datetimeFigureOut">
               <a:rPr lang="en-US" smtClean="0"/>
-              <a:t>9/16/2026</a:t>
+              <a:t>9/17/2026</a:t>
             </a:fld>
             <a:endParaRPr lang="en-US"/>
           </a:p>
@@ -889,7 +890,7 @@
           <a:p>
             <a:fld id="{89743378-6FBE-468B-B28B-85AEB7ADD678}" type="datetimeFigureOut">
               <a:rPr lang="en-US" smtClean="0"/>
-              <a:t>9/16/2026</a:t>
+              <a:t>9/17/2026</a:t>
             </a:fld>
             <a:endParaRPr lang="en-US"/>
           </a:p>
@@ -1164,7 +1165,7 @@
           <a:p>
             <a:fld id="{89743378-6FBE-468B-B28B-85AEB7ADD678}" type="datetimeFigureOut">
               <a:rPr lang="en-US" smtClean="0"/>
-              <a:t>9/16/2026</a:t>
+              <a:t>9/17/2026</a:t>
             </a:fld>
             <a:endParaRPr lang="en-US"/>
           </a:p>
@@ -1429,7 +1430,7 @@
           <a:p>
             <a:fld id="{89743378-6FBE-468B-B28B-85AEB7ADD678}" type="datetimeFigureOut">
               <a:rPr lang="en-US" smtClean="0"/>
-              <a:t>9/16/2026</a:t>
+              <a:t>9/17/2026</a:t>
             </a:fld>
             <a:endParaRPr lang="en-US"/>
           </a:p>
@@ -1841,7 +1842,7 @@
           <a:p>
             <a:fld id="{89743378-6FBE-468B-B28B-85AEB7ADD678}" type="datetimeFigureOut">
               <a:rPr lang="en-US" smtClean="0"/>
-              <a:t>9/16/2026</a:t>
+              <a:t>9/17/2026</a:t>
             </a:fld>
             <a:endParaRPr lang="en-US"/>
           </a:p>
@@ -1982,7 +1983,7 @@
           <a:p>
             <a:fld id="{89743378-6FBE-468B-B28B-85AEB7ADD678}" type="datetimeFigureOut">
               <a:rPr lang="en-US" smtClean="0"/>
-              <a:t>9/16/2026</a:t>
+              <a:t>9/17/2026</a:t>
             </a:fld>
             <a:endParaRPr lang="en-US"/>
           </a:p>
@@ -2095,7 +2096,7 @@
           <a:p>
             <a:fld id="{89743378-6FBE-468B-B28B-85AEB7ADD678}" type="datetimeFigureOut">
               <a:rPr lang="en-US" smtClean="0"/>
-              <a:t>9/16/2026</a:t>
+              <a:t>9/17/2026</a:t>
             </a:fld>
             <a:endParaRPr lang="en-US"/>
           </a:p>
@@ -2406,7 +2407,7 @@
           <a:p>
             <a:fld id="{89743378-6FBE-468B-B28B-85AEB7ADD678}" type="datetimeFigureOut">
               <a:rPr lang="en-US" smtClean="0"/>
-              <a:t>9/16/2026</a:t>
+              <a:t>9/17/2026</a:t>
             </a:fld>
             <a:endParaRPr lang="en-US"/>
           </a:p>
@@ -2694,7 +2695,7 @@
           <a:p>
             <a:fld id="{89743378-6FBE-468B-B28B-85AEB7ADD678}" type="datetimeFigureOut">
               <a:rPr lang="en-US" smtClean="0"/>
-              <a:t>9/16/2026</a:t>
+              <a:t>9/17/2026</a:t>
             </a:fld>
             <a:endParaRPr lang="en-US"/>
           </a:p>
@@ -2935,7 +2936,7 @@
           <a:p>
             <a:fld id="{89743378-6FBE-468B-B28B-85AEB7ADD678}" type="datetimeFigureOut">
               <a:rPr lang="en-US" smtClean="0"/>
-              <a:t>9/16/2026</a:t>
+              <a:t>9/17/2026</a:t>
             </a:fld>
             <a:endParaRPr lang="en-US"/>
           </a:p>
@@ -3443,7 +3444,7 @@
           <p:cNvPr id="2" name="Title 1">
             <a:extLst>
               <a:ext uri="{FF2B5EF4-FFF2-40B4-BE49-F238E27FC236}">
-                <a16:creationId xmlns:a16="http://schemas.microsoft.com/office/drawing/2014/main" id="{010905FE-C604-2F18-A693-B41F8D012592}"/>
+                <a16:creationId xmlns:a16="http://schemas.microsoft.com/office/drawing/2014/main" id="{6EE03DDD-90E2-7813-A529-5EEC6DABDB00}"/>
               </a:ext>
             </a:extLst>
           </p:cNvPr>
@@ -3454,19 +3455,14 @@
             <p:ph type="title"/>
           </p:nvPr>
         </p:nvSpPr>
-        <p:spPr>
-          <a:xfrm>
-            <a:off x="838200" y="365125"/>
-            <a:ext cx="10515600" cy="1082675"/>
-          </a:xfrm>
-        </p:spPr>
+        <p:spPr/>
         <p:txBody>
           <a:bodyPr/>
           <a:lstStyle/>
           <a:p>
             <a:r>
-              <a:rPr lang="en-US" i="1" dirty="0"/>
-              <a:t>System Files</a:t>
+              <a:rPr lang="en-US" dirty="0"/>
+              <a:t>Adding or Modifying Sessions</a:t>
             </a:r>
           </a:p>
         </p:txBody>
@@ -3476,7 +3472,7 @@
           <p:cNvPr id="3" name="Content Placeholder 2">
             <a:extLst>
               <a:ext uri="{FF2B5EF4-FFF2-40B4-BE49-F238E27FC236}">
-                <a16:creationId xmlns:a16="http://schemas.microsoft.com/office/drawing/2014/main" id="{A0625F5A-0612-85A4-A86A-3A806DC4216E}"/>
+                <a16:creationId xmlns:a16="http://schemas.microsoft.com/office/drawing/2014/main" id="{9678E180-5917-A17E-300B-A48ED127B515}"/>
               </a:ext>
             </a:extLst>
           </p:cNvPr>
@@ -3487,148 +3483,81 @@
             <p:ph idx="1"/>
           </p:nvPr>
         </p:nvSpPr>
-        <p:spPr>
-          <a:xfrm>
-            <a:off x="838200" y="1690688"/>
-            <a:ext cx="10515600" cy="4486275"/>
-          </a:xfrm>
-        </p:spPr>
+        <p:spPr/>
         <p:txBody>
           <a:bodyPr>
-            <a:normAutofit fontScale="92500" lnSpcReduction="10000"/>
+            <a:normAutofit/>
           </a:bodyPr>
           <a:lstStyle/>
           <a:p>
             <a:r>
+              <a:rPr lang="en-US" sz="2400" dirty="0"/>
+              <a:t>The initial set of session may get you over the finish line, but more often you eventually will need to add new sessions and modify existing sessions.</a:t>
+            </a:r>
+            <a:br>
+              <a:rPr lang="en-US" sz="2400" dirty="0"/>
+            </a:br>
+            <a:endParaRPr lang="en-US" sz="2400" dirty="0"/>
+          </a:p>
+          <a:p>
+            <a:r>
+              <a:rPr lang="en-US" sz="2400" dirty="0"/>
+              <a:t>There are two ways to do this:</a:t>
+            </a:r>
+          </a:p>
+          <a:p>
+            <a:pPr marL="914400" lvl="1" indent="-457200">
+              <a:buFont typeface="+mj-lt"/>
+              <a:buAutoNum type="arabicPeriod"/>
+            </a:pPr>
+            <a:r>
+              <a:rPr lang="en-US" sz="2200" dirty="0"/>
+              <a:t>"Consult with AI"</a:t>
+            </a:r>
+          </a:p>
+          <a:p>
+            <a:pPr lvl="2"/>
+            <a:r>
               <a:rPr lang="en-US" dirty="0"/>
-              <a:t>The extension (sometimes called "framework") uses files to govern its work.  </a:t>
-            </a:r>
-          </a:p>
-          <a:p>
+              <a:t>Available in the Work Explorer by right-clicking on the solution name or a session</a:t>
+            </a:r>
+          </a:p>
+          <a:p>
+            <a:pPr lvl="2"/>
             <a:r>
               <a:rPr lang="en-US" dirty="0"/>
-              <a:t>Do not directly edit anything in the .dabbler directory, nor the session-plan.md file, as these have special formats.</a:t>
-            </a:r>
-          </a:p>
-          <a:p>
+              <a:t>Allows you to choose an AI model</a:t>
+            </a:r>
+          </a:p>
+          <a:p>
+            <a:pPr lvl="2"/>
             <a:r>
               <a:rPr lang="en-US" dirty="0"/>
-              <a:t>Here are some of the important system files:</a:t>
-            </a:r>
-          </a:p>
-          <a:p>
-            <a:pPr lvl="1"/>
-            <a:r>
-              <a:rPr lang="en-US" b="1" u="sng" dirty="0">
-                <a:solidFill>
-                  <a:srgbClr val="0070C0"/>
-                </a:solidFill>
-              </a:rPr>
-              <a:t>docs\planning\solution-plan.md</a:t>
-            </a:r>
+              <a:t>Automatically commits/pushes modified plans</a:t>
+            </a:r>
+          </a:p>
+          <a:p>
+            <a:pPr marL="914400" lvl="1" indent="-457200">
+              <a:buFont typeface="+mj-lt"/>
+              <a:buAutoNum type="arabicPeriod"/>
+            </a:pPr>
+            <a:r>
+              <a:rPr lang="en-US" sz="2200" dirty="0"/>
+              <a:t>Ad Hoc AI Chat Window</a:t>
+            </a:r>
+          </a:p>
+          <a:p>
+            <a:pPr lvl="2"/>
             <a:r>
               <a:rPr lang="en-US" dirty="0"/>
-              <a:t> – the overall solution plan</a:t>
-            </a:r>
-            <a:endParaRPr lang="en-US" b="1" u="sng" dirty="0">
-              <a:solidFill>
-                <a:srgbClr val="0070C0"/>
-              </a:solidFill>
-            </a:endParaRPr>
-          </a:p>
-          <a:p>
-            <a:pPr lvl="1"/>
-            <a:r>
-              <a:rPr lang="en-US" b="1" u="sng" dirty="0">
-                <a:solidFill>
-                  <a:srgbClr val="0070C0"/>
-                </a:solidFill>
-              </a:rPr>
-              <a:t>docs\sessions\session-plan.md</a:t>
-            </a:r>
+              <a:t>Use Visual Studio Code to fire up an independent AI chat instance</a:t>
+            </a:r>
+          </a:p>
+          <a:p>
+            <a:pPr lvl="2"/>
             <a:r>
               <a:rPr lang="en-US" dirty="0"/>
-              <a:t> – the session-specific plan</a:t>
-            </a:r>
-          </a:p>
-          <a:p>
-            <a:pPr lvl="1"/>
-            <a:r>
-              <a:rPr lang="en-US" b="1" u="sng" dirty="0">
-                <a:solidFill>
-                  <a:srgbClr val="0070C0"/>
-                </a:solidFill>
-              </a:rPr>
-              <a:t>.dabbler\solution\</a:t>
-            </a:r>
-            <a:r>
-              <a:rPr lang="en-US" b="1" u="sng" dirty="0" err="1">
-                <a:solidFill>
-                  <a:srgbClr val="0070C0"/>
-                </a:solidFill>
-              </a:rPr>
-              <a:t>solution.json</a:t>
-            </a:r>
-            <a:r>
-              <a:rPr lang="en-US" dirty="0"/>
-              <a:t> – the organization of the solution into projects or modules (if any)</a:t>
-            </a:r>
-          </a:p>
-          <a:p>
-            <a:pPr lvl="1"/>
-            <a:r>
-              <a:rPr lang="en-US" b="1" u="sng" dirty="0">
-                <a:solidFill>
-                  <a:srgbClr val="0070C0"/>
-                </a:solidFill>
-              </a:rPr>
-              <a:t>.dabbler\...\</a:t>
-            </a:r>
-            <a:r>
-              <a:rPr lang="en-US" b="1" u="sng" dirty="0" err="1">
-                <a:solidFill>
-                  <a:srgbClr val="0070C0"/>
-                </a:solidFill>
-              </a:rPr>
-              <a:t>instruction.json</a:t>
-            </a:r>
-            <a:r>
-              <a:rPr lang="en-US" u="sng" dirty="0"/>
-              <a:t> </a:t>
-            </a:r>
-            <a:r>
-              <a:rPr lang="en-US" dirty="0"/>
-              <a:t>– a shared file between the extension and AI that allows coordination of work</a:t>
-            </a:r>
-          </a:p>
-          <a:p>
-            <a:pPr lvl="1"/>
-            <a:r>
-              <a:rPr lang="en-US" b="1" dirty="0" err="1">
-                <a:solidFill>
-                  <a:srgbClr val="0070C0"/>
-                </a:solidFill>
-              </a:rPr>
-              <a:t>dabbler.yaml</a:t>
-            </a:r>
-            <a:r>
-              <a:rPr lang="en-US" dirty="0"/>
-              <a:t> – defines testing and solution packaging</a:t>
-            </a:r>
-          </a:p>
-          <a:p>
-            <a:pPr lvl="1"/>
-            <a:r>
-              <a:rPr lang="en-US" b="1" u="sng" dirty="0">
-                <a:solidFill>
-                  <a:srgbClr val="0070C0"/>
-                </a:solidFill>
-              </a:rPr>
-              <a:t>AGENTS.md, CLAUDE.me</a:t>
-            </a:r>
-            <a:r>
-              <a:rPr lang="en-US" dirty="0"/>
-              <a:t> – initial instruction files for AI models.</a:t>
+              <a:t>This is out-of-band, so be careful how you do this if another session is running. (Tell AI  to wait until the in-flight session lands before making any changes to files.)</a:t>
             </a:r>
           </a:p>
         </p:txBody>
@@ -3636,7 +3565,7 @@
     </p:spTree>
     <p:extLst>
       <p:ext uri="{BB962C8B-B14F-4D97-AF65-F5344CB8AC3E}">
-        <p14:creationId xmlns:p14="http://schemas.microsoft.com/office/powerpoint/2010/main" val="229979975"/>
+        <p14:creationId xmlns:p14="http://schemas.microsoft.com/office/powerpoint/2010/main" val="439382176"/>
       </p:ext>
     </p:extLst>
   </p:cSld>
@@ -3668,7 +3597,7 @@
           <p:cNvPr id="2" name="Title 1">
             <a:extLst>
               <a:ext uri="{FF2B5EF4-FFF2-40B4-BE49-F238E27FC236}">
-                <a16:creationId xmlns:a16="http://schemas.microsoft.com/office/drawing/2014/main" id="{5BD1EF6E-CEFB-2608-C538-1FE9724AD32C}"/>
+                <a16:creationId xmlns:a16="http://schemas.microsoft.com/office/drawing/2014/main" id="{010905FE-C604-2F18-A693-B41F8D012592}"/>
               </a:ext>
             </a:extLst>
           </p:cNvPr>
@@ -3679,14 +3608,19 @@
             <p:ph type="title"/>
           </p:nvPr>
         </p:nvSpPr>
-        <p:spPr/>
+        <p:spPr>
+          <a:xfrm>
+            <a:off x="838200" y="365125"/>
+            <a:ext cx="10515600" cy="1082675"/>
+          </a:xfrm>
+        </p:spPr>
         <p:txBody>
           <a:bodyPr/>
           <a:lstStyle/>
           <a:p>
             <a:r>
               <a:rPr lang="en-US" i="1" dirty="0"/>
-              <a:t>Additional Q&amp;A</a:t>
+              <a:t>System Files</a:t>
             </a:r>
           </a:p>
         </p:txBody>
@@ -3696,7 +3630,7 @@
           <p:cNvPr id="3" name="Content Placeholder 2">
             <a:extLst>
               <a:ext uri="{FF2B5EF4-FFF2-40B4-BE49-F238E27FC236}">
-                <a16:creationId xmlns:a16="http://schemas.microsoft.com/office/drawing/2014/main" id="{B3AC8D0A-1B14-C3C2-79B3-89E560244202}"/>
+                <a16:creationId xmlns:a16="http://schemas.microsoft.com/office/drawing/2014/main" id="{A0625F5A-0612-85A4-A86A-3A806DC4216E}"/>
               </a:ext>
             </a:extLst>
           </p:cNvPr>
@@ -3707,34 +3641,148 @@
             <p:ph idx="1"/>
           </p:nvPr>
         </p:nvSpPr>
-        <p:spPr/>
+        <p:spPr>
+          <a:xfrm>
+            <a:off x="838200" y="1690688"/>
+            <a:ext cx="10515600" cy="4486275"/>
+          </a:xfrm>
+        </p:spPr>
         <p:txBody>
           <a:bodyPr>
-            <a:normAutofit/>
+            <a:normAutofit fontScale="92500" lnSpcReduction="10000"/>
           </a:bodyPr>
           <a:lstStyle/>
           <a:p>
             <a:r>
               <a:rPr lang="en-US" dirty="0"/>
-              <a:t>Question: </a:t>
-            </a:r>
-            <a:r>
-              <a:rPr lang="en-US" i="1" dirty="0"/>
-              <a:t>This is an open-source extension developed by one person.  Isn't that risky?</a:t>
-            </a:r>
-            <a:br>
+              <a:t>The extension (sometimes called "framework") uses files to govern its work.  </a:t>
+            </a:r>
+          </a:p>
+          <a:p>
+            <a:r>
               <a:rPr lang="en-US" dirty="0"/>
-            </a:br>
-            <a:endParaRPr lang="en-US" dirty="0"/>
+              <a:t>Do not directly edit anything in the .dabbler directory, nor the session-plan.md file, as these have special formats.</a:t>
+            </a:r>
           </a:p>
           <a:p>
             <a:r>
               <a:rPr lang="en-US" dirty="0"/>
-              <a:t>Answer: </a:t>
-            </a:r>
-            <a:r>
-              <a:rPr lang="en-US" i="1" dirty="0"/>
-              <a:t>It is less risky than many open-source extensions because, in reality, it is written by AI and maintained by AI.  Anyone with access to AI can fix or enhance the solution.  Being a developer helps, but you don't have to know anything about AI or TypeScript or Visual Studio Code Extension programming. </a:t>
+              <a:t>Here are some of the important system files:</a:t>
+            </a:r>
+          </a:p>
+          <a:p>
+            <a:pPr lvl="1"/>
+            <a:r>
+              <a:rPr lang="en-US" b="1" u="sng" dirty="0">
+                <a:solidFill>
+                  <a:srgbClr val="0070C0"/>
+                </a:solidFill>
+              </a:rPr>
+              <a:t>docs\planning\solution-plan.md</a:t>
+            </a:r>
+            <a:r>
+              <a:rPr lang="en-US" dirty="0"/>
+              <a:t> – the overall solution plan</a:t>
+            </a:r>
+            <a:endParaRPr lang="en-US" b="1" u="sng" dirty="0">
+              <a:solidFill>
+                <a:srgbClr val="0070C0"/>
+              </a:solidFill>
+            </a:endParaRPr>
+          </a:p>
+          <a:p>
+            <a:pPr lvl="1"/>
+            <a:r>
+              <a:rPr lang="en-US" b="1" u="sng" dirty="0">
+                <a:solidFill>
+                  <a:srgbClr val="0070C0"/>
+                </a:solidFill>
+              </a:rPr>
+              <a:t>docs\sessions\session-plan.md</a:t>
+            </a:r>
+            <a:r>
+              <a:rPr lang="en-US" dirty="0"/>
+              <a:t> – the session-specific plan</a:t>
+            </a:r>
+          </a:p>
+          <a:p>
+            <a:pPr lvl="1"/>
+            <a:r>
+              <a:rPr lang="en-US" b="1" u="sng" dirty="0">
+                <a:solidFill>
+                  <a:srgbClr val="0070C0"/>
+                </a:solidFill>
+              </a:rPr>
+              <a:t>.dabbler\solution\</a:t>
+            </a:r>
+            <a:r>
+              <a:rPr lang="en-US" b="1" u="sng" dirty="0" err="1">
+                <a:solidFill>
+                  <a:srgbClr val="0070C0"/>
+                </a:solidFill>
+              </a:rPr>
+              <a:t>solution.json</a:t>
+            </a:r>
+            <a:r>
+              <a:rPr lang="en-US" dirty="0"/>
+              <a:t> – the organization of the solution into projects or modules (if any)</a:t>
+            </a:r>
+          </a:p>
+          <a:p>
+            <a:pPr lvl="1"/>
+            <a:r>
+              <a:rPr lang="en-US" b="1" u="sng" dirty="0">
+                <a:solidFill>
+                  <a:srgbClr val="0070C0"/>
+                </a:solidFill>
+              </a:rPr>
+              <a:t>.dabbler\...\</a:t>
+            </a:r>
+            <a:r>
+              <a:rPr lang="en-US" b="1" u="sng" dirty="0" err="1">
+                <a:solidFill>
+                  <a:srgbClr val="0070C0"/>
+                </a:solidFill>
+              </a:rPr>
+              <a:t>instruction.json</a:t>
+            </a:r>
+            <a:r>
+              <a:rPr lang="en-US" u="sng" dirty="0"/>
+              <a:t> </a:t>
+            </a:r>
+            <a:r>
+              <a:rPr lang="en-US" dirty="0"/>
+              <a:t>– a shared file between the extension and AI that allows coordination of work</a:t>
+            </a:r>
+          </a:p>
+          <a:p>
+            <a:pPr lvl="1"/>
+            <a:r>
+              <a:rPr lang="en-US" b="1" dirty="0" err="1">
+                <a:solidFill>
+                  <a:srgbClr val="0070C0"/>
+                </a:solidFill>
+              </a:rPr>
+              <a:t>dabbler.yaml</a:t>
+            </a:r>
+            <a:r>
+              <a:rPr lang="en-US" dirty="0"/>
+              <a:t> – defines testing and solution packaging</a:t>
+            </a:r>
+          </a:p>
+          <a:p>
+            <a:pPr lvl="1"/>
+            <a:r>
+              <a:rPr lang="en-US" b="1" u="sng" dirty="0">
+                <a:solidFill>
+                  <a:srgbClr val="0070C0"/>
+                </a:solidFill>
+              </a:rPr>
+              <a:t>AGENTS.md, CLAUDE.me</a:t>
+            </a:r>
+            <a:r>
+              <a:rPr lang="en-US" dirty="0"/>
+              <a:t> – initial instruction files for AI models.</a:t>
             </a:r>
           </a:p>
         </p:txBody>
@@ -3742,7 +3790,7 @@
     </p:spTree>
     <p:extLst>
       <p:ext uri="{BB962C8B-B14F-4D97-AF65-F5344CB8AC3E}">
-        <p14:creationId xmlns:p14="http://schemas.microsoft.com/office/powerpoint/2010/main" val="3540892354"/>
+        <p14:creationId xmlns:p14="http://schemas.microsoft.com/office/powerpoint/2010/main" val="229979975"/>
       </p:ext>
     </p:extLst>
   </p:cSld>
@@ -3774,6 +3822,112 @@
           <p:cNvPr id="2" name="Title 1">
             <a:extLst>
               <a:ext uri="{FF2B5EF4-FFF2-40B4-BE49-F238E27FC236}">
+                <a16:creationId xmlns:a16="http://schemas.microsoft.com/office/drawing/2014/main" id="{5BD1EF6E-CEFB-2608-C538-1FE9724AD32C}"/>
+              </a:ext>
+            </a:extLst>
+          </p:cNvPr>
+          <p:cNvSpPr>
+            <a:spLocks noGrp="1"/>
+          </p:cNvSpPr>
+          <p:nvPr>
+            <p:ph type="title"/>
+          </p:nvPr>
+        </p:nvSpPr>
+        <p:spPr/>
+        <p:txBody>
+          <a:bodyPr/>
+          <a:lstStyle/>
+          <a:p>
+            <a:r>
+              <a:rPr lang="en-US" i="1" dirty="0"/>
+              <a:t>Additional Q&amp;A</a:t>
+            </a:r>
+          </a:p>
+        </p:txBody>
+      </p:sp>
+      <p:sp>
+        <p:nvSpPr>
+          <p:cNvPr id="3" name="Content Placeholder 2">
+            <a:extLst>
+              <a:ext uri="{FF2B5EF4-FFF2-40B4-BE49-F238E27FC236}">
+                <a16:creationId xmlns:a16="http://schemas.microsoft.com/office/drawing/2014/main" id="{B3AC8D0A-1B14-C3C2-79B3-89E560244202}"/>
+              </a:ext>
+            </a:extLst>
+          </p:cNvPr>
+          <p:cNvSpPr>
+            <a:spLocks noGrp="1"/>
+          </p:cNvSpPr>
+          <p:nvPr>
+            <p:ph idx="1"/>
+          </p:nvPr>
+        </p:nvSpPr>
+        <p:spPr/>
+        <p:txBody>
+          <a:bodyPr>
+            <a:normAutofit/>
+          </a:bodyPr>
+          <a:lstStyle/>
+          <a:p>
+            <a:r>
+              <a:rPr lang="en-US" dirty="0"/>
+              <a:t>Question: </a:t>
+            </a:r>
+            <a:r>
+              <a:rPr lang="en-US" i="1" dirty="0"/>
+              <a:t>This is an open-source extension developed by one person.  Isn't that risky?</a:t>
+            </a:r>
+            <a:br>
+              <a:rPr lang="en-US" dirty="0"/>
+            </a:br>
+            <a:endParaRPr lang="en-US" dirty="0"/>
+          </a:p>
+          <a:p>
+            <a:r>
+              <a:rPr lang="en-US" dirty="0"/>
+              <a:t>Answer: </a:t>
+            </a:r>
+            <a:r>
+              <a:rPr lang="en-US" i="1" dirty="0"/>
+              <a:t>It is less risky than many open-source extensions because, in reality, it is written by AI and maintained by AI.  Anyone with access to AI can fix or enhance the solution.  Being a developer helps, but you don't have to know anything about AI or TypeScript or Visual Studio Code Extension programming. </a:t>
+            </a:r>
+          </a:p>
+        </p:txBody>
+      </p:sp>
+    </p:spTree>
+    <p:extLst>
+      <p:ext uri="{BB962C8B-B14F-4D97-AF65-F5344CB8AC3E}">
+        <p14:creationId xmlns:p14="http://schemas.microsoft.com/office/powerpoint/2010/main" val="3540892354"/>
+      </p:ext>
+    </p:extLst>
+  </p:cSld>
+  <p:clrMapOvr>
+    <a:masterClrMapping/>
+  </p:clrMapOvr>
+</p:sld>
+</file>
+
+<file path=ppt/slides/slide13.xml><?xml version="1.0" encoding="utf-8"?>
+<p:sld xmlns:a="http://schemas.openxmlformats.org/drawingml/2006/main" xmlns:r="http://schemas.openxmlformats.org/officeDocument/2006/relationships" xmlns:p="http://schemas.openxmlformats.org/presentationml/2006/main">
+  <p:cSld>
+    <p:spTree>
+      <p:nvGrpSpPr>
+        <p:cNvPr id="1" name=""/>
+        <p:cNvGrpSpPr/>
+        <p:nvPr/>
+      </p:nvGrpSpPr>
+      <p:grpSpPr>
+        <a:xfrm>
+          <a:off x="0" y="0"/>
+          <a:ext cx="0" cy="0"/>
+          <a:chOff x="0" y="0"/>
+          <a:chExt cx="0" cy="0"/>
+        </a:xfrm>
+      </p:grpSpPr>
+      <p:sp>
+        <p:nvSpPr>
+          <p:cNvPr id="2" name="Title 1">
+            <a:extLst>
+              <a:ext uri="{FF2B5EF4-FFF2-40B4-BE49-F238E27FC236}">
                 <a16:creationId xmlns:a16="http://schemas.microsoft.com/office/drawing/2014/main" id="{B5AC1AB3-0EAE-BCD9-7654-8CC37159596D}"/>
               </a:ext>
             </a:extLst>
@@ -3857,7 +4011,7 @@
 </p:sld>
 </file>
 
-<file path=ppt/slides/slide13.xml><?xml version="1.0" encoding="utf-8"?>
+<file path=ppt/slides/slide14.xml><?xml version="1.0" encoding="utf-8"?>
 <p:sld xmlns:a="http://schemas.openxmlformats.org/drawingml/2006/main" xmlns:r="http://schemas.openxmlformats.org/officeDocument/2006/relationships" xmlns:p="http://schemas.openxmlformats.org/presentationml/2006/main">
   <p:cSld>
     <p:spTree>
@@ -3968,7 +4122,7 @@
 </p:sld>
 </file>
 
-<file path=ppt/slides/slide14.xml><?xml version="1.0" encoding="utf-8"?>
+<file path=ppt/slides/slide15.xml><?xml version="1.0" encoding="utf-8"?>
 <p:sld xmlns:a="http://schemas.openxmlformats.org/drawingml/2006/main" xmlns:r="http://schemas.openxmlformats.org/officeDocument/2006/relationships" xmlns:p="http://schemas.openxmlformats.org/presentationml/2006/main">
   <p:cSld>
     <p:spTree>
@@ -4079,7 +4233,7 @@
 </p:sld>
 </file>
 
-<file path=ppt/slides/slide15.xml><?xml version="1.0" encoding="utf-8"?>
+<file path=ppt/slides/slide16.xml><?xml version="1.0" encoding="utf-8"?>
 <p:sld xmlns:a="http://schemas.openxmlformats.org/drawingml/2006/main" xmlns:r="http://schemas.openxmlformats.org/officeDocument/2006/relationships" xmlns:p="http://schemas.openxmlformats.org/presentationml/2006/main">
   <p:cSld>
     <p:spTree>
@@ -4218,7 +4372,7 @@
 </p:sld>
 </file>
 
-<file path=ppt/slides/slide16.xml><?xml version="1.0" encoding="utf-8"?>
+<file path=ppt/slides/slide17.xml><?xml version="1.0" encoding="utf-8"?>
 <p:sld xmlns:a="http://schemas.openxmlformats.org/drawingml/2006/main" xmlns:r="http://schemas.openxmlformats.org/officeDocument/2006/relationships" xmlns:p="http://schemas.openxmlformats.org/presentationml/2006/main">
   <p:cSld>
     <p:spTree>

</xml_diff>

<commit_message>
Update PowerPoint to address configuration
</commit_message>
<xml_diff>
--- a/docs/onboarding/ai-orchestration.pptx
+++ b/docs/onboarding/ai-orchestration.pptx
@@ -10,18 +10,19 @@
     <p:sldId id="258" r:id="rId4"/>
     <p:sldId id="259" r:id="rId5"/>
     <p:sldId id="260" r:id="rId6"/>
-    <p:sldId id="261" r:id="rId7"/>
-    <p:sldId id="263" r:id="rId8"/>
-    <p:sldId id="262" r:id="rId9"/>
-    <p:sldId id="264" r:id="rId10"/>
-    <p:sldId id="272" r:id="rId11"/>
-    <p:sldId id="265" r:id="rId12"/>
-    <p:sldId id="266" r:id="rId13"/>
-    <p:sldId id="267" r:id="rId14"/>
-    <p:sldId id="271" r:id="rId15"/>
-    <p:sldId id="268" r:id="rId16"/>
-    <p:sldId id="269" r:id="rId17"/>
-    <p:sldId id="270" r:id="rId18"/>
+    <p:sldId id="273" r:id="rId7"/>
+    <p:sldId id="261" r:id="rId8"/>
+    <p:sldId id="263" r:id="rId9"/>
+    <p:sldId id="262" r:id="rId10"/>
+    <p:sldId id="264" r:id="rId11"/>
+    <p:sldId id="272" r:id="rId12"/>
+    <p:sldId id="265" r:id="rId13"/>
+    <p:sldId id="266" r:id="rId14"/>
+    <p:sldId id="267" r:id="rId15"/>
+    <p:sldId id="271" r:id="rId16"/>
+    <p:sldId id="268" r:id="rId17"/>
+    <p:sldId id="269" r:id="rId18"/>
+    <p:sldId id="270" r:id="rId19"/>
   </p:sldIdLst>
   <p:sldSz cx="12192000" cy="6858000"/>
   <p:notesSz cx="6858000" cy="9144000"/>
@@ -3444,7 +3445,7 @@
           <p:cNvPr id="2" name="Title 1">
             <a:extLst>
               <a:ext uri="{FF2B5EF4-FFF2-40B4-BE49-F238E27FC236}">
-                <a16:creationId xmlns:a16="http://schemas.microsoft.com/office/drawing/2014/main" id="{6EE03DDD-90E2-7813-A529-5EEC6DABDB00}"/>
+                <a16:creationId xmlns:a16="http://schemas.microsoft.com/office/drawing/2014/main" id="{E12EF12D-46C0-5B31-F59D-6A32246E1740}"/>
               </a:ext>
             </a:extLst>
           </p:cNvPr>
@@ -3461,8 +3462,8 @@
           <a:lstStyle/>
           <a:p>
             <a:r>
-              <a:rPr lang="en-US" dirty="0"/>
-              <a:t>Adding or Modifying Sessions</a:t>
+              <a:rPr lang="en-US" i="1" dirty="0"/>
+              <a:t>Tracking a Session</a:t>
             </a:r>
           </a:p>
         </p:txBody>
@@ -3472,7 +3473,7 @@
           <p:cNvPr id="3" name="Content Placeholder 2">
             <a:extLst>
               <a:ext uri="{FF2B5EF4-FFF2-40B4-BE49-F238E27FC236}">
-                <a16:creationId xmlns:a16="http://schemas.microsoft.com/office/drawing/2014/main" id="{9678E180-5917-A17E-300B-A48ED127B515}"/>
+                <a16:creationId xmlns:a16="http://schemas.microsoft.com/office/drawing/2014/main" id="{774329B2-A4A0-E9C8-5A88-4758282B571A}"/>
               </a:ext>
             </a:extLst>
           </p:cNvPr>
@@ -3483,89 +3484,86 @@
             <p:ph idx="1"/>
           </p:nvPr>
         </p:nvSpPr>
-        <p:spPr/>
+        <p:spPr>
+          <a:xfrm>
+            <a:off x="838200" y="1825625"/>
+            <a:ext cx="4107287" cy="4351338"/>
+          </a:xfrm>
+        </p:spPr>
         <p:txBody>
           <a:bodyPr>
-            <a:normAutofit/>
+            <a:normAutofit fontScale="92500" lnSpcReduction="10000"/>
           </a:bodyPr>
           <a:lstStyle/>
           <a:p>
             <a:r>
-              <a:rPr lang="en-US" sz="2400" dirty="0"/>
-              <a:t>The initial set of session may get you over the finish line, but more often you eventually will need to add new sessions and modify existing sessions.</a:t>
-            </a:r>
-            <a:br>
-              <a:rPr lang="en-US" sz="2400" dirty="0"/>
-            </a:br>
-            <a:endParaRPr lang="en-US" sz="2400" dirty="0"/>
-          </a:p>
-          <a:p>
-            <a:r>
-              <a:rPr lang="en-US" sz="2400" dirty="0"/>
-              <a:t>There are two ways to do this:</a:t>
-            </a:r>
-          </a:p>
-          <a:p>
-            <a:pPr marL="914400" lvl="1" indent="-457200">
-              <a:buFont typeface="+mj-lt"/>
-              <a:buAutoNum type="arabicPeriod"/>
-            </a:pPr>
-            <a:r>
-              <a:rPr lang="en-US" sz="2200" dirty="0"/>
-              <a:t>"Consult with AI"</a:t>
-            </a:r>
-          </a:p>
-          <a:p>
-            <a:pPr lvl="2"/>
-            <a:r>
-              <a:rPr lang="en-US" dirty="0"/>
-              <a:t>Available in the Work Explorer by right-clicking on the solution name or a session</a:t>
-            </a:r>
-          </a:p>
-          <a:p>
-            <a:pPr lvl="2"/>
-            <a:r>
-              <a:rPr lang="en-US" dirty="0"/>
-              <a:t>Allows you to choose an AI model</a:t>
-            </a:r>
-          </a:p>
-          <a:p>
-            <a:pPr lvl="2"/>
-            <a:r>
-              <a:rPr lang="en-US" dirty="0"/>
-              <a:t>Automatically commits/pushes modified plans</a:t>
-            </a:r>
-          </a:p>
-          <a:p>
-            <a:pPr marL="914400" lvl="1" indent="-457200">
-              <a:buFont typeface="+mj-lt"/>
-              <a:buAutoNum type="arabicPeriod"/>
-            </a:pPr>
-            <a:r>
-              <a:rPr lang="en-US" sz="2200" dirty="0"/>
-              <a:t>Ad Hoc AI Chat Window</a:t>
-            </a:r>
-          </a:p>
-          <a:p>
-            <a:pPr lvl="2"/>
-            <a:r>
-              <a:rPr lang="en-US" dirty="0"/>
-              <a:t>Use Visual Studio Code to fire up an independent AI chat instance</a:t>
-            </a:r>
-          </a:p>
-          <a:p>
-            <a:pPr lvl="2"/>
-            <a:r>
-              <a:rPr lang="en-US" dirty="0"/>
-              <a:t>This is out-of-band, so be careful how you do this if another session is running. (Tell AI  to wait until the in-flight session lands before making any changes to files.)</a:t>
-            </a:r>
-          </a:p>
-        </p:txBody>
-      </p:sp>
+              <a:rPr lang="en-US" sz="2600" dirty="0"/>
+              <a:t>When you start a session, it is labeled as "In Progress" (also called </a:t>
+            </a:r>
+            <a:r>
+              <a:rPr lang="en-US" sz="2600" i="1" dirty="0"/>
+              <a:t>in flight</a:t>
+            </a:r>
+            <a:r>
+              <a:rPr lang="en-US" sz="2600" dirty="0"/>
+              <a:t>)</a:t>
+            </a:r>
+          </a:p>
+          <a:p>
+            <a:r>
+              <a:rPr lang="en-US" sz="2600" dirty="0"/>
+              <a:t>An in-progress session displays its lifecycle phases (register, plan … etc.)</a:t>
+            </a:r>
+          </a:p>
+          <a:p>
+            <a:r>
+              <a:rPr lang="en-US" sz="2600" dirty="0"/>
+              <a:t>When the work phase starts, it displays a list of work steps.</a:t>
+            </a:r>
+          </a:p>
+          <a:p>
+            <a:r>
+              <a:rPr lang="en-US" sz="2600" dirty="0"/>
+              <a:t>When the session is done, it is moved to the "Complete" node in the Work Explorer. </a:t>
+            </a:r>
+          </a:p>
+        </p:txBody>
+      </p:sp>
+      <p:pic>
+        <p:nvPicPr>
+          <p:cNvPr id="5" name="Picture 4">
+            <a:extLst>
+              <a:ext uri="{FF2B5EF4-FFF2-40B4-BE49-F238E27FC236}">
+                <a16:creationId xmlns:a16="http://schemas.microsoft.com/office/drawing/2014/main" id="{964DD055-C21C-FB9F-F138-98D8F5693FA9}"/>
+              </a:ext>
+            </a:extLst>
+          </p:cNvPr>
+          <p:cNvPicPr>
+            <a:picLocks noChangeAspect="1"/>
+          </p:cNvPicPr>
+          <p:nvPr/>
+        </p:nvPicPr>
+        <p:blipFill>
+          <a:blip r:embed="rId2"/>
+          <a:srcRect l="4237" t="56199" r="71367" b="-182"/>
+          <a:stretch>
+            <a:fillRect/>
+          </a:stretch>
+        </p:blipFill>
+        <p:spPr>
+          <a:xfrm>
+            <a:off x="6285426" y="1690688"/>
+            <a:ext cx="4484174" cy="4372410"/>
+          </a:xfrm>
+          <a:prstGeom prst="rect">
+            <a:avLst/>
+          </a:prstGeom>
+        </p:spPr>
+      </p:pic>
     </p:spTree>
     <p:extLst>
       <p:ext uri="{BB962C8B-B14F-4D97-AF65-F5344CB8AC3E}">
-        <p14:creationId xmlns:p14="http://schemas.microsoft.com/office/powerpoint/2010/main" val="439382176"/>
+        <p14:creationId xmlns:p14="http://schemas.microsoft.com/office/powerpoint/2010/main" val="3985681127"/>
       </p:ext>
     </p:extLst>
   </p:cSld>
@@ -3597,7 +3595,7 @@
           <p:cNvPr id="2" name="Title 1">
             <a:extLst>
               <a:ext uri="{FF2B5EF4-FFF2-40B4-BE49-F238E27FC236}">
-                <a16:creationId xmlns:a16="http://schemas.microsoft.com/office/drawing/2014/main" id="{010905FE-C604-2F18-A693-B41F8D012592}"/>
+                <a16:creationId xmlns:a16="http://schemas.microsoft.com/office/drawing/2014/main" id="{6EE03DDD-90E2-7813-A529-5EEC6DABDB00}"/>
               </a:ext>
             </a:extLst>
           </p:cNvPr>
@@ -3608,19 +3606,14 @@
             <p:ph type="title"/>
           </p:nvPr>
         </p:nvSpPr>
-        <p:spPr>
-          <a:xfrm>
-            <a:off x="838200" y="365125"/>
-            <a:ext cx="10515600" cy="1082675"/>
-          </a:xfrm>
-        </p:spPr>
+        <p:spPr/>
         <p:txBody>
           <a:bodyPr/>
           <a:lstStyle/>
           <a:p>
             <a:r>
-              <a:rPr lang="en-US" i="1" dirty="0"/>
-              <a:t>System Files</a:t>
+              <a:rPr lang="en-US" dirty="0"/>
+              <a:t>Adding or Modifying Sessions</a:t>
             </a:r>
           </a:p>
         </p:txBody>
@@ -3630,7 +3623,7 @@
           <p:cNvPr id="3" name="Content Placeholder 2">
             <a:extLst>
               <a:ext uri="{FF2B5EF4-FFF2-40B4-BE49-F238E27FC236}">
-                <a16:creationId xmlns:a16="http://schemas.microsoft.com/office/drawing/2014/main" id="{A0625F5A-0612-85A4-A86A-3A806DC4216E}"/>
+                <a16:creationId xmlns:a16="http://schemas.microsoft.com/office/drawing/2014/main" id="{9678E180-5917-A17E-300B-A48ED127B515}"/>
               </a:ext>
             </a:extLst>
           </p:cNvPr>
@@ -3641,148 +3634,81 @@
             <p:ph idx="1"/>
           </p:nvPr>
         </p:nvSpPr>
-        <p:spPr>
-          <a:xfrm>
-            <a:off x="838200" y="1690688"/>
-            <a:ext cx="10515600" cy="4486275"/>
-          </a:xfrm>
-        </p:spPr>
+        <p:spPr/>
         <p:txBody>
           <a:bodyPr>
-            <a:normAutofit fontScale="92500" lnSpcReduction="10000"/>
+            <a:normAutofit/>
           </a:bodyPr>
           <a:lstStyle/>
           <a:p>
             <a:r>
+              <a:rPr lang="en-US" sz="2400" dirty="0"/>
+              <a:t>The initial set of session may get you over the finish line, but more often you eventually will need to add new sessions and modify existing sessions.</a:t>
+            </a:r>
+            <a:br>
+              <a:rPr lang="en-US" sz="2400" dirty="0"/>
+            </a:br>
+            <a:endParaRPr lang="en-US" sz="2400" dirty="0"/>
+          </a:p>
+          <a:p>
+            <a:r>
+              <a:rPr lang="en-US" sz="2400" dirty="0"/>
+              <a:t>There are two ways to do this:</a:t>
+            </a:r>
+          </a:p>
+          <a:p>
+            <a:pPr marL="914400" lvl="1" indent="-457200">
+              <a:buFont typeface="+mj-lt"/>
+              <a:buAutoNum type="arabicPeriod"/>
+            </a:pPr>
+            <a:r>
+              <a:rPr lang="en-US" sz="2200" dirty="0"/>
+              <a:t>"Consult with AI"</a:t>
+            </a:r>
+          </a:p>
+          <a:p>
+            <a:pPr lvl="2"/>
+            <a:r>
               <a:rPr lang="en-US" dirty="0"/>
-              <a:t>The extension (sometimes called "framework") uses files to govern its work.  </a:t>
-            </a:r>
-          </a:p>
-          <a:p>
+              <a:t>Available in the Work Explorer by right-clicking on the solution name or a session</a:t>
+            </a:r>
+          </a:p>
+          <a:p>
+            <a:pPr lvl="2"/>
             <a:r>
               <a:rPr lang="en-US" dirty="0"/>
-              <a:t>Do not directly edit anything in the .dabbler directory, nor the session-plan.md file, as these have special formats.</a:t>
-            </a:r>
-          </a:p>
-          <a:p>
+              <a:t>Allows you to choose an AI model</a:t>
+            </a:r>
+          </a:p>
+          <a:p>
+            <a:pPr lvl="2"/>
             <a:r>
               <a:rPr lang="en-US" dirty="0"/>
-              <a:t>Here are some of the important system files:</a:t>
-            </a:r>
-          </a:p>
-          <a:p>
-            <a:pPr lvl="1"/>
-            <a:r>
-              <a:rPr lang="en-US" b="1" u="sng" dirty="0">
-                <a:solidFill>
-                  <a:srgbClr val="0070C0"/>
-                </a:solidFill>
-              </a:rPr>
-              <a:t>docs\planning\solution-plan.md</a:t>
-            </a:r>
+              <a:t>Automatically commits/pushes modified plans</a:t>
+            </a:r>
+          </a:p>
+          <a:p>
+            <a:pPr marL="914400" lvl="1" indent="-457200">
+              <a:buFont typeface="+mj-lt"/>
+              <a:buAutoNum type="arabicPeriod"/>
+            </a:pPr>
+            <a:r>
+              <a:rPr lang="en-US" sz="2200" dirty="0"/>
+              <a:t>Ad Hoc AI Chat Window</a:t>
+            </a:r>
+          </a:p>
+          <a:p>
+            <a:pPr lvl="2"/>
             <a:r>
               <a:rPr lang="en-US" dirty="0"/>
-              <a:t> – the overall solution plan</a:t>
-            </a:r>
-            <a:endParaRPr lang="en-US" b="1" u="sng" dirty="0">
-              <a:solidFill>
-                <a:srgbClr val="0070C0"/>
-              </a:solidFill>
-            </a:endParaRPr>
-          </a:p>
-          <a:p>
-            <a:pPr lvl="1"/>
-            <a:r>
-              <a:rPr lang="en-US" b="1" u="sng" dirty="0">
-                <a:solidFill>
-                  <a:srgbClr val="0070C0"/>
-                </a:solidFill>
-              </a:rPr>
-              <a:t>docs\sessions\session-plan.md</a:t>
-            </a:r>
+              <a:t>Use Visual Studio Code to fire up an independent AI chat instance</a:t>
+            </a:r>
+          </a:p>
+          <a:p>
+            <a:pPr lvl="2"/>
             <a:r>
               <a:rPr lang="en-US" dirty="0"/>
-              <a:t> – the session-specific plan</a:t>
-            </a:r>
-          </a:p>
-          <a:p>
-            <a:pPr lvl="1"/>
-            <a:r>
-              <a:rPr lang="en-US" b="1" u="sng" dirty="0">
-                <a:solidFill>
-                  <a:srgbClr val="0070C0"/>
-                </a:solidFill>
-              </a:rPr>
-              <a:t>.dabbler\solution\</a:t>
-            </a:r>
-            <a:r>
-              <a:rPr lang="en-US" b="1" u="sng" dirty="0" err="1">
-                <a:solidFill>
-                  <a:srgbClr val="0070C0"/>
-                </a:solidFill>
-              </a:rPr>
-              <a:t>solution.json</a:t>
-            </a:r>
-            <a:r>
-              <a:rPr lang="en-US" dirty="0"/>
-              <a:t> – the organization of the solution into projects or modules (if any)</a:t>
-            </a:r>
-          </a:p>
-          <a:p>
-            <a:pPr lvl="1"/>
-            <a:r>
-              <a:rPr lang="en-US" b="1" u="sng" dirty="0">
-                <a:solidFill>
-                  <a:srgbClr val="0070C0"/>
-                </a:solidFill>
-              </a:rPr>
-              <a:t>.dabbler\...\</a:t>
-            </a:r>
-            <a:r>
-              <a:rPr lang="en-US" b="1" u="sng" dirty="0" err="1">
-                <a:solidFill>
-                  <a:srgbClr val="0070C0"/>
-                </a:solidFill>
-              </a:rPr>
-              <a:t>instruction.json</a:t>
-            </a:r>
-            <a:r>
-              <a:rPr lang="en-US" u="sng" dirty="0"/>
-              <a:t> </a:t>
-            </a:r>
-            <a:r>
-              <a:rPr lang="en-US" dirty="0"/>
-              <a:t>– a shared file between the extension and AI that allows coordination of work</a:t>
-            </a:r>
-          </a:p>
-          <a:p>
-            <a:pPr lvl="1"/>
-            <a:r>
-              <a:rPr lang="en-US" b="1" dirty="0" err="1">
-                <a:solidFill>
-                  <a:srgbClr val="0070C0"/>
-                </a:solidFill>
-              </a:rPr>
-              <a:t>dabbler.yaml</a:t>
-            </a:r>
-            <a:r>
-              <a:rPr lang="en-US" dirty="0"/>
-              <a:t> – defines testing and solution packaging</a:t>
-            </a:r>
-          </a:p>
-          <a:p>
-            <a:pPr lvl="1"/>
-            <a:r>
-              <a:rPr lang="en-US" b="1" u="sng" dirty="0">
-                <a:solidFill>
-                  <a:srgbClr val="0070C0"/>
-                </a:solidFill>
-              </a:rPr>
-              <a:t>AGENTS.md, CLAUDE.me</a:t>
-            </a:r>
-            <a:r>
-              <a:rPr lang="en-US" dirty="0"/>
-              <a:t> – initial instruction files for AI models.</a:t>
+              <a:t>This is out-of-band, so be careful how you do this if another session is running. (Tell AI  to wait until the in-flight session lands before making any changes to files.)</a:t>
             </a:r>
           </a:p>
         </p:txBody>
@@ -3790,7 +3716,7 @@
     </p:spTree>
     <p:extLst>
       <p:ext uri="{BB962C8B-B14F-4D97-AF65-F5344CB8AC3E}">
-        <p14:creationId xmlns:p14="http://schemas.microsoft.com/office/powerpoint/2010/main" val="229979975"/>
+        <p14:creationId xmlns:p14="http://schemas.microsoft.com/office/powerpoint/2010/main" val="439382176"/>
       </p:ext>
     </p:extLst>
   </p:cSld>
@@ -3822,7 +3748,7 @@
           <p:cNvPr id="2" name="Title 1">
             <a:extLst>
               <a:ext uri="{FF2B5EF4-FFF2-40B4-BE49-F238E27FC236}">
-                <a16:creationId xmlns:a16="http://schemas.microsoft.com/office/drawing/2014/main" id="{5BD1EF6E-CEFB-2608-C538-1FE9724AD32C}"/>
+                <a16:creationId xmlns:a16="http://schemas.microsoft.com/office/drawing/2014/main" id="{010905FE-C604-2F18-A693-B41F8D012592}"/>
               </a:ext>
             </a:extLst>
           </p:cNvPr>
@@ -3833,14 +3759,19 @@
             <p:ph type="title"/>
           </p:nvPr>
         </p:nvSpPr>
-        <p:spPr/>
+        <p:spPr>
+          <a:xfrm>
+            <a:off x="838200" y="365125"/>
+            <a:ext cx="10515600" cy="1082675"/>
+          </a:xfrm>
+        </p:spPr>
         <p:txBody>
           <a:bodyPr/>
           <a:lstStyle/>
           <a:p>
             <a:r>
               <a:rPr lang="en-US" i="1" dirty="0"/>
-              <a:t>Additional Q&amp;A</a:t>
+              <a:t>System Files</a:t>
             </a:r>
           </a:p>
         </p:txBody>
@@ -3850,7 +3781,7 @@
           <p:cNvPr id="3" name="Content Placeholder 2">
             <a:extLst>
               <a:ext uri="{FF2B5EF4-FFF2-40B4-BE49-F238E27FC236}">
-                <a16:creationId xmlns:a16="http://schemas.microsoft.com/office/drawing/2014/main" id="{B3AC8D0A-1B14-C3C2-79B3-89E560244202}"/>
+                <a16:creationId xmlns:a16="http://schemas.microsoft.com/office/drawing/2014/main" id="{A0625F5A-0612-85A4-A86A-3A806DC4216E}"/>
               </a:ext>
             </a:extLst>
           </p:cNvPr>
@@ -3861,34 +3792,148 @@
             <p:ph idx="1"/>
           </p:nvPr>
         </p:nvSpPr>
-        <p:spPr/>
+        <p:spPr>
+          <a:xfrm>
+            <a:off x="838200" y="1690688"/>
+            <a:ext cx="10515600" cy="4486275"/>
+          </a:xfrm>
+        </p:spPr>
         <p:txBody>
           <a:bodyPr>
-            <a:normAutofit/>
+            <a:normAutofit fontScale="92500" lnSpcReduction="10000"/>
           </a:bodyPr>
           <a:lstStyle/>
           <a:p>
             <a:r>
               <a:rPr lang="en-US" dirty="0"/>
-              <a:t>Question: </a:t>
-            </a:r>
-            <a:r>
-              <a:rPr lang="en-US" i="1" dirty="0"/>
-              <a:t>This is an open-source extension developed by one person.  Isn't that risky?</a:t>
-            </a:r>
-            <a:br>
+              <a:t>The extension (sometimes called "framework") uses files to govern its work.  </a:t>
+            </a:r>
+          </a:p>
+          <a:p>
+            <a:r>
               <a:rPr lang="en-US" dirty="0"/>
-            </a:br>
-            <a:endParaRPr lang="en-US" dirty="0"/>
+              <a:t>Do not directly edit anything in the .dabbler directory, nor the session-plan.md file, as these have special formats.</a:t>
+            </a:r>
           </a:p>
           <a:p>
             <a:r>
               <a:rPr lang="en-US" dirty="0"/>
-              <a:t>Answer: </a:t>
-            </a:r>
-            <a:r>
-              <a:rPr lang="en-US" i="1" dirty="0"/>
-              <a:t>It is less risky than many open-source extensions because, in reality, it is written by AI and maintained by AI.  Anyone with access to AI can fix or enhance the solution.  Being a developer helps, but you don't have to know anything about AI or TypeScript or Visual Studio Code Extension programming. </a:t>
+              <a:t>Here are some of the important system files:</a:t>
+            </a:r>
+          </a:p>
+          <a:p>
+            <a:pPr lvl="1"/>
+            <a:r>
+              <a:rPr lang="en-US" b="1" u="sng" dirty="0">
+                <a:solidFill>
+                  <a:srgbClr val="0070C0"/>
+                </a:solidFill>
+              </a:rPr>
+              <a:t>docs\planning\solution-plan.md</a:t>
+            </a:r>
+            <a:r>
+              <a:rPr lang="en-US" dirty="0"/>
+              <a:t> – the overall solution plan</a:t>
+            </a:r>
+            <a:endParaRPr lang="en-US" b="1" u="sng" dirty="0">
+              <a:solidFill>
+                <a:srgbClr val="0070C0"/>
+              </a:solidFill>
+            </a:endParaRPr>
+          </a:p>
+          <a:p>
+            <a:pPr lvl="1"/>
+            <a:r>
+              <a:rPr lang="en-US" b="1" u="sng" dirty="0">
+                <a:solidFill>
+                  <a:srgbClr val="0070C0"/>
+                </a:solidFill>
+              </a:rPr>
+              <a:t>docs\sessions\session-plan.md</a:t>
+            </a:r>
+            <a:r>
+              <a:rPr lang="en-US" dirty="0"/>
+              <a:t> – the session-specific plan</a:t>
+            </a:r>
+          </a:p>
+          <a:p>
+            <a:pPr lvl="1"/>
+            <a:r>
+              <a:rPr lang="en-US" b="1" u="sng" dirty="0">
+                <a:solidFill>
+                  <a:srgbClr val="0070C0"/>
+                </a:solidFill>
+              </a:rPr>
+              <a:t>.dabbler\solution\</a:t>
+            </a:r>
+            <a:r>
+              <a:rPr lang="en-US" b="1" u="sng" dirty="0" err="1">
+                <a:solidFill>
+                  <a:srgbClr val="0070C0"/>
+                </a:solidFill>
+              </a:rPr>
+              <a:t>solution.json</a:t>
+            </a:r>
+            <a:r>
+              <a:rPr lang="en-US" dirty="0"/>
+              <a:t> – the organization of the solution into projects or modules (if any)</a:t>
+            </a:r>
+          </a:p>
+          <a:p>
+            <a:pPr lvl="1"/>
+            <a:r>
+              <a:rPr lang="en-US" b="1" u="sng" dirty="0">
+                <a:solidFill>
+                  <a:srgbClr val="0070C0"/>
+                </a:solidFill>
+              </a:rPr>
+              <a:t>.dabbler\...\</a:t>
+            </a:r>
+            <a:r>
+              <a:rPr lang="en-US" b="1" u="sng" dirty="0" err="1">
+                <a:solidFill>
+                  <a:srgbClr val="0070C0"/>
+                </a:solidFill>
+              </a:rPr>
+              <a:t>instruction.json</a:t>
+            </a:r>
+            <a:r>
+              <a:rPr lang="en-US" u="sng" dirty="0"/>
+              <a:t> </a:t>
+            </a:r>
+            <a:r>
+              <a:rPr lang="en-US" dirty="0"/>
+              <a:t>– a shared file between the extension and AI that allows coordination of work</a:t>
+            </a:r>
+          </a:p>
+          <a:p>
+            <a:pPr lvl="1"/>
+            <a:r>
+              <a:rPr lang="en-US" b="1" dirty="0" err="1">
+                <a:solidFill>
+                  <a:srgbClr val="0070C0"/>
+                </a:solidFill>
+              </a:rPr>
+              <a:t>dabbler.yaml</a:t>
+            </a:r>
+            <a:r>
+              <a:rPr lang="en-US" dirty="0"/>
+              <a:t> – defines testing and solution packaging</a:t>
+            </a:r>
+          </a:p>
+          <a:p>
+            <a:pPr lvl="1"/>
+            <a:r>
+              <a:rPr lang="en-US" b="1" u="sng" dirty="0">
+                <a:solidFill>
+                  <a:srgbClr val="0070C0"/>
+                </a:solidFill>
+              </a:rPr>
+              <a:t>AGENTS.md, CLAUDE.me</a:t>
+            </a:r>
+            <a:r>
+              <a:rPr lang="en-US" dirty="0"/>
+              <a:t> – initial instruction files for AI models.</a:t>
             </a:r>
           </a:p>
         </p:txBody>
@@ -3896,7 +3941,7 @@
     </p:spTree>
     <p:extLst>
       <p:ext uri="{BB962C8B-B14F-4D97-AF65-F5344CB8AC3E}">
-        <p14:creationId xmlns:p14="http://schemas.microsoft.com/office/powerpoint/2010/main" val="3540892354"/>
+        <p14:creationId xmlns:p14="http://schemas.microsoft.com/office/powerpoint/2010/main" val="229979975"/>
       </p:ext>
     </p:extLst>
   </p:cSld>
@@ -3928,6 +3973,112 @@
           <p:cNvPr id="2" name="Title 1">
             <a:extLst>
               <a:ext uri="{FF2B5EF4-FFF2-40B4-BE49-F238E27FC236}">
+                <a16:creationId xmlns:a16="http://schemas.microsoft.com/office/drawing/2014/main" id="{5BD1EF6E-CEFB-2608-C538-1FE9724AD32C}"/>
+              </a:ext>
+            </a:extLst>
+          </p:cNvPr>
+          <p:cNvSpPr>
+            <a:spLocks noGrp="1"/>
+          </p:cNvSpPr>
+          <p:nvPr>
+            <p:ph type="title"/>
+          </p:nvPr>
+        </p:nvSpPr>
+        <p:spPr/>
+        <p:txBody>
+          <a:bodyPr/>
+          <a:lstStyle/>
+          <a:p>
+            <a:r>
+              <a:rPr lang="en-US" i="1" dirty="0"/>
+              <a:t>Additional Q&amp;A</a:t>
+            </a:r>
+          </a:p>
+        </p:txBody>
+      </p:sp>
+      <p:sp>
+        <p:nvSpPr>
+          <p:cNvPr id="3" name="Content Placeholder 2">
+            <a:extLst>
+              <a:ext uri="{FF2B5EF4-FFF2-40B4-BE49-F238E27FC236}">
+                <a16:creationId xmlns:a16="http://schemas.microsoft.com/office/drawing/2014/main" id="{B3AC8D0A-1B14-C3C2-79B3-89E560244202}"/>
+              </a:ext>
+            </a:extLst>
+          </p:cNvPr>
+          <p:cNvSpPr>
+            <a:spLocks noGrp="1"/>
+          </p:cNvSpPr>
+          <p:nvPr>
+            <p:ph idx="1"/>
+          </p:nvPr>
+        </p:nvSpPr>
+        <p:spPr/>
+        <p:txBody>
+          <a:bodyPr>
+            <a:normAutofit/>
+          </a:bodyPr>
+          <a:lstStyle/>
+          <a:p>
+            <a:r>
+              <a:rPr lang="en-US" dirty="0"/>
+              <a:t>Question: </a:t>
+            </a:r>
+            <a:r>
+              <a:rPr lang="en-US" i="1" dirty="0"/>
+              <a:t>This is an open-source extension developed by one person.  Isn't that risky?</a:t>
+            </a:r>
+            <a:br>
+              <a:rPr lang="en-US" dirty="0"/>
+            </a:br>
+            <a:endParaRPr lang="en-US" dirty="0"/>
+          </a:p>
+          <a:p>
+            <a:r>
+              <a:rPr lang="en-US" dirty="0"/>
+              <a:t>Answer: </a:t>
+            </a:r>
+            <a:r>
+              <a:rPr lang="en-US" i="1" dirty="0"/>
+              <a:t>It is less risky than many open-source extensions because, in reality, it is written by AI and maintained by AI.  Anyone with access to AI can fix or enhance the solution.  Being a developer helps, but you don't have to know anything about AI or TypeScript or Visual Studio Code Extension programming. </a:t>
+            </a:r>
+          </a:p>
+        </p:txBody>
+      </p:sp>
+    </p:spTree>
+    <p:extLst>
+      <p:ext uri="{BB962C8B-B14F-4D97-AF65-F5344CB8AC3E}">
+        <p14:creationId xmlns:p14="http://schemas.microsoft.com/office/powerpoint/2010/main" val="3540892354"/>
+      </p:ext>
+    </p:extLst>
+  </p:cSld>
+  <p:clrMapOvr>
+    <a:masterClrMapping/>
+  </p:clrMapOvr>
+</p:sld>
+</file>
+
+<file path=ppt/slides/slide14.xml><?xml version="1.0" encoding="utf-8"?>
+<p:sld xmlns:a="http://schemas.openxmlformats.org/drawingml/2006/main" xmlns:r="http://schemas.openxmlformats.org/officeDocument/2006/relationships" xmlns:p="http://schemas.openxmlformats.org/presentationml/2006/main">
+  <p:cSld>
+    <p:spTree>
+      <p:nvGrpSpPr>
+        <p:cNvPr id="1" name=""/>
+        <p:cNvGrpSpPr/>
+        <p:nvPr/>
+      </p:nvGrpSpPr>
+      <p:grpSpPr>
+        <a:xfrm>
+          <a:off x="0" y="0"/>
+          <a:ext cx="0" cy="0"/>
+          <a:chOff x="0" y="0"/>
+          <a:chExt cx="0" cy="0"/>
+        </a:xfrm>
+      </p:grpSpPr>
+      <p:sp>
+        <p:nvSpPr>
+          <p:cNvPr id="2" name="Title 1">
+            <a:extLst>
+              <a:ext uri="{FF2B5EF4-FFF2-40B4-BE49-F238E27FC236}">
                 <a16:creationId xmlns:a16="http://schemas.microsoft.com/office/drawing/2014/main" id="{B5AC1AB3-0EAE-BCD9-7654-8CC37159596D}"/>
               </a:ext>
             </a:extLst>
@@ -4011,7 +4162,7 @@
 </p:sld>
 </file>
 
-<file path=ppt/slides/slide14.xml><?xml version="1.0" encoding="utf-8"?>
+<file path=ppt/slides/slide15.xml><?xml version="1.0" encoding="utf-8"?>
 <p:sld xmlns:a="http://schemas.openxmlformats.org/drawingml/2006/main" xmlns:r="http://schemas.openxmlformats.org/officeDocument/2006/relationships" xmlns:p="http://schemas.openxmlformats.org/presentationml/2006/main">
   <p:cSld>
     <p:spTree>
@@ -4122,7 +4273,7 @@
 </p:sld>
 </file>
 
-<file path=ppt/slides/slide15.xml><?xml version="1.0" encoding="utf-8"?>
+<file path=ppt/slides/slide16.xml><?xml version="1.0" encoding="utf-8"?>
 <p:sld xmlns:a="http://schemas.openxmlformats.org/drawingml/2006/main" xmlns:r="http://schemas.openxmlformats.org/officeDocument/2006/relationships" xmlns:p="http://schemas.openxmlformats.org/presentationml/2006/main">
   <p:cSld>
     <p:spTree>
@@ -4233,7 +4384,7 @@
 </p:sld>
 </file>
 
-<file path=ppt/slides/slide16.xml><?xml version="1.0" encoding="utf-8"?>
+<file path=ppt/slides/slide17.xml><?xml version="1.0" encoding="utf-8"?>
 <p:sld xmlns:a="http://schemas.openxmlformats.org/drawingml/2006/main" xmlns:r="http://schemas.openxmlformats.org/officeDocument/2006/relationships" xmlns:p="http://schemas.openxmlformats.org/presentationml/2006/main">
   <p:cSld>
     <p:spTree>
@@ -4372,7 +4523,7 @@
 </p:sld>
 </file>
 
-<file path=ppt/slides/slide17.xml><?xml version="1.0" encoding="utf-8"?>
+<file path=ppt/slides/slide18.xml><?xml version="1.0" encoding="utf-8"?>
 <p:sld xmlns:a="http://schemas.openxmlformats.org/drawingml/2006/main" xmlns:r="http://schemas.openxmlformats.org/officeDocument/2006/relationships" xmlns:p="http://schemas.openxmlformats.org/presentationml/2006/main">
   <p:cSld>
     <p:spTree>
@@ -5207,7 +5358,7 @@
           <a:p>
             <a:r>
               <a:rPr lang="en-US" i="1" dirty="0"/>
-              <a:t>Getting Started – Project Set Up</a:t>
+              <a:t>Getting Started – Project* Set Up</a:t>
             </a:r>
           </a:p>
         </p:txBody>
@@ -5345,6 +5496,42 @@
           </a:prstGeom>
         </p:spPr>
       </p:pic>
+      <p:sp>
+        <p:nvSpPr>
+          <p:cNvPr id="6" name="TextBox 5">
+            <a:extLst>
+              <a:ext uri="{FF2B5EF4-FFF2-40B4-BE49-F238E27FC236}">
+                <a16:creationId xmlns:a16="http://schemas.microsoft.com/office/drawing/2014/main" id="{73A71B08-5293-F952-BD2F-CA79B0D633A0}"/>
+              </a:ext>
+            </a:extLst>
+          </p:cNvPr>
+          <p:cNvSpPr txBox="1"/>
+          <p:nvPr/>
+        </p:nvSpPr>
+        <p:spPr>
+          <a:xfrm>
+            <a:off x="636154" y="6347533"/>
+            <a:ext cx="6520664" cy="369332"/>
+          </a:xfrm>
+          <a:prstGeom prst="rect">
+            <a:avLst/>
+          </a:prstGeom>
+          <a:noFill/>
+        </p:spPr>
+        <p:txBody>
+          <a:bodyPr wrap="square">
+            <a:spAutoFit/>
+          </a:bodyPr>
+          <a:lstStyle/>
+          <a:p>
+            <a:r>
+              <a:rPr lang="en-US" i="1" dirty="0"/>
+              <a:t>*Here, "project" refers to the whole solution or repo</a:t>
+            </a:r>
+            <a:endParaRPr lang="en-US" sz="900" dirty="0"/>
+          </a:p>
+        </p:txBody>
+      </p:sp>
     </p:spTree>
     <p:extLst>
       <p:ext uri="{BB962C8B-B14F-4D97-AF65-F5344CB8AC3E}">
@@ -5359,6 +5546,284 @@
 </file>
 
 <file path=ppt/slides/slide6.xml><?xml version="1.0" encoding="utf-8"?>
+<p:sld xmlns:a="http://schemas.openxmlformats.org/drawingml/2006/main" xmlns:r="http://schemas.openxmlformats.org/officeDocument/2006/relationships" xmlns:p="http://schemas.openxmlformats.org/presentationml/2006/main">
+  <p:cSld>
+    <p:spTree>
+      <p:nvGrpSpPr>
+        <p:cNvPr id="1" name="">
+          <a:extLst>
+            <a:ext uri="{FF2B5EF4-FFF2-40B4-BE49-F238E27FC236}">
+              <a16:creationId xmlns:a16="http://schemas.microsoft.com/office/drawing/2014/main" id="{A2C80558-632D-6B70-B6EC-63CE40EA24F5}"/>
+            </a:ext>
+          </a:extLst>
+        </p:cNvPr>
+        <p:cNvGrpSpPr/>
+        <p:nvPr/>
+      </p:nvGrpSpPr>
+      <p:grpSpPr>
+        <a:xfrm>
+          <a:off x="0" y="0"/>
+          <a:ext cx="0" cy="0"/>
+          <a:chOff x="0" y="0"/>
+          <a:chExt cx="0" cy="0"/>
+        </a:xfrm>
+      </p:grpSpPr>
+      <p:sp>
+        <p:nvSpPr>
+          <p:cNvPr id="2" name="Title 1">
+            <a:extLst>
+              <a:ext uri="{FF2B5EF4-FFF2-40B4-BE49-F238E27FC236}">
+                <a16:creationId xmlns:a16="http://schemas.microsoft.com/office/drawing/2014/main" id="{104EF990-5253-930C-A7DF-464205EABCFF}"/>
+              </a:ext>
+            </a:extLst>
+          </p:cNvPr>
+          <p:cNvSpPr>
+            <a:spLocks noGrp="1"/>
+          </p:cNvSpPr>
+          <p:nvPr>
+            <p:ph type="title"/>
+          </p:nvPr>
+        </p:nvSpPr>
+        <p:spPr>
+          <a:xfrm>
+            <a:off x="838200" y="365125"/>
+            <a:ext cx="10515600" cy="798657"/>
+          </a:xfrm>
+        </p:spPr>
+        <p:txBody>
+          <a:bodyPr>
+            <a:noAutofit/>
+          </a:bodyPr>
+          <a:lstStyle/>
+          <a:p>
+            <a:r>
+              <a:rPr lang="en-US" sz="3600" i="1" dirty="0"/>
+              <a:t>Getting Started – Default AI Configurations for Repo</a:t>
+            </a:r>
+          </a:p>
+        </p:txBody>
+      </p:sp>
+      <p:sp>
+        <p:nvSpPr>
+          <p:cNvPr id="3" name="Content Placeholder 2">
+            <a:extLst>
+              <a:ext uri="{FF2B5EF4-FFF2-40B4-BE49-F238E27FC236}">
+                <a16:creationId xmlns:a16="http://schemas.microsoft.com/office/drawing/2014/main" id="{F17C7BB2-EE08-8F35-260C-21F3F2B398B0}"/>
+              </a:ext>
+            </a:extLst>
+          </p:cNvPr>
+          <p:cNvSpPr>
+            <a:spLocks noGrp="1"/>
+          </p:cNvSpPr>
+          <p:nvPr>
+            <p:ph idx="1"/>
+          </p:nvPr>
+        </p:nvSpPr>
+        <p:spPr>
+          <a:xfrm>
+            <a:off x="498550" y="1346200"/>
+            <a:ext cx="5330749" cy="5001333"/>
+          </a:xfrm>
+        </p:spPr>
+        <p:txBody>
+          <a:bodyPr>
+            <a:normAutofit lnSpcReduction="10000"/>
+          </a:bodyPr>
+          <a:lstStyle/>
+          <a:p>
+            <a:pPr marL="457200" indent="-457200">
+              <a:buFont typeface="+mj-lt"/>
+              <a:buAutoNum type="arabicPeriod"/>
+            </a:pPr>
+            <a:r>
+              <a:rPr lang="en-US" sz="1800" dirty="0"/>
+              <a:t>The Configuration section in the Solution Explorer allows you to set default AI settings for your repo/solution.</a:t>
+            </a:r>
+          </a:p>
+          <a:p>
+            <a:pPr marL="457200" indent="-457200">
+              <a:buFont typeface="+mj-lt"/>
+              <a:buAutoNum type="arabicPeriod"/>
+            </a:pPr>
+            <a:r>
+              <a:rPr lang="en-US" sz="1800" dirty="0"/>
+              <a:t>The </a:t>
+            </a:r>
+            <a:r>
+              <a:rPr lang="en-US" sz="1800" b="1" dirty="0">
+                <a:solidFill>
+                  <a:srgbClr val="0070C0"/>
+                </a:solidFill>
+              </a:rPr>
+              <a:t>Authoring AI </a:t>
+            </a:r>
+            <a:r>
+              <a:rPr lang="en-US" sz="1800" dirty="0"/>
+              <a:t>is the AI that writes your code</a:t>
+            </a:r>
+          </a:p>
+          <a:p>
+            <a:pPr marL="457200" indent="-457200">
+              <a:buFont typeface="+mj-lt"/>
+              <a:buAutoNum type="arabicPeriod"/>
+            </a:pPr>
+            <a:r>
+              <a:rPr lang="en-US" sz="1800" dirty="0"/>
+              <a:t>The </a:t>
+            </a:r>
+            <a:r>
+              <a:rPr lang="en-US" sz="1800" b="1" dirty="0">
+                <a:solidFill>
+                  <a:srgbClr val="0070C0"/>
+                </a:solidFill>
+              </a:rPr>
+              <a:t>Reviewing AI</a:t>
+            </a:r>
+            <a:r>
+              <a:rPr lang="en-US" sz="1800" dirty="0"/>
+              <a:t> is the AI that reviews, evaluates, and ultimately verifies your code.</a:t>
+            </a:r>
+          </a:p>
+          <a:p>
+            <a:pPr lvl="1"/>
+            <a:r>
+              <a:rPr lang="en-US" sz="1600" dirty="0"/>
+              <a:t>Primary Model does most of the Work</a:t>
+            </a:r>
+          </a:p>
+          <a:p>
+            <a:pPr lvl="1"/>
+            <a:r>
+              <a:rPr lang="en-US" sz="1600" dirty="0"/>
+              <a:t>Auxiliary Model has final word when Authoring AI disagrees with Primary Reviewing Model</a:t>
+            </a:r>
+          </a:p>
+          <a:p>
+            <a:pPr marL="457200" indent="-457200">
+              <a:buFont typeface="+mj-lt"/>
+              <a:buAutoNum type="arabicPeriod"/>
+            </a:pPr>
+            <a:r>
+              <a:rPr lang="en-US" sz="1800" dirty="0"/>
+              <a:t>The </a:t>
+            </a:r>
+            <a:r>
+              <a:rPr lang="en-US" sz="1800" b="1" dirty="0">
+                <a:solidFill>
+                  <a:srgbClr val="0070C0"/>
+                </a:solidFill>
+              </a:rPr>
+              <a:t>Vehicle </a:t>
+            </a:r>
+            <a:r>
+              <a:rPr lang="en-US" sz="1800" dirty="0"/>
+              <a:t>is the CLI or API that communicates with the AI model</a:t>
+            </a:r>
+          </a:p>
+          <a:p>
+            <a:pPr marL="457200" indent="-457200">
+              <a:buFont typeface="+mj-lt"/>
+              <a:buAutoNum type="arabicPeriod"/>
+            </a:pPr>
+            <a:r>
+              <a:rPr lang="en-US" sz="1800" dirty="0"/>
+              <a:t>The </a:t>
+            </a:r>
+            <a:r>
+              <a:rPr lang="en-US" sz="1800" b="1" dirty="0">
+                <a:solidFill>
+                  <a:srgbClr val="0070C0"/>
+                </a:solidFill>
+              </a:rPr>
+              <a:t>Model </a:t>
+            </a:r>
+            <a:r>
+              <a:rPr lang="en-US" sz="1800" dirty="0"/>
+              <a:t>is the specific AI model used (e.g., claude-opus-5, gpt-5.6-terra … etc.)</a:t>
+            </a:r>
+          </a:p>
+          <a:p>
+            <a:pPr marL="457200" indent="-457200">
+              <a:buFont typeface="+mj-lt"/>
+              <a:buAutoNum type="arabicPeriod"/>
+            </a:pPr>
+            <a:r>
+              <a:rPr lang="en-US" sz="1800" dirty="0"/>
+              <a:t>The </a:t>
+            </a:r>
+            <a:r>
+              <a:rPr lang="en-US" sz="1800" b="1" dirty="0">
+                <a:solidFill>
+                  <a:srgbClr val="0070C0"/>
+                </a:solidFill>
+              </a:rPr>
+              <a:t>API Keys </a:t>
+            </a:r>
+            <a:r>
+              <a:rPr lang="en-US" sz="1800" dirty="0"/>
+              <a:t>are authentication keys used to call AI APIs.</a:t>
+            </a:r>
+          </a:p>
+          <a:p>
+            <a:pPr lvl="1"/>
+            <a:r>
+              <a:rPr lang="en-US" sz="1600" dirty="0"/>
+              <a:t>Require dedicated API accounts</a:t>
+            </a:r>
+          </a:p>
+          <a:p>
+            <a:pPr lvl="1"/>
+            <a:r>
+              <a:rPr lang="en-US" sz="1600" dirty="0"/>
+              <a:t>Currently they are used only for Reviewing AI</a:t>
+            </a:r>
+          </a:p>
+        </p:txBody>
+      </p:sp>
+      <p:pic>
+        <p:nvPicPr>
+          <p:cNvPr id="6" name="Picture 5">
+            <a:extLst>
+              <a:ext uri="{FF2B5EF4-FFF2-40B4-BE49-F238E27FC236}">
+                <a16:creationId xmlns:a16="http://schemas.microsoft.com/office/drawing/2014/main" id="{97DB52AA-6DF3-33DF-4A18-5089AC760226}"/>
+              </a:ext>
+            </a:extLst>
+          </p:cNvPr>
+          <p:cNvPicPr>
+            <a:picLocks noChangeAspect="1"/>
+          </p:cNvPicPr>
+          <p:nvPr/>
+        </p:nvPicPr>
+        <p:blipFill>
+          <a:blip r:embed="rId2"/>
+          <a:stretch>
+            <a:fillRect/>
+          </a:stretch>
+        </p:blipFill>
+        <p:spPr>
+          <a:xfrm>
+            <a:off x="6034809" y="1163782"/>
+            <a:ext cx="5658640" cy="5277587"/>
+          </a:xfrm>
+          <a:prstGeom prst="rect">
+            <a:avLst/>
+          </a:prstGeom>
+        </p:spPr>
+      </p:pic>
+    </p:spTree>
+    <p:extLst>
+      <p:ext uri="{BB962C8B-B14F-4D97-AF65-F5344CB8AC3E}">
+        <p14:creationId xmlns:p14="http://schemas.microsoft.com/office/powerpoint/2010/main" val="291432367"/>
+      </p:ext>
+    </p:extLst>
+  </p:cSld>
+  <p:clrMapOvr>
+    <a:masterClrMapping/>
+  </p:clrMapOvr>
+</p:sld>
+</file>
+
+<file path=ppt/slides/slide7.xml><?xml version="1.0" encoding="utf-8"?>
 <p:sld xmlns:a="http://schemas.openxmlformats.org/drawingml/2006/main" xmlns:r="http://schemas.openxmlformats.org/officeDocument/2006/relationships" xmlns:p="http://schemas.openxmlformats.org/presentationml/2006/main">
   <p:cSld>
     <p:spTree>
@@ -6315,14 +6780,14 @@
           <p:nvPr>
             <p:extLst>
               <p:ext uri="{D42A27DB-BD31-4B8C-83A1-F6EECF244321}">
-                <p14:modId xmlns:p14="http://schemas.microsoft.com/office/powerpoint/2010/main" val="1920859465"/>
+                <p14:modId xmlns:p14="http://schemas.microsoft.com/office/powerpoint/2010/main" val="3229417365"/>
               </p:ext>
             </p:extLst>
           </p:nvPr>
         </p:nvGraphicFramePr>
         <p:xfrm>
-          <a:off x="1194582" y="1967872"/>
-          <a:ext cx="2833087" cy="1833880"/>
+          <a:off x="636275" y="2006599"/>
+          <a:ext cx="3282806" cy="1559560"/>
         </p:xfrm>
         <a:graphic>
           <a:graphicData uri="http://schemas.openxmlformats.org/drawingml/2006/table">
@@ -6331,7 +6796,7 @@
                 <a:tableStyleId>{5C22544A-7EE6-4342-B048-85BDC9FD1C3A}</a:tableStyleId>
               </a:tblPr>
               <a:tblGrid>
-                <a:gridCol w="2833087">
+                <a:gridCol w="3282806">
                   <a:extLst>
                     <a:ext uri="{9D8B030D-6E8A-4147-A177-3AD203B41FA5}">
                       <a16:colId xmlns:a16="http://schemas.microsoft.com/office/drawing/2014/main" val="1033090965"/>
@@ -6429,7 +6894,7 @@
                       </a:pPr>
                       <a:r>
                         <a:rPr lang="en-US" sz="1800" dirty="0"/>
-                        <a:t>Where you choose AI models for sessions</a:t>
+                        <a:t>Where you choose default AI settings for a repo</a:t>
                       </a:r>
                     </a:p>
                     <a:p>
@@ -6521,7 +6986,7 @@
 </p:sld>
 </file>
 
-<file path=ppt/slides/slide7.xml><?xml version="1.0" encoding="utf-8"?>
+<file path=ppt/slides/slide8.xml><?xml version="1.0" encoding="utf-8"?>
 <p:sld xmlns:a="http://schemas.openxmlformats.org/drawingml/2006/main" xmlns:r="http://schemas.openxmlformats.org/officeDocument/2006/relationships" xmlns:p="http://schemas.openxmlformats.org/presentationml/2006/main">
   <p:cSld>
     <p:spTree>
@@ -6688,152 +7153,6 @@
     <p:extLst>
       <p:ext uri="{BB962C8B-B14F-4D97-AF65-F5344CB8AC3E}">
         <p14:creationId xmlns:p14="http://schemas.microsoft.com/office/powerpoint/2010/main" val="2367043460"/>
-      </p:ext>
-    </p:extLst>
-  </p:cSld>
-  <p:clrMapOvr>
-    <a:masterClrMapping/>
-  </p:clrMapOvr>
-</p:sld>
-</file>
-
-<file path=ppt/slides/slide8.xml><?xml version="1.0" encoding="utf-8"?>
-<p:sld xmlns:a="http://schemas.openxmlformats.org/drawingml/2006/main" xmlns:r="http://schemas.openxmlformats.org/officeDocument/2006/relationships" xmlns:p="http://schemas.openxmlformats.org/presentationml/2006/main">
-  <p:cSld>
-    <p:spTree>
-      <p:nvGrpSpPr>
-        <p:cNvPr id="1" name=""/>
-        <p:cNvGrpSpPr/>
-        <p:nvPr/>
-      </p:nvGrpSpPr>
-      <p:grpSpPr>
-        <a:xfrm>
-          <a:off x="0" y="0"/>
-          <a:ext cx="0" cy="0"/>
-          <a:chOff x="0" y="0"/>
-          <a:chExt cx="0" cy="0"/>
-        </a:xfrm>
-      </p:grpSpPr>
-      <p:pic>
-        <p:nvPicPr>
-          <p:cNvPr id="7" name="Picture 6">
-            <a:extLst>
-              <a:ext uri="{FF2B5EF4-FFF2-40B4-BE49-F238E27FC236}">
-                <a16:creationId xmlns:a16="http://schemas.microsoft.com/office/drawing/2014/main" id="{15F11CCF-549F-E107-D5A6-C3411B6E577A}"/>
-              </a:ext>
-            </a:extLst>
-          </p:cNvPr>
-          <p:cNvPicPr>
-            <a:picLocks noChangeAspect="1"/>
-          </p:cNvPicPr>
-          <p:nvPr/>
-        </p:nvPicPr>
-        <p:blipFill>
-          <a:blip r:embed="rId2"/>
-          <a:stretch>
-            <a:fillRect/>
-          </a:stretch>
-        </p:blipFill>
-        <p:spPr>
-          <a:xfrm>
-            <a:off x="6209970" y="2441414"/>
-            <a:ext cx="4725059" cy="2305372"/>
-          </a:xfrm>
-          <a:prstGeom prst="rect">
-            <a:avLst/>
-          </a:prstGeom>
-        </p:spPr>
-      </p:pic>
-      <p:sp>
-        <p:nvSpPr>
-          <p:cNvPr id="8" name="Title 7">
-            <a:extLst>
-              <a:ext uri="{FF2B5EF4-FFF2-40B4-BE49-F238E27FC236}">
-                <a16:creationId xmlns:a16="http://schemas.microsoft.com/office/drawing/2014/main" id="{0FEC81DB-8592-20EA-FA5D-453C781CEC43}"/>
-              </a:ext>
-            </a:extLst>
-          </p:cNvPr>
-          <p:cNvSpPr>
-            <a:spLocks noGrp="1"/>
-          </p:cNvSpPr>
-          <p:nvPr>
-            <p:ph type="title"/>
-          </p:nvPr>
-        </p:nvSpPr>
-        <p:spPr>
-          <a:xfrm>
-            <a:off x="838200" y="492126"/>
-            <a:ext cx="10515600" cy="811450"/>
-          </a:xfrm>
-        </p:spPr>
-        <p:txBody>
-          <a:bodyPr/>
-          <a:lstStyle/>
-          <a:p>
-            <a:r>
-              <a:rPr lang="en-US" i="1" dirty="0"/>
-              <a:t>Starting a Session</a:t>
-            </a:r>
-          </a:p>
-        </p:txBody>
-      </p:sp>
-      <p:sp>
-        <p:nvSpPr>
-          <p:cNvPr id="9" name="Content Placeholder 8">
-            <a:extLst>
-              <a:ext uri="{FF2B5EF4-FFF2-40B4-BE49-F238E27FC236}">
-                <a16:creationId xmlns:a16="http://schemas.microsoft.com/office/drawing/2014/main" id="{6903AD9D-3EA9-A901-13DB-6C20935CC738}"/>
-              </a:ext>
-            </a:extLst>
-          </p:cNvPr>
-          <p:cNvSpPr>
-            <a:spLocks noGrp="1"/>
-          </p:cNvSpPr>
-          <p:nvPr>
-            <p:ph idx="1"/>
-          </p:nvPr>
-        </p:nvSpPr>
-        <p:spPr>
-          <a:xfrm>
-            <a:off x="838200" y="1825625"/>
-            <a:ext cx="4635500" cy="4351338"/>
-          </a:xfrm>
-        </p:spPr>
-        <p:txBody>
-          <a:bodyPr>
-            <a:normAutofit fontScale="92500" lnSpcReduction="10000"/>
-          </a:bodyPr>
-          <a:lstStyle/>
-          <a:p>
-            <a:r>
-              <a:rPr lang="en-US" sz="2600" dirty="0"/>
-              <a:t>To start a session, right click on the next session and select "Start Session"</a:t>
-            </a:r>
-          </a:p>
-          <a:p>
-            <a:r>
-              <a:rPr lang="en-US" sz="2600" dirty="0"/>
-              <a:t>At the top of the screen, you will be prompted to confirm you AI tool and model</a:t>
-            </a:r>
-          </a:p>
-          <a:p>
-            <a:r>
-              <a:rPr lang="en-US" sz="2600" dirty="0"/>
-              <a:t>You can cancel a session by right clicking and choosing "Cancel Session"</a:t>
-            </a:r>
-          </a:p>
-          <a:p>
-            <a:r>
-              <a:rPr lang="en-US" sz="2600" dirty="0"/>
-              <a:t>You must run sessions in order, but you can have AI change to order of sessions (when you are between sessions) </a:t>
-            </a:r>
-          </a:p>
-        </p:txBody>
-      </p:sp>
-    </p:spTree>
-    <p:extLst>
-      <p:ext uri="{BB962C8B-B14F-4D97-AF65-F5344CB8AC3E}">
-        <p14:creationId xmlns:p14="http://schemas.microsoft.com/office/powerpoint/2010/main" val="1788143237"/>
       </p:ext>
     </p:extLst>
   </p:cSld>
@@ -6862,10 +7181,10 @@
       </p:grpSpPr>
       <p:sp>
         <p:nvSpPr>
-          <p:cNvPr id="2" name="Title 1">
-            <a:extLst>
-              <a:ext uri="{FF2B5EF4-FFF2-40B4-BE49-F238E27FC236}">
-                <a16:creationId xmlns:a16="http://schemas.microsoft.com/office/drawing/2014/main" id="{E12EF12D-46C0-5B31-F59D-6A32246E1740}"/>
+          <p:cNvPr id="8" name="Title 7">
+            <a:extLst>
+              <a:ext uri="{FF2B5EF4-FFF2-40B4-BE49-F238E27FC236}">
+                <a16:creationId xmlns:a16="http://schemas.microsoft.com/office/drawing/2014/main" id="{0FEC81DB-8592-20EA-FA5D-453C781CEC43}"/>
               </a:ext>
             </a:extLst>
           </p:cNvPr>
@@ -6874,87 +7193,84 @@
           </p:cNvSpPr>
           <p:nvPr>
             <p:ph type="title"/>
-          </p:nvPr>
-        </p:nvSpPr>
-        <p:spPr/>
-        <p:txBody>
-          <a:bodyPr/>
-          <a:lstStyle/>
-          <a:p>
-            <a:r>
-              <a:rPr lang="en-US" i="1" dirty="0"/>
-              <a:t>Tracking a Session</a:t>
-            </a:r>
-          </a:p>
-        </p:txBody>
-      </p:sp>
-      <p:sp>
-        <p:nvSpPr>
-          <p:cNvPr id="3" name="Content Placeholder 2">
-            <a:extLst>
-              <a:ext uri="{FF2B5EF4-FFF2-40B4-BE49-F238E27FC236}">
-                <a16:creationId xmlns:a16="http://schemas.microsoft.com/office/drawing/2014/main" id="{774329B2-A4A0-E9C8-5A88-4758282B571A}"/>
-              </a:ext>
-            </a:extLst>
-          </p:cNvPr>
-          <p:cNvSpPr>
-            <a:spLocks noGrp="1"/>
-          </p:cNvSpPr>
-          <p:nvPr>
-            <p:ph idx="1"/>
           </p:nvPr>
         </p:nvSpPr>
         <p:spPr>
           <a:xfrm>
-            <a:off x="838200" y="1825625"/>
-            <a:ext cx="4107287" cy="4351338"/>
+            <a:off x="838200" y="492126"/>
+            <a:ext cx="10515600" cy="811450"/>
           </a:xfrm>
         </p:spPr>
         <p:txBody>
+          <a:bodyPr/>
+          <a:lstStyle/>
+          <a:p>
+            <a:r>
+              <a:rPr lang="en-US" i="1" dirty="0"/>
+              <a:t>Starting a Session</a:t>
+            </a:r>
+          </a:p>
+        </p:txBody>
+      </p:sp>
+      <p:sp>
+        <p:nvSpPr>
+          <p:cNvPr id="9" name="Content Placeholder 8">
+            <a:extLst>
+              <a:ext uri="{FF2B5EF4-FFF2-40B4-BE49-F238E27FC236}">
+                <a16:creationId xmlns:a16="http://schemas.microsoft.com/office/drawing/2014/main" id="{6903AD9D-3EA9-A901-13DB-6C20935CC738}"/>
+              </a:ext>
+            </a:extLst>
+          </p:cNvPr>
+          <p:cNvSpPr>
+            <a:spLocks noGrp="1"/>
+          </p:cNvSpPr>
+          <p:nvPr>
+            <p:ph idx="1"/>
+          </p:nvPr>
+        </p:nvSpPr>
+        <p:spPr>
+          <a:xfrm>
+            <a:off x="838200" y="1574800"/>
+            <a:ext cx="4927600" cy="5029200"/>
+          </a:xfrm>
+        </p:spPr>
+        <p:txBody>
           <a:bodyPr>
-            <a:normAutofit fontScale="92500" lnSpcReduction="10000"/>
+            <a:noAutofit/>
           </a:bodyPr>
           <a:lstStyle/>
           <a:p>
             <a:r>
-              <a:rPr lang="en-US" sz="2600" dirty="0"/>
-              <a:t>When you start a session, it is labeled as "In Progress" (also called </a:t>
-            </a:r>
-            <a:r>
-              <a:rPr lang="en-US" sz="2600" i="1" dirty="0"/>
-              <a:t>in flight</a:t>
-            </a:r>
-            <a:r>
-              <a:rPr lang="en-US" sz="2600" dirty="0"/>
-              <a:t>)</a:t>
-            </a:r>
-          </a:p>
-          <a:p>
-            <a:r>
-              <a:rPr lang="en-US" sz="2600" dirty="0"/>
-              <a:t>An in-progress session displays its lifecycle phases (register, plan … etc.)</a:t>
-            </a:r>
-          </a:p>
-          <a:p>
-            <a:r>
-              <a:rPr lang="en-US" sz="2600" dirty="0"/>
-              <a:t>When the work phase starts, it displays a list of work steps.</a:t>
-            </a:r>
-          </a:p>
-          <a:p>
-            <a:r>
-              <a:rPr lang="en-US" sz="2600" dirty="0"/>
-              <a:t>When the session is done, it is moved to the "Complete" node in the Work Explorer. </a:t>
+              <a:rPr lang="en-US" sz="2200" dirty="0"/>
+              <a:t>To start a session, right click on the next session and select "Start Session," which runs with AI settings from your Configuration.</a:t>
+            </a:r>
+          </a:p>
+          <a:p>
+            <a:r>
+              <a:rPr lang="en-US" sz="2200" dirty="0"/>
+              <a:t>You can also select "Start Session with Different Models", which prompts you for the AI vehicles and models for the session.</a:t>
+            </a:r>
+          </a:p>
+          <a:p>
+            <a:r>
+              <a:rPr lang="en-US" sz="2200" dirty="0"/>
+              <a:t>You can cancel a session by right clicking and choosing "Cancel Session"</a:t>
+            </a:r>
+          </a:p>
+          <a:p>
+            <a:r>
+              <a:rPr lang="en-US" sz="2200" dirty="0"/>
+              <a:t>You must run sessions in order, but you can have AI change to order of sessions (when you are between sessions) </a:t>
             </a:r>
           </a:p>
         </p:txBody>
       </p:sp>
       <p:pic>
         <p:nvPicPr>
-          <p:cNvPr id="5" name="Picture 4">
-            <a:extLst>
-              <a:ext uri="{FF2B5EF4-FFF2-40B4-BE49-F238E27FC236}">
-                <a16:creationId xmlns:a16="http://schemas.microsoft.com/office/drawing/2014/main" id="{964DD055-C21C-FB9F-F138-98D8F5693FA9}"/>
+          <p:cNvPr id="3" name="Picture 2">
+            <a:extLst>
+              <a:ext uri="{FF2B5EF4-FFF2-40B4-BE49-F238E27FC236}">
+                <a16:creationId xmlns:a16="http://schemas.microsoft.com/office/drawing/2014/main" id="{3E6C756E-C203-1536-FFD3-5B7EB5065A90}"/>
               </a:ext>
             </a:extLst>
           </p:cNvPr>
@@ -6965,15 +7281,14 @@
         </p:nvPicPr>
         <p:blipFill>
           <a:blip r:embed="rId2"/>
-          <a:srcRect l="4237" t="56199" r="71367" b="-182"/>
           <a:stretch>
             <a:fillRect/>
           </a:stretch>
         </p:blipFill>
         <p:spPr>
           <a:xfrm>
-            <a:off x="6285426" y="1690688"/>
-            <a:ext cx="4484174" cy="4372410"/>
+            <a:off x="5981700" y="2577961"/>
+            <a:ext cx="5771036" cy="2273439"/>
           </a:xfrm>
           <a:prstGeom prst="rect">
             <a:avLst/>
@@ -6983,7 +7298,7 @@
     </p:spTree>
     <p:extLst>
       <p:ext uri="{BB962C8B-B14F-4D97-AF65-F5344CB8AC3E}">
-        <p14:creationId xmlns:p14="http://schemas.microsoft.com/office/powerpoint/2010/main" val="3985681127"/>
+        <p14:creationId xmlns:p14="http://schemas.microsoft.com/office/powerpoint/2010/main" val="1788143237"/>
       </p:ext>
     </p:extLst>
   </p:cSld>

</xml_diff>

<commit_message>
Update Java Sample prompt to use H2, instead of SQLite -- makes it a little easier on the Java side.
</commit_message>
<xml_diff>
--- a/docs/onboarding/ai-orchestration.pptx
+++ b/docs/onboarding/ai-orchestration.pptx
@@ -287,7 +287,7 @@
           <a:p>
             <a:fld id="{89743378-6FBE-468B-B28B-85AEB7ADD678}" type="datetimeFigureOut">
               <a:rPr lang="en-US" smtClean="0"/>
-              <a:t>9/17/2026</a:t>
+              <a:t>9/22/2026</a:t>
             </a:fld>
             <a:endParaRPr lang="en-US"/>
           </a:p>
@@ -485,7 +485,7 @@
           <a:p>
             <a:fld id="{89743378-6FBE-468B-B28B-85AEB7ADD678}" type="datetimeFigureOut">
               <a:rPr lang="en-US" smtClean="0"/>
-              <a:t>9/17/2026</a:t>
+              <a:t>9/22/2026</a:t>
             </a:fld>
             <a:endParaRPr lang="en-US"/>
           </a:p>
@@ -693,7 +693,7 @@
           <a:p>
             <a:fld id="{89743378-6FBE-468B-B28B-85AEB7ADD678}" type="datetimeFigureOut">
               <a:rPr lang="en-US" smtClean="0"/>
-              <a:t>9/17/2026</a:t>
+              <a:t>9/22/2026</a:t>
             </a:fld>
             <a:endParaRPr lang="en-US"/>
           </a:p>
@@ -891,7 +891,7 @@
           <a:p>
             <a:fld id="{89743378-6FBE-468B-B28B-85AEB7ADD678}" type="datetimeFigureOut">
               <a:rPr lang="en-US" smtClean="0"/>
-              <a:t>9/17/2026</a:t>
+              <a:t>9/22/2026</a:t>
             </a:fld>
             <a:endParaRPr lang="en-US"/>
           </a:p>
@@ -1166,7 +1166,7 @@
           <a:p>
             <a:fld id="{89743378-6FBE-468B-B28B-85AEB7ADD678}" type="datetimeFigureOut">
               <a:rPr lang="en-US" smtClean="0"/>
-              <a:t>9/17/2026</a:t>
+              <a:t>9/22/2026</a:t>
             </a:fld>
             <a:endParaRPr lang="en-US"/>
           </a:p>
@@ -1431,7 +1431,7 @@
           <a:p>
             <a:fld id="{89743378-6FBE-468B-B28B-85AEB7ADD678}" type="datetimeFigureOut">
               <a:rPr lang="en-US" smtClean="0"/>
-              <a:t>9/17/2026</a:t>
+              <a:t>9/22/2026</a:t>
             </a:fld>
             <a:endParaRPr lang="en-US"/>
           </a:p>
@@ -1843,7 +1843,7 @@
           <a:p>
             <a:fld id="{89743378-6FBE-468B-B28B-85AEB7ADD678}" type="datetimeFigureOut">
               <a:rPr lang="en-US" smtClean="0"/>
-              <a:t>9/17/2026</a:t>
+              <a:t>9/22/2026</a:t>
             </a:fld>
             <a:endParaRPr lang="en-US"/>
           </a:p>
@@ -1984,7 +1984,7 @@
           <a:p>
             <a:fld id="{89743378-6FBE-468B-B28B-85AEB7ADD678}" type="datetimeFigureOut">
               <a:rPr lang="en-US" smtClean="0"/>
-              <a:t>9/17/2026</a:t>
+              <a:t>9/22/2026</a:t>
             </a:fld>
             <a:endParaRPr lang="en-US"/>
           </a:p>
@@ -2097,7 +2097,7 @@
           <a:p>
             <a:fld id="{89743378-6FBE-468B-B28B-85AEB7ADD678}" type="datetimeFigureOut">
               <a:rPr lang="en-US" smtClean="0"/>
-              <a:t>9/17/2026</a:t>
+              <a:t>9/22/2026</a:t>
             </a:fld>
             <a:endParaRPr lang="en-US"/>
           </a:p>
@@ -2408,7 +2408,7 @@
           <a:p>
             <a:fld id="{89743378-6FBE-468B-B28B-85AEB7ADD678}" type="datetimeFigureOut">
               <a:rPr lang="en-US" smtClean="0"/>
-              <a:t>9/17/2026</a:t>
+              <a:t>9/22/2026</a:t>
             </a:fld>
             <a:endParaRPr lang="en-US"/>
           </a:p>
@@ -2696,7 +2696,7 @@
           <a:p>
             <a:fld id="{89743378-6FBE-468B-B28B-85AEB7ADD678}" type="datetimeFigureOut">
               <a:rPr lang="en-US" smtClean="0"/>
-              <a:t>9/17/2026</a:t>
+              <a:t>9/22/2026</a:t>
             </a:fld>
             <a:endParaRPr lang="en-US"/>
           </a:p>
@@ -2937,7 +2937,7 @@
           <a:p>
             <a:fld id="{89743378-6FBE-468B-B28B-85AEB7ADD678}" type="datetimeFigureOut">
               <a:rPr lang="en-US" smtClean="0"/>
-              <a:t>9/17/2026</a:t>
+              <a:t>9/22/2026</a:t>
             </a:fld>
             <a:endParaRPr lang="en-US"/>
           </a:p>
@@ -4624,7 +4624,7 @@
                 <a:latin typeface="Courier New" panose="02070309020205020404" pitchFamily="49" charset="0"/>
                 <a:cs typeface="Courier New" panose="02070309020205020404" pitchFamily="49" charset="0"/>
               </a:rPr>
-              <a:t>The true purpose of this solution is to learn the Dabbler AI Orchestration platform. The exercise will take the form of a solution whose main project is a console app that reads in CSV files from a folder, deserializes the files into Person objects, persists the objects to a SQLite database using JPA, and then displays all records from the database in the console.  I would like for the project to break the project up into several modules -- a Person model library module, a </a:t>
+              <a:t>The true purpose of this solution is to learn the Dabbler AI Orchestration platform. The exercise will take the form of a solution whose main project is a console app that reads in CSV files from a folder, deserializes the files into Person objects, persists the objects to an H2 database using JPA, and then displays all records from the database in the console.  I would like for the project to break the project up into several modules -- a Person model library module, a </a:t>
             </a:r>
             <a:r>
               <a:rPr lang="en-US" i="1" dirty="0" err="1">

</xml_diff>